<commit_message>
docs: refine trajectory defense narrative
Clarifies the Vida Software to openTrends transition as a move from deep lab/product work toward communication, junior mentoring, and collaborative consulting.

Explains the La Salle to TecnoCampus bridge through conversations with the La Salle coordinator and director, leading to Ester Bernado as a concrete academic connection.

Replaces the harder-to-pronounce internationalization wording with consultancy and international training, and regenerates trajectory DOCX/PDF derivatives.
</commit_message>
<xml_diff>
--- a/doc/presentations/defensa-placa-permanent-dsi-ports-sortida-hexagonal/output/defensa-trajectoria-10-minuts.pptx
+++ b/doc/presentations/defensa-placa-permanent-dsi-ports-sortida-hexagonal/output/defensa-trajectoria-10-minuts.pptx
@@ -5811,7 +5811,19 @@
             </a:r>
             <a:r>
               <a:rPr lang="es-ES" dirty="0"/>
-              <a:t> de memoria. </a:t>
+              <a:t> de memoria, </a:t>
+            </a:r>
+            <a:r>
+              <a:rPr lang="es-ES" dirty="0" err="1"/>
+              <a:t>cpu</a:t>
+            </a:r>
+            <a:r>
+              <a:rPr lang="es-ES" dirty="0"/>
+              <a:t> i </a:t>
+            </a:r>
+            <a:r>
+              <a:rPr lang="es-ES"/>
+              <a:t>xarxa. </a:t>
             </a:r>
             <a:r>
               <a:rPr lang="es-ES" dirty="0" err="1"/>

</xml_diff>

<commit_message>
Fix Catalan presentation text
</commit_message>
<xml_diff>
--- a/doc/presentations/defensa-placa-permanent-dsi-ports-sortida-hexagonal/output/defensa-trajectoria-10-minuts.pptx
+++ b/doc/presentations/defensa-placa-permanent-dsi-ports-sortida-hexagonal/output/defensa-trajectoria-10-minuts.pptx
@@ -432,7 +432,7 @@
 </file>
 
 <file path=ppt/notesSlides/notesSlide3.xml><?xml version="1.0" encoding="utf-8"?>
-<p:notes xmlns:a="http://schemas.openxmlformats.org/drawingml/2006/main" xmlns:r="http://schemas.openxmlformats.org/officeDocument/2006/relationships" xmlns:p="http://schemas.openxmlformats.org/presentationml/2006/main">
+<p:notes xmlns:a="http://schemas.openxmlformats.org/drawingml/2006/main" xmlns:p="http://schemas.openxmlformats.org/presentationml/2006/main">
   <p:cSld>
     <p:spTree>
       <p:nvGrpSpPr>
@@ -486,7 +486,7 @@
           </a:p>
           <a:p>
             <a:r>
-              <a:t>Agraïment a la FP; no minusvalorar-la.</a:t>
+              <a:t>Agraïment a l’FP; no menysvalorar-la.</a:t>
             </a:r>
           </a:p>
           <a:p>
@@ -1165,7 +1165,7 @@
           <a:p>
             <a:fld id="{5BCAD085-E8A6-8845-BD4E-CB4CCA059FC4}" type="datetimeFigureOut">
               <a:rPr lang="en-US" smtClean="0"/>
-              <a:t>7/5/26</a:t>
+              <a:t>7/6/26</a:t>
             </a:fld>
             <a:endParaRPr lang="en-US"/>
           </a:p>
@@ -1333,7 +1333,7 @@
           <a:p>
             <a:fld id="{5BCAD085-E8A6-8845-BD4E-CB4CCA059FC4}" type="datetimeFigureOut">
               <a:rPr lang="en-US" smtClean="0"/>
-              <a:t>7/5/26</a:t>
+              <a:t>7/6/26</a:t>
             </a:fld>
             <a:endParaRPr lang="en-US"/>
           </a:p>
@@ -1511,7 +1511,7 @@
           <a:p>
             <a:fld id="{5BCAD085-E8A6-8845-BD4E-CB4CCA059FC4}" type="datetimeFigureOut">
               <a:rPr lang="en-US" smtClean="0"/>
-              <a:t>7/5/26</a:t>
+              <a:t>7/6/26</a:t>
             </a:fld>
             <a:endParaRPr lang="en-US"/>
           </a:p>
@@ -1679,7 +1679,7 @@
           <a:p>
             <a:fld id="{5BCAD085-E8A6-8845-BD4E-CB4CCA059FC4}" type="datetimeFigureOut">
               <a:rPr lang="en-US" smtClean="0"/>
-              <a:t>7/5/26</a:t>
+              <a:t>7/6/26</a:t>
             </a:fld>
             <a:endParaRPr lang="en-US"/>
           </a:p>
@@ -1924,7 +1924,7 @@
           <a:p>
             <a:fld id="{5BCAD085-E8A6-8845-BD4E-CB4CCA059FC4}" type="datetimeFigureOut">
               <a:rPr lang="en-US" smtClean="0"/>
-              <a:t>7/5/26</a:t>
+              <a:t>7/6/26</a:t>
             </a:fld>
             <a:endParaRPr lang="en-US"/>
           </a:p>
@@ -2209,7 +2209,7 @@
           <a:p>
             <a:fld id="{5BCAD085-E8A6-8845-BD4E-CB4CCA059FC4}" type="datetimeFigureOut">
               <a:rPr lang="en-US" smtClean="0"/>
-              <a:t>7/5/26</a:t>
+              <a:t>7/6/26</a:t>
             </a:fld>
             <a:endParaRPr lang="en-US"/>
           </a:p>
@@ -2628,7 +2628,7 @@
           <a:p>
             <a:fld id="{5BCAD085-E8A6-8845-BD4E-CB4CCA059FC4}" type="datetimeFigureOut">
               <a:rPr lang="en-US" smtClean="0"/>
-              <a:t>7/5/26</a:t>
+              <a:t>7/6/26</a:t>
             </a:fld>
             <a:endParaRPr lang="en-US"/>
           </a:p>
@@ -2745,7 +2745,7 @@
           <a:p>
             <a:fld id="{5BCAD085-E8A6-8845-BD4E-CB4CCA059FC4}" type="datetimeFigureOut">
               <a:rPr lang="en-US" smtClean="0"/>
-              <a:t>7/5/26</a:t>
+              <a:t>7/6/26</a:t>
             </a:fld>
             <a:endParaRPr lang="en-US"/>
           </a:p>
@@ -2840,7 +2840,7 @@
           <a:p>
             <a:fld id="{5BCAD085-E8A6-8845-BD4E-CB4CCA059FC4}" type="datetimeFigureOut">
               <a:rPr lang="en-US" smtClean="0"/>
-              <a:t>7/5/26</a:t>
+              <a:t>7/6/26</a:t>
             </a:fld>
             <a:endParaRPr lang="en-US"/>
           </a:p>
@@ -3115,7 +3115,7 @@
           <a:p>
             <a:fld id="{5BCAD085-E8A6-8845-BD4E-CB4CCA059FC4}" type="datetimeFigureOut">
               <a:rPr lang="en-US" smtClean="0"/>
-              <a:t>7/5/26</a:t>
+              <a:t>7/6/26</a:t>
             </a:fld>
             <a:endParaRPr lang="en-US"/>
           </a:p>
@@ -3367,7 +3367,7 @@
           <a:p>
             <a:fld id="{5BCAD085-E8A6-8845-BD4E-CB4CCA059FC4}" type="datetimeFigureOut">
               <a:rPr lang="en-US" smtClean="0"/>
-              <a:t>7/5/26</a:t>
+              <a:t>7/6/26</a:t>
             </a:fld>
             <a:endParaRPr lang="en-US"/>
           </a:p>
@@ -3578,7 +3578,7 @@
           <a:p>
             <a:fld id="{5BCAD085-E8A6-8845-BD4E-CB4CCA059FC4}" type="datetimeFigureOut">
               <a:rPr lang="en-US" smtClean="0"/>
-              <a:t>7/5/26</a:t>
+              <a:t>7/6/26</a:t>
             </a:fld>
             <a:endParaRPr lang="en-US"/>
           </a:p>
@@ -3937,7 +3937,7 @@
 </file>
 
 <file path=ppt/slides/slide1.xml><?xml version="1.0" encoding="utf-8"?>
-<p:sld xmlns:a="http://schemas.openxmlformats.org/drawingml/2006/main" xmlns:r="http://schemas.openxmlformats.org/officeDocument/2006/relationships" xmlns:p="http://schemas.openxmlformats.org/presentationml/2006/main">
+<p:sld xmlns:a="http://schemas.openxmlformats.org/drawingml/2006/main" xmlns:p="http://schemas.openxmlformats.org/presentationml/2006/main" xmlns:r="http://schemas.openxmlformats.org/officeDocument/2006/relationships">
   <p:cSld>
     <p:spTree>
       <p:nvGrpSpPr>
@@ -4806,7 +4806,7 @@
                 </a:solidFill>
                 <a:latin typeface="Arial"/>
               </a:rPr>
-              <a:t> docente i </a:t>
+              <a:t> docent i acadèmic</a:t>
             </a:r>
             <a:r>
               <a:rPr sz="1080" b="0" dirty="0">
@@ -4815,7 +4815,7 @@
                 </a:solidFill>
                 <a:latin typeface="Arial"/>
               </a:rPr>
-              <a:t> </a:t>
+              <a:t/>
             </a:r>
             <a:r>
               <a:rPr sz="1080" b="0" dirty="0" err="1">
@@ -4824,7 +4824,7 @@
                 </a:solidFill>
                 <a:latin typeface="Arial"/>
               </a:rPr>
-              <a:t>acadèmic</a:t>
+              <a:t/>
             </a:r>
             <a:endParaRPr sz="1080" b="0" dirty="0">
               <a:solidFill>
@@ -5213,7 +5213,7 @@
 </file>
 
 <file path=ppt/slides/slide2.xml><?xml version="1.0" encoding="utf-8"?>
-<p:sld xmlns:a="http://schemas.openxmlformats.org/drawingml/2006/main" xmlns:r="http://schemas.openxmlformats.org/officeDocument/2006/relationships" xmlns:p="http://schemas.openxmlformats.org/presentationml/2006/main">
+<p:sld xmlns:a="http://schemas.openxmlformats.org/drawingml/2006/main" xmlns:ns3="http://schemas.microsoft.com/office/drawing/2014/main" xmlns:ns4="http://schemas.microsoft.com/office/drawing/2010/main" xmlns:p="http://schemas.openxmlformats.org/presentationml/2006/main" xmlns:r="http://schemas.openxmlformats.org/officeDocument/2006/relationships">
   <p:cSld>
     <p:spTree>
       <p:nvGrpSpPr>
@@ -5750,11 +5750,11 @@
             </a:r>
             <a:r>
               <a:rPr lang="es-ES" dirty="0"/>
-              <a:t> a apps Nokia/Symbian </a:t>
+              <a:t> a apps per a dispositius Nokia/Symbian</a:t>
             </a:r>
             <a:r>
               <a:rPr lang="es-ES" dirty="0" err="1"/>
-              <a:t>devices</a:t>
+              <a:t/>
             </a:r>
             <a:r>
               <a:rPr lang="es-ES" dirty="0"/>
@@ -5811,19 +5811,23 @@
             </a:r>
             <a:r>
               <a:rPr lang="es-ES" dirty="0"/>
-              <a:t> de memoria, </a:t>
+              <a:t> de memòria, CPU</a:t>
             </a:r>
             <a:r>
               <a:rPr lang="es-ES" dirty="0" err="1"/>
-              <a:t>cpu</a:t>
+              <a:t/>
             </a:r>
             <a:r>
               <a:rPr lang="es-ES" dirty="0"/>
               <a:t> i </a:t>
             </a:r>
             <a:r>
-              <a:rPr lang="es-ES"/>
-              <a:t>xarxa. </a:t>
+              <a:rPr lang="es-ES" dirty="0" err="1"/>
+              <a:t>xarxa</a:t>
+            </a:r>
+            <a:r>
+              <a:rPr lang="es-ES" dirty="0"/>
+              <a:t>. </a:t>
             </a:r>
             <a:r>
               <a:rPr lang="es-ES" dirty="0" err="1"/>
@@ -5831,7 +5835,7 @@
             </a:r>
             <a:r>
               <a:rPr lang="es-ES" dirty="0"/>
-              <a:t> IP, UPD, RPT, SIP, AMR.</a:t>
+              <a:t> IP, UDP, RTP, SIP, AMR.</a:t>
             </a:r>
           </a:p>
           <a:p>
@@ -6058,7 +6062,7 @@
         <p:spPr>
           <a:xfrm>
             <a:off x="6441947" y="2580963"/>
-            <a:ext cx="4343400" cy="1168077"/>
+            <a:ext cx="4283203" cy="1461619"/>
           </a:xfrm>
           <a:prstGeom prst="rect">
             <a:avLst/>
@@ -6087,7 +6091,15 @@
             </a:pPr>
             <a:r>
               <a:rPr dirty="0"/>
-              <a:t>• Java</a:t>
+              <a:t>• </a:t>
+            </a:r>
+            <a:r>
+              <a:rPr lang="es-ES" dirty="0"/>
+              <a:t>Linux, </a:t>
+            </a:r>
+            <a:r>
+              <a:rPr dirty="0"/>
+              <a:t>Java</a:t>
             </a:r>
             <a:r>
               <a:rPr lang="es-ES" dirty="0"/>
@@ -6180,8 +6192,8 @@
               <a:t>• </a:t>
             </a:r>
             <a:r>
-              <a:rPr dirty="0" err="1"/>
-              <a:t>integració</a:t>
+              <a:rPr lang="es-ES" dirty="0" err="1"/>
+              <a:t>enginyeria</a:t>
             </a:r>
             <a:r>
               <a:rPr dirty="0"/>
@@ -6229,11 +6241,19 @@
             </a:r>
             <a:r>
               <a:rPr dirty="0"/>
-              <a:t> </a:t>
+              <a:t> tècnica</a:t>
+            </a:r>
+            <a:r>
+              <a:rPr lang="es-ES" dirty="0"/>
+              <a:t/>
             </a:r>
             <a:r>
               <a:rPr dirty="0" err="1"/>
-              <a:t>tècnica</a:t>
+              <a:t/>
+            </a:r>
+            <a:r>
+              <a:rPr lang="es-ES" dirty="0"/>
+              <a:t> i comercial</a:t>
             </a:r>
             <a:r>
               <a:rPr dirty="0"/>
@@ -6258,6 +6278,51 @@
             <a:r>
               <a:rPr dirty="0" err="1"/>
               <a:t>perfils</a:t>
+            </a:r>
+            <a:endParaRPr lang="es-ES" dirty="0"/>
+          </a:p>
+          <a:p>
+            <a:pPr>
+              <a:lnSpc>
+                <a:spcPct val="105000"/>
+              </a:lnSpc>
+              <a:spcAft>
+                <a:spcPts val="500"/>
+              </a:spcAft>
+              <a:defRPr sz="1420">
+                <a:solidFill>
+                  <a:srgbClr val="2D343C"/>
+                </a:solidFill>
+                <a:latin typeface="Arial"/>
+              </a:defRPr>
+            </a:pPr>
+            <a:r>
+              <a:rPr lang="es-ES" dirty="0"/>
+              <a:t>• </a:t>
+            </a:r>
+            <a:r>
+              <a:rPr lang="es-ES" dirty="0" err="1"/>
+              <a:t>formació</a:t>
+            </a:r>
+            <a:r>
+              <a:rPr lang="es-ES" dirty="0"/>
+              <a:t> i </a:t>
+            </a:r>
+            <a:r>
+              <a:rPr lang="es-ES" dirty="0" err="1"/>
+              <a:t>mentoria</a:t>
+            </a:r>
+            <a:r>
+              <a:rPr lang="es-ES" dirty="0"/>
+              <a:t> </a:t>
+            </a:r>
+            <a:r>
+              <a:rPr lang="es-ES" dirty="0" err="1"/>
+              <a:t>d'enginyers</a:t>
+            </a:r>
+            <a:r>
+              <a:rPr lang="es-ES" dirty="0"/>
+              <a:t> júniors. </a:t>
             </a:r>
             <a:endParaRPr dirty="0"/>
           </a:p>
@@ -6271,7 +6336,7 @@
         </p:nvSpPr>
         <p:spPr>
           <a:xfrm>
-            <a:off x="6419088" y="4160520"/>
+            <a:off x="6419088" y="4303395"/>
             <a:ext cx="4434840" cy="384048"/>
           </a:xfrm>
           <a:prstGeom prst="rect">
@@ -6381,16 +6446,16 @@
               <a:t> </a:t>
             </a:r>
             <a:r>
-              <a:rPr sz="1250" b="0" dirty="0" err="1">
+              <a:rPr lang="es-ES" sz="1250" b="0" dirty="0" err="1">
                 <a:solidFill>
                   <a:srgbClr val="67717C"/>
                 </a:solidFill>
                 <a:latin typeface="Arial"/>
               </a:rPr>
-              <a:t>treball</a:t>
-            </a:r>
-            <a:r>
-              <a:rPr sz="1250" b="0" dirty="0">
+              <a:t>desenvolupament</a:t>
+            </a:r>
+            <a:r>
+              <a:rPr lang="es-ES" sz="1250" b="0" dirty="0">
                 <a:solidFill>
                   <a:srgbClr val="67717C"/>
                 </a:solidFill>
@@ -6399,31 +6464,40 @@
               <a:t> </a:t>
             </a:r>
             <a:r>
-              <a:rPr sz="1250" b="0" dirty="0" err="1">
+              <a:rPr lang="es-ES" sz="1250" b="0" dirty="0" err="1">
                 <a:solidFill>
                   <a:srgbClr val="67717C"/>
                 </a:solidFill>
                 <a:latin typeface="Arial"/>
               </a:rPr>
-              <a:t>amb</a:t>
-            </a:r>
-            <a:r>
-              <a:rPr sz="1250" b="0" dirty="0">
+              <a:t>d’habilitats</a:t>
+            </a:r>
+            <a:r>
+              <a:rPr lang="es-ES" sz="1250" b="0" dirty="0">
                 <a:solidFill>
                   <a:srgbClr val="67717C"/>
                 </a:solidFill>
                 <a:latin typeface="Arial"/>
               </a:rPr>
-              <a:t> </a:t>
-            </a:r>
-            <a:r>
-              <a:rPr sz="1250" b="0" dirty="0" err="1">
+              <a:t> de </a:t>
+            </a:r>
+            <a:r>
+              <a:rPr lang="es-ES" sz="1250" dirty="0" err="1">
                 <a:solidFill>
                   <a:srgbClr val="67717C"/>
                 </a:solidFill>
                 <a:latin typeface="Arial"/>
               </a:rPr>
-              <a:t>persones</a:t>
+              <a:t>c</a:t>
+            </a:r>
+            <a:r>
+              <a:rPr lang="es-ES" sz="1250" b="0" dirty="0" err="1">
+                <a:solidFill>
+                  <a:srgbClr val="67717C"/>
+                </a:solidFill>
+                <a:latin typeface="Arial"/>
+              </a:rPr>
+              <a:t>omunicació</a:t>
             </a:r>
             <a:r>
               <a:rPr sz="1250" b="0" dirty="0">
@@ -6768,7 +6842,7 @@
           <p:cNvPr id="12" name="Picture 2">
             <a:extLst>
               <a:ext uri="{FF2B5EF4-FFF2-40B4-BE49-F238E27FC236}">
-                <a16:creationId xmlns:a16="http://schemas.microsoft.com/office/drawing/2014/main" id="{BB6ECFDF-B584-B54F-80A3-0D4117F0A159}"/>
+                <ns3:creationId id="{BB6ECFDF-B584-B54F-80A3-0D4117F0A159}"/>
               </a:ext>
             </a:extLst>
           </p:cNvPr>
@@ -6781,7 +6855,7 @@
           <a:blip r:embed="rId4">
             <a:extLst>
               <a:ext uri="{28A0092B-C50C-407E-A947-70E740481C1C}">
-                <a14:useLocalDpi xmlns:a14="http://schemas.microsoft.com/office/drawing/2010/main" val="0"/>
+                <ns4:useLocalDpi val="0"/>
               </a:ext>
             </a:extLst>
           </a:blip>
@@ -6801,11 +6875,11 @@
           <a:noFill/>
           <a:extLst>
             <a:ext uri="{909E8E84-426E-40DD-AFC4-6F175D3DCCD1}">
-              <a14:hiddenFill xmlns:a14="http://schemas.microsoft.com/office/drawing/2010/main">
+              <ns4:hiddenFill>
                 <a:solidFill>
                   <a:srgbClr val="FFFFFF"/>
                 </a:solidFill>
-              </a14:hiddenFill>
+              </ns4:hiddenFill>
             </a:ext>
           </a:extLst>
         </p:spPr>
@@ -6819,7 +6893,7 @@
 </file>
 
 <file path=ppt/slides/slide3.xml><?xml version="1.0" encoding="utf-8"?>
-<p:sld xmlns:a="http://schemas.openxmlformats.org/drawingml/2006/main" xmlns:r="http://schemas.openxmlformats.org/officeDocument/2006/relationships" xmlns:p="http://schemas.openxmlformats.org/presentationml/2006/main">
+<p:sld xmlns:a="http://schemas.openxmlformats.org/drawingml/2006/main" xmlns:p="http://schemas.openxmlformats.org/presentationml/2006/main" xmlns:r="http://schemas.openxmlformats.org/officeDocument/2006/relationships">
   <p:cSld>
     <p:spTree>
       <p:nvGrpSpPr>
@@ -7652,14 +7726,236 @@
               </a:lnSpc>
             </a:pPr>
             <a:r>
-              <a:rPr sz="1370" b="0">
-                <a:solidFill>
-                  <a:srgbClr val="2D343C"/>
-                </a:solidFill>
-                <a:latin typeface="Arial"/>
-              </a:rPr>
-              <a:t>Voluntat de portar a l’aula continguts més avançats d’enginyeria de software, arquitectura i disseny de sistemes.</a:t>
-            </a:r>
+              <a:rPr sz="1370" b="0" dirty="0" err="1">
+                <a:solidFill>
+                  <a:srgbClr val="2D343C"/>
+                </a:solidFill>
+                <a:latin typeface="Arial"/>
+              </a:rPr>
+              <a:t>Voluntat</a:t>
+            </a:r>
+            <a:r>
+              <a:rPr sz="1370" b="0" dirty="0">
+                <a:solidFill>
+                  <a:srgbClr val="2D343C"/>
+                </a:solidFill>
+                <a:latin typeface="Arial"/>
+              </a:rPr>
+              <a:t> de </a:t>
+            </a:r>
+            <a:r>
+              <a:rPr sz="1370" b="0" dirty="0" err="1">
+                <a:solidFill>
+                  <a:srgbClr val="2D343C"/>
+                </a:solidFill>
+                <a:latin typeface="Arial"/>
+              </a:rPr>
+              <a:t>portar</a:t>
+            </a:r>
+            <a:r>
+              <a:rPr sz="1370" b="0" dirty="0">
+                <a:solidFill>
+                  <a:srgbClr val="2D343C"/>
+                </a:solidFill>
+                <a:latin typeface="Arial"/>
+              </a:rPr>
+              <a:t> a </a:t>
+            </a:r>
+            <a:r>
+              <a:rPr sz="1370" b="0" dirty="0" err="1">
+                <a:solidFill>
+                  <a:srgbClr val="2D343C"/>
+                </a:solidFill>
+                <a:latin typeface="Arial"/>
+              </a:rPr>
+              <a:t>l’aula</a:t>
+            </a:r>
+            <a:r>
+              <a:rPr sz="1370" b="0" dirty="0">
+                <a:solidFill>
+                  <a:srgbClr val="2D343C"/>
+                </a:solidFill>
+                <a:latin typeface="Arial"/>
+              </a:rPr>
+              <a:t> </a:t>
+            </a:r>
+            <a:r>
+              <a:rPr sz="1370" b="0" dirty="0" err="1">
+                <a:solidFill>
+                  <a:srgbClr val="2D343C"/>
+                </a:solidFill>
+                <a:latin typeface="Arial"/>
+              </a:rPr>
+              <a:t>continguts</a:t>
+            </a:r>
+            <a:r>
+              <a:rPr sz="1370" b="0" dirty="0">
+                <a:solidFill>
+                  <a:srgbClr val="2D343C"/>
+                </a:solidFill>
+                <a:latin typeface="Arial"/>
+              </a:rPr>
+              <a:t> </a:t>
+            </a:r>
+            <a:r>
+              <a:rPr sz="1370" b="0" dirty="0" err="1">
+                <a:solidFill>
+                  <a:srgbClr val="2D343C"/>
+                </a:solidFill>
+                <a:latin typeface="Arial"/>
+              </a:rPr>
+              <a:t>més</a:t>
+            </a:r>
+            <a:r>
+              <a:rPr sz="1370" b="0" dirty="0">
+                <a:solidFill>
+                  <a:srgbClr val="2D343C"/>
+                </a:solidFill>
+                <a:latin typeface="Arial"/>
+              </a:rPr>
+              <a:t> </a:t>
+            </a:r>
+            <a:r>
+              <a:rPr sz="1370" b="0" dirty="0" err="1">
+                <a:solidFill>
+                  <a:srgbClr val="2D343C"/>
+                </a:solidFill>
+                <a:latin typeface="Arial"/>
+              </a:rPr>
+              <a:t>avançats</a:t>
+            </a:r>
+            <a:r>
+              <a:rPr sz="1370" b="0" dirty="0">
+                <a:solidFill>
+                  <a:srgbClr val="2D343C"/>
+                </a:solidFill>
+                <a:latin typeface="Arial"/>
+              </a:rPr>
+              <a:t> </a:t>
+            </a:r>
+            <a:r>
+              <a:rPr sz="1370" b="0" dirty="0" err="1">
+                <a:solidFill>
+                  <a:srgbClr val="2D343C"/>
+                </a:solidFill>
+                <a:latin typeface="Arial"/>
+              </a:rPr>
+              <a:t>d’enginyeria</a:t>
+            </a:r>
+            <a:r>
+              <a:rPr sz="1370" b="0" dirty="0">
+                <a:solidFill>
+                  <a:srgbClr val="2D343C"/>
+                </a:solidFill>
+                <a:latin typeface="Arial"/>
+              </a:rPr>
+              <a:t> de software, </a:t>
+            </a:r>
+            <a:r>
+              <a:rPr sz="1370" b="0" dirty="0" err="1">
+                <a:solidFill>
+                  <a:srgbClr val="2D343C"/>
+                </a:solidFill>
+                <a:latin typeface="Arial"/>
+              </a:rPr>
+              <a:t>arquitectura</a:t>
+            </a:r>
+            <a:r>
+              <a:rPr sz="1370" b="0" dirty="0">
+                <a:solidFill>
+                  <a:srgbClr val="2D343C"/>
+                </a:solidFill>
+                <a:latin typeface="Arial"/>
+              </a:rPr>
+              <a:t> </a:t>
+            </a:r>
+            <a:r>
+              <a:rPr sz="1370" b="0" dirty="0" err="1">
+                <a:solidFill>
+                  <a:srgbClr val="2D343C"/>
+                </a:solidFill>
+                <a:latin typeface="Arial"/>
+              </a:rPr>
+              <a:t>i</a:t>
+            </a:r>
+            <a:r>
+              <a:rPr sz="1370" b="0" dirty="0">
+                <a:solidFill>
+                  <a:srgbClr val="2D343C"/>
+                </a:solidFill>
+                <a:latin typeface="Arial"/>
+              </a:rPr>
+              <a:t> </a:t>
+            </a:r>
+            <a:r>
+              <a:rPr sz="1370" b="0" dirty="0" err="1">
+                <a:solidFill>
+                  <a:srgbClr val="2D343C"/>
+                </a:solidFill>
+                <a:latin typeface="Arial"/>
+              </a:rPr>
+              <a:t>disseny</a:t>
+            </a:r>
+            <a:r>
+              <a:rPr sz="1370" b="0" dirty="0">
+                <a:solidFill>
+                  <a:srgbClr val="2D343C"/>
+                </a:solidFill>
+                <a:latin typeface="Arial"/>
+              </a:rPr>
+              <a:t> de sistemes</a:t>
+            </a:r>
+            <a:r>
+              <a:rPr sz="1370" b="0" dirty="0" err="1">
+                <a:solidFill>
+                  <a:srgbClr val="2D343C"/>
+                </a:solidFill>
+                <a:latin typeface="Arial"/>
+              </a:rPr>
+              <a:t/>
+            </a:r>
+            <a:r>
+              <a:rPr lang="es-ES" sz="1370" b="0" dirty="0">
+                <a:solidFill>
+                  <a:srgbClr val="2D343C"/>
+                </a:solidFill>
+                <a:latin typeface="Arial"/>
+              </a:rPr>
+              <a:t/>
+            </a:r>
+            <a:r>
+              <a:rPr sz="1370" b="0" dirty="0">
+                <a:solidFill>
+                  <a:srgbClr val="2D343C"/>
+                </a:solidFill>
+                <a:latin typeface="Arial"/>
+              </a:rPr>
+              <a:t/>
+            </a:r>
+            <a:r>
+              <a:rPr lang="es-ES" sz="1370" dirty="0">
+                <a:solidFill>
+                  <a:srgbClr val="2D343C"/>
+                </a:solidFill>
+                <a:latin typeface="Arial"/>
+              </a:rPr>
+              <a:t> </a:t>
+            </a:r>
+            <a:r>
+              <a:rPr lang="es-ES" sz="1370" dirty="0" err="1">
+                <a:solidFill>
+                  <a:srgbClr val="2D343C"/>
+                </a:solidFill>
+                <a:latin typeface="Arial"/>
+              </a:rPr>
+              <a:t>d’informació</a:t>
+            </a:r>
+            <a:endParaRPr sz="1370" b="0" dirty="0">
+              <a:solidFill>
+                <a:srgbClr val="2D343C"/>
+              </a:solidFill>
+              <a:latin typeface="Arial"/>
+            </a:endParaRPr>
           </a:p>
         </p:txBody>
       </p:sp>
@@ -7706,7 +8002,7 @@
                 </a:solidFill>
                 <a:latin typeface="Arial"/>
               </a:rPr>
-              <a:t> positiva de </a:t>
+              <a:t> positiva de l’FP</a:t>
             </a:r>
             <a:r>
               <a:rPr sz="1600" b="1" dirty="0">
@@ -7715,7 +8011,7 @@
                 </a:solidFill>
                 <a:latin typeface="Arial"/>
               </a:rPr>
-              <a:t>la FP</a:t>
+              <a:t/>
             </a:r>
             <a:r>
               <a:rPr lang="es-ES" sz="1600" b="1" dirty="0">
@@ -7897,7 +8193,7 @@
 </file>
 
 <file path=ppt/slides/slide4.xml><?xml version="1.0" encoding="utf-8"?>
-<p:sld xmlns:a="http://schemas.openxmlformats.org/drawingml/2006/main" xmlns:r="http://schemas.openxmlformats.org/officeDocument/2006/relationships" xmlns:p="http://schemas.openxmlformats.org/presentationml/2006/main">
+<p:sld xmlns:a="http://schemas.openxmlformats.org/drawingml/2006/main" xmlns:p="http://schemas.openxmlformats.org/presentationml/2006/main" xmlns:r="http://schemas.openxmlformats.org/officeDocument/2006/relationships">
   <p:cSld>
     <p:spTree>
       <p:nvGrpSpPr>
@@ -8841,14 +9137,254 @@
               </a:lnSpc>
             </a:pPr>
             <a:r>
-              <a:rPr sz="1650" b="1">
+              <a:rPr sz="1650" b="1" dirty="0">
                 <a:solidFill>
                   <a:srgbClr val="1C2B3B"/>
                 </a:solidFill>
                 <a:latin typeface="Arial"/>
               </a:rPr>
-              <a:t>El desig de consolidar una plaça al TecnoCampus no neix ara: ve d’una trajectòria que hi ha trobat coherència.</a:t>
-            </a:r>
+              <a:t>El </a:t>
+            </a:r>
+            <a:r>
+              <a:rPr sz="1650" b="1" dirty="0" err="1">
+                <a:solidFill>
+                  <a:srgbClr val="1C2B3B"/>
+                </a:solidFill>
+                <a:latin typeface="Arial"/>
+              </a:rPr>
+              <a:t>desig</a:t>
+            </a:r>
+            <a:r>
+              <a:rPr sz="1650" b="1" dirty="0">
+                <a:solidFill>
+                  <a:srgbClr val="1C2B3B"/>
+                </a:solidFill>
+                <a:latin typeface="Arial"/>
+              </a:rPr>
+              <a:t> de </a:t>
+            </a:r>
+            <a:r>
+              <a:rPr sz="1650" b="1" dirty="0" err="1">
+                <a:solidFill>
+                  <a:srgbClr val="1C2B3B"/>
+                </a:solidFill>
+                <a:latin typeface="Arial"/>
+              </a:rPr>
+              <a:t>consolidar</a:t>
+            </a:r>
+            <a:r>
+              <a:rPr sz="1650" b="1" dirty="0">
+                <a:solidFill>
+                  <a:srgbClr val="1C2B3B"/>
+                </a:solidFill>
+                <a:latin typeface="Arial"/>
+              </a:rPr>
+              <a:t> </a:t>
+            </a:r>
+            <a:r>
+              <a:rPr sz="1650" b="1" dirty="0" err="1">
+                <a:solidFill>
+                  <a:srgbClr val="1C2B3B"/>
+                </a:solidFill>
+                <a:latin typeface="Arial"/>
+              </a:rPr>
+              <a:t>una</a:t>
+            </a:r>
+            <a:r>
+              <a:rPr sz="1650" b="1" dirty="0">
+                <a:solidFill>
+                  <a:srgbClr val="1C2B3B"/>
+                </a:solidFill>
+                <a:latin typeface="Arial"/>
+              </a:rPr>
+              <a:t> </a:t>
+            </a:r>
+            <a:r>
+              <a:rPr sz="1650" b="1" dirty="0" err="1">
+                <a:solidFill>
+                  <a:srgbClr val="1C2B3B"/>
+                </a:solidFill>
+                <a:latin typeface="Arial"/>
+              </a:rPr>
+              <a:t>plaça</a:t>
+            </a:r>
+            <a:r>
+              <a:rPr sz="1650" b="1" dirty="0">
+                <a:solidFill>
+                  <a:srgbClr val="1C2B3B"/>
+                </a:solidFill>
+                <a:latin typeface="Arial"/>
+              </a:rPr>
+              <a:t> al </a:t>
+            </a:r>
+            <a:r>
+              <a:rPr sz="1650" b="1" dirty="0" err="1">
+                <a:solidFill>
+                  <a:srgbClr val="1C2B3B"/>
+                </a:solidFill>
+                <a:latin typeface="Arial"/>
+              </a:rPr>
+              <a:t>TecnoCampus</a:t>
+            </a:r>
+            <a:r>
+              <a:rPr sz="1650" b="1" dirty="0">
+                <a:solidFill>
+                  <a:srgbClr val="1C2B3B"/>
+                </a:solidFill>
+                <a:latin typeface="Arial"/>
+              </a:rPr>
+              <a:t> no </a:t>
+            </a:r>
+            <a:r>
+              <a:rPr sz="1650" b="1" dirty="0" err="1">
+                <a:solidFill>
+                  <a:srgbClr val="1C2B3B"/>
+                </a:solidFill>
+                <a:latin typeface="Arial"/>
+              </a:rPr>
+              <a:t>neix</a:t>
+            </a:r>
+            <a:r>
+              <a:rPr sz="1650" b="1" dirty="0">
+                <a:solidFill>
+                  <a:srgbClr val="1C2B3B"/>
+                </a:solidFill>
+                <a:latin typeface="Arial"/>
+              </a:rPr>
+              <a:t> </a:t>
+            </a:r>
+            <a:r>
+              <a:rPr sz="1650" b="1" dirty="0" err="1">
+                <a:solidFill>
+                  <a:srgbClr val="1C2B3B"/>
+                </a:solidFill>
+                <a:latin typeface="Arial"/>
+              </a:rPr>
+              <a:t>ara</a:t>
+            </a:r>
+            <a:r>
+              <a:rPr sz="1650" b="1" dirty="0">
+                <a:solidFill>
+                  <a:srgbClr val="1C2B3B"/>
+                </a:solidFill>
+                <a:latin typeface="Arial"/>
+              </a:rPr>
+              <a:t>: </a:t>
+            </a:r>
+            <a:r>
+              <a:rPr sz="1650" b="1" dirty="0" err="1">
+                <a:solidFill>
+                  <a:srgbClr val="1C2B3B"/>
+                </a:solidFill>
+                <a:latin typeface="Arial"/>
+              </a:rPr>
+              <a:t>ve</a:t>
+            </a:r>
+            <a:r>
+              <a:rPr sz="1650" b="1" dirty="0">
+                <a:solidFill>
+                  <a:srgbClr val="1C2B3B"/>
+                </a:solidFill>
+                <a:latin typeface="Arial"/>
+              </a:rPr>
+              <a:t> </a:t>
+            </a:r>
+            <a:r>
+              <a:rPr sz="1650" b="1" dirty="0" err="1">
+                <a:solidFill>
+                  <a:srgbClr val="1C2B3B"/>
+                </a:solidFill>
+                <a:latin typeface="Arial"/>
+              </a:rPr>
+              <a:t>d’una</a:t>
+            </a:r>
+            <a:r>
+              <a:rPr sz="1650" b="1" dirty="0">
+                <a:solidFill>
+                  <a:srgbClr val="1C2B3B"/>
+                </a:solidFill>
+                <a:latin typeface="Arial"/>
+              </a:rPr>
+              <a:t> </a:t>
+            </a:r>
+            <a:r>
+              <a:rPr sz="1650" b="1" dirty="0" err="1">
+                <a:solidFill>
+                  <a:srgbClr val="1C2B3B"/>
+                </a:solidFill>
+                <a:latin typeface="Arial"/>
+              </a:rPr>
+              <a:t>trajectòria</a:t>
+            </a:r>
+            <a:r>
+              <a:rPr sz="1650" b="1" dirty="0">
+                <a:solidFill>
+                  <a:srgbClr val="1C2B3B"/>
+                </a:solidFill>
+                <a:latin typeface="Arial"/>
+              </a:rPr>
+              <a:t> que hi ha </a:t>
+            </a:r>
+            <a:r>
+              <a:rPr sz="1650" b="1" dirty="0" err="1">
+                <a:solidFill>
+                  <a:srgbClr val="1C2B3B"/>
+                </a:solidFill>
+                <a:latin typeface="Arial"/>
+              </a:rPr>
+              <a:t>trobat</a:t>
+            </a:r>
+            <a:r>
+              <a:rPr sz="1650" b="1" dirty="0">
+                <a:solidFill>
+                  <a:srgbClr val="1C2B3B"/>
+                </a:solidFill>
+                <a:latin typeface="Arial"/>
+              </a:rPr>
+              <a:t> coherència</a:t>
+            </a:r>
+            <a:r>
+              <a:rPr sz="1650" b="1" dirty="0" err="1">
+                <a:solidFill>
+                  <a:srgbClr val="1C2B3B"/>
+                </a:solidFill>
+                <a:latin typeface="Arial"/>
+              </a:rPr>
+              <a:t/>
+            </a:r>
+            <a:r>
+              <a:rPr lang="es-ES" sz="1650" b="1" dirty="0">
+                <a:solidFill>
+                  <a:srgbClr val="1C2B3B"/>
+                </a:solidFill>
+                <a:latin typeface="Arial"/>
+              </a:rPr>
+              <a:t/>
+            </a:r>
+            <a:r>
+              <a:rPr sz="1650" b="1" dirty="0" err="1">
+                <a:solidFill>
+                  <a:srgbClr val="1C2B3B"/>
+                </a:solidFill>
+                <a:latin typeface="Arial"/>
+              </a:rPr>
+              <a:t/>
+            </a:r>
+            <a:r>
+              <a:rPr lang="es-ES" sz="1650" b="1" dirty="0">
+                <a:solidFill>
+                  <a:srgbClr val="1C2B3B"/>
+                </a:solidFill>
+                <a:latin typeface="Arial"/>
+              </a:rPr>
+              <a:t>.</a:t>
+            </a:r>
+            <a:endParaRPr sz="1650" b="1" dirty="0">
+              <a:solidFill>
+                <a:srgbClr val="1C2B3B"/>
+              </a:solidFill>
+              <a:latin typeface="Arial"/>
+            </a:endParaRPr>
           </a:p>
         </p:txBody>
       </p:sp>
@@ -8939,7 +9475,7 @@
 </file>
 
 <file path=ppt/slides/slide5.xml><?xml version="1.0" encoding="utf-8"?>
-<p:sld xmlns:a="http://schemas.openxmlformats.org/drawingml/2006/main" xmlns:r="http://schemas.openxmlformats.org/officeDocument/2006/relationships" xmlns:p="http://schemas.openxmlformats.org/presentationml/2006/main">
+<p:sld xmlns:a="http://schemas.openxmlformats.org/drawingml/2006/main" xmlns:p="http://schemas.openxmlformats.org/presentationml/2006/main" xmlns:r="http://schemas.openxmlformats.org/officeDocument/2006/relationships">
   <p:cSld>
     <p:spTree>
       <p:nvGrpSpPr>
@@ -9265,15 +9801,15 @@
             </a:r>
             <a:r>
               <a:rPr dirty="0"/>
-              <a:t> </a:t>
+              <a:t> estructura de dades</a:t>
             </a:r>
             <a:r>
               <a:rPr lang="es-ES" dirty="0"/>
-              <a:t>estructura de  </a:t>
+              <a:t/>
             </a:r>
             <a:r>
               <a:rPr dirty="0" err="1"/>
-              <a:t>dades</a:t>
+              <a:t/>
             </a:r>
             <a:endParaRPr dirty="0"/>
           </a:p>
@@ -9371,11 +9907,11 @@
             </a:r>
             <a:r>
               <a:rPr lang="es-ES" dirty="0"/>
-              <a:t> </a:t>
+              <a:t> d’informació</a:t>
             </a:r>
             <a:r>
               <a:rPr lang="es-ES" dirty="0" err="1"/>
-              <a:t>d’información</a:t>
+              <a:t/>
             </a:r>
             <a:endParaRPr lang="es-ES" dirty="0"/>
           </a:p>
@@ -9985,7 +10521,7 @@
           <a:p>
             <a:pPr algn="ctr"/>
             <a:r>
-              <a:rPr sz="1200" b="1">
+              <a:rPr sz="1200" b="1" dirty="0">
                 <a:solidFill>
                   <a:srgbClr val="2A5C84"/>
                 </a:solidFill>
@@ -10339,13 +10875,175 @@
               </a:lnSpc>
             </a:pPr>
             <a:r>
-              <a:rPr sz="1450" b="1">
+              <a:rPr sz="1450" b="1" dirty="0">
                 <a:solidFill>
                   <a:srgbClr val="1C2B3B"/>
                 </a:solidFill>
                 <a:latin typeface="Arial"/>
               </a:rPr>
-              <a:t>La classe magistral posterior neix d’aquest punt de trobada: docència universitària, enginyeria de software i transferència professional.</a:t>
+              <a:t>La </a:t>
+            </a:r>
+            <a:r>
+              <a:rPr sz="1450" b="1" dirty="0" err="1">
+                <a:solidFill>
+                  <a:srgbClr val="1C2B3B"/>
+                </a:solidFill>
+                <a:latin typeface="Arial"/>
+              </a:rPr>
+              <a:t>classe</a:t>
+            </a:r>
+            <a:r>
+              <a:rPr sz="1450" b="1" dirty="0">
+                <a:solidFill>
+                  <a:srgbClr val="1C2B3B"/>
+                </a:solidFill>
+                <a:latin typeface="Arial"/>
+              </a:rPr>
+              <a:t> magistral posterior </a:t>
+            </a:r>
+            <a:r>
+              <a:rPr sz="1450" b="1" dirty="0" err="1">
+                <a:solidFill>
+                  <a:srgbClr val="1C2B3B"/>
+                </a:solidFill>
+                <a:latin typeface="Arial"/>
+              </a:rPr>
+              <a:t>neix</a:t>
+            </a:r>
+            <a:r>
+              <a:rPr sz="1450" b="1" dirty="0">
+                <a:solidFill>
+                  <a:srgbClr val="1C2B3B"/>
+                </a:solidFill>
+                <a:latin typeface="Arial"/>
+              </a:rPr>
+              <a:t> </a:t>
+            </a:r>
+            <a:r>
+              <a:rPr sz="1450" b="1" dirty="0" err="1">
+                <a:solidFill>
+                  <a:srgbClr val="1C2B3B"/>
+                </a:solidFill>
+                <a:latin typeface="Arial"/>
+              </a:rPr>
+              <a:t>d’aquest</a:t>
+            </a:r>
+            <a:r>
+              <a:rPr sz="1450" b="1" dirty="0">
+                <a:solidFill>
+                  <a:srgbClr val="1C2B3B"/>
+                </a:solidFill>
+                <a:latin typeface="Arial"/>
+              </a:rPr>
+              <a:t> punt de </a:t>
+            </a:r>
+            <a:r>
+              <a:rPr sz="1450" b="1" dirty="0" err="1">
+                <a:solidFill>
+                  <a:srgbClr val="1C2B3B"/>
+                </a:solidFill>
+                <a:latin typeface="Arial"/>
+              </a:rPr>
+              <a:t>trobada</a:t>
+            </a:r>
+            <a:r>
+              <a:rPr sz="1450" b="1" dirty="0">
+                <a:solidFill>
+                  <a:srgbClr val="1C2B3B"/>
+                </a:solidFill>
+                <a:latin typeface="Arial"/>
+              </a:rPr>
+              <a:t>: </a:t>
+            </a:r>
+            <a:r>
+              <a:rPr sz="1450" b="1" dirty="0" err="1">
+                <a:solidFill>
+                  <a:srgbClr val="1C2B3B"/>
+                </a:solidFill>
+                <a:latin typeface="Arial"/>
+              </a:rPr>
+              <a:t>docència</a:t>
+            </a:r>
+            <a:r>
+              <a:rPr sz="1450" b="1" dirty="0">
+                <a:solidFill>
+                  <a:srgbClr val="1C2B3B"/>
+                </a:solidFill>
+                <a:latin typeface="Arial"/>
+              </a:rPr>
+              <a:t> </a:t>
+            </a:r>
+            <a:r>
+              <a:rPr sz="1450" b="1" dirty="0" err="1">
+                <a:solidFill>
+                  <a:srgbClr val="1C2B3B"/>
+                </a:solidFill>
+                <a:latin typeface="Arial"/>
+              </a:rPr>
+              <a:t>universitària</a:t>
+            </a:r>
+            <a:r>
+              <a:rPr sz="1450" b="1" dirty="0">
+                <a:solidFill>
+                  <a:srgbClr val="1C2B3B"/>
+                </a:solidFill>
+                <a:latin typeface="Arial"/>
+              </a:rPr>
+              <a:t>, </a:t>
+            </a:r>
+            <a:r>
+              <a:rPr sz="1450" b="1" dirty="0" err="1">
+                <a:solidFill>
+                  <a:srgbClr val="1C2B3B"/>
+                </a:solidFill>
+                <a:latin typeface="Arial"/>
+              </a:rPr>
+              <a:t>enginyeria</a:t>
+            </a:r>
+            <a:r>
+              <a:rPr sz="1450" b="1" dirty="0">
+                <a:solidFill>
+                  <a:srgbClr val="1C2B3B"/>
+                </a:solidFill>
+                <a:latin typeface="Arial"/>
+              </a:rPr>
+              <a:t> de software </a:t>
+            </a:r>
+            <a:r>
+              <a:rPr sz="1450" b="1" dirty="0" err="1">
+                <a:solidFill>
+                  <a:srgbClr val="1C2B3B"/>
+                </a:solidFill>
+                <a:latin typeface="Arial"/>
+              </a:rPr>
+              <a:t>i</a:t>
+            </a:r>
+            <a:r>
+              <a:rPr sz="1450" b="1" dirty="0">
+                <a:solidFill>
+                  <a:srgbClr val="1C2B3B"/>
+                </a:solidFill>
+                <a:latin typeface="Arial"/>
+              </a:rPr>
+              <a:t> </a:t>
+            </a:r>
+            <a:r>
+              <a:rPr sz="1450" b="1" dirty="0" err="1">
+                <a:solidFill>
+                  <a:srgbClr val="1C2B3B"/>
+                </a:solidFill>
+                <a:latin typeface="Arial"/>
+              </a:rPr>
+              <a:t>transferència</a:t>
+            </a:r>
+            <a:r>
+              <a:rPr sz="1450" b="1" dirty="0">
+                <a:solidFill>
+                  <a:srgbClr val="1C2B3B"/>
+                </a:solidFill>
+                <a:latin typeface="Arial"/>
+              </a:rPr>
+              <a:t> professional.</a:t>
             </a:r>
           </a:p>
         </p:txBody>
@@ -10437,7 +11135,7 @@
 </file>
 
 <file path=ppt/slides/slide6.xml><?xml version="1.0" encoding="utf-8"?>
-<p:sld xmlns:a="http://schemas.openxmlformats.org/drawingml/2006/main" xmlns:r="http://schemas.openxmlformats.org/officeDocument/2006/relationships" xmlns:p="http://schemas.openxmlformats.org/presentationml/2006/main">
+<p:sld xmlns:a="http://schemas.openxmlformats.org/drawingml/2006/main" xmlns:p="http://schemas.openxmlformats.org/presentationml/2006/main" xmlns:r="http://schemas.openxmlformats.org/officeDocument/2006/relationships">
   <p:cSld>
     <p:spTree>
       <p:nvGrpSpPr>
@@ -11025,7 +11723,7 @@
                 </a:solidFill>
                 <a:latin typeface="Arial"/>
               </a:rPr>
-              <a:t>Educació</a:t>
+              <a:t>Educació i Tecnologia / empatia, escolta activa i comunicació assertiva en l’ensenyament de l’enginyeria de software.</a:t>
             </a:r>
             <a:r>
               <a:rPr sz="1340" b="0" dirty="0">
@@ -11034,7 +11732,7 @@
                 </a:solidFill>
                 <a:latin typeface="Arial"/>
               </a:rPr>
-              <a:t> </a:t>
+              <a:t/>
             </a:r>
             <a:r>
               <a:rPr sz="1340" b="0" dirty="0" err="1">
@@ -11043,7 +11741,7 @@
                 </a:solidFill>
                 <a:latin typeface="Arial"/>
               </a:rPr>
-              <a:t>i</a:t>
+              <a:t/>
             </a:r>
             <a:r>
               <a:rPr sz="1340" b="0" dirty="0">
@@ -11052,7 +11750,7 @@
                 </a:solidFill>
                 <a:latin typeface="Arial"/>
               </a:rPr>
-              <a:t> </a:t>
+              <a:t/>
             </a:r>
             <a:r>
               <a:rPr sz="1340" b="0" dirty="0" err="1">
@@ -11061,107 +11759,115 @@
                 </a:solidFill>
                 <a:latin typeface="Arial"/>
               </a:rPr>
-              <a:t>Tecnologia</a:t>
-            </a:r>
-            <a:br>
+              <a:t/>
+            </a:r>
+            <a:r>
+              <a:rPr sz="1340" b="0" dirty="0">
+                <a:solidFill>
+                  <a:srgbClr val="2D343C"/>
+                </a:solidFill>
+                <a:latin typeface="Arial"/>
+              </a:rPr>
+              <a:t/>
+            </a:r>
+            <a:r>
+              <a:rPr sz="1340" b="0" dirty="0" err="1">
+                <a:solidFill>
+                  <a:srgbClr val="2D343C"/>
+                </a:solidFill>
+                <a:latin typeface="Arial"/>
+              </a:rPr>
+              <a:t/>
+            </a:r>
+            <a:r>
+              <a:rPr sz="1340" b="0" dirty="0">
+                <a:solidFill>
+                  <a:srgbClr val="2D343C"/>
+                </a:solidFill>
+                <a:latin typeface="Arial"/>
+              </a:rPr>
+              <a:t/>
+            </a:r>
+            <a:r>
+              <a:rPr sz="1340" b="0" dirty="0" err="1">
+                <a:solidFill>
+                  <a:srgbClr val="2D343C"/>
+                </a:solidFill>
+                <a:latin typeface="Arial"/>
+              </a:rPr>
+              <a:t/>
+            </a:r>
+            <a:r>
+              <a:rPr sz="1340" b="0" dirty="0">
+                <a:solidFill>
+                  <a:srgbClr val="2D343C"/>
+                </a:solidFill>
+                <a:latin typeface="Arial"/>
+              </a:rPr>
+              <a:t/>
+            </a:r>
+            <a:r>
+              <a:rPr sz="1340" b="0" dirty="0" err="1">
+                <a:solidFill>
+                  <a:srgbClr val="2D343C"/>
+                </a:solidFill>
+                <a:latin typeface="Arial"/>
+              </a:rPr>
+              <a:t/>
+            </a:r>
+            <a:r>
+              <a:rPr sz="1340" b="0" dirty="0">
+                <a:solidFill>
+                  <a:srgbClr val="2D343C"/>
+                </a:solidFill>
+                <a:latin typeface="Arial"/>
+              </a:rPr>
+              <a:t/>
+            </a:r>
+            <a:r>
+              <a:rPr sz="1340" b="0" dirty="0" err="1">
+                <a:solidFill>
+                  <a:srgbClr val="2D343C"/>
+                </a:solidFill>
+                <a:latin typeface="Arial"/>
+              </a:rPr>
+              <a:t/>
+            </a:r>
+            <a:r>
+              <a:rPr sz="1340" b="0" dirty="0">
+                <a:solidFill>
+                  <a:srgbClr val="2D343C"/>
+                </a:solidFill>
+                <a:latin typeface="Arial"/>
+              </a:rPr>
+              <a:t/>
+            </a:r>
+            <a:r>
+              <a:rPr sz="1340" b="0" dirty="0" err="1">
+                <a:solidFill>
+                  <a:srgbClr val="2D343C"/>
+                </a:solidFill>
+                <a:latin typeface="Arial"/>
+              </a:rPr>
+              <a:t/>
+            </a:r>
+            <a:r>
               <a:rPr lang="es-ES" sz="1340" b="0" dirty="0">
                 <a:solidFill>
                   <a:srgbClr val="2D343C"/>
                 </a:solidFill>
                 <a:latin typeface="Arial"/>
               </a:rPr>
-            </a:br>
-            <a:r>
-              <a:rPr sz="1340" b="0" dirty="0">
-                <a:solidFill>
-                  <a:srgbClr val="2D343C"/>
-                </a:solidFill>
-                <a:latin typeface="Arial"/>
-              </a:rPr>
-              <a:t>
-</a:t>
-            </a:r>
-            <a:r>
-              <a:rPr sz="1340" b="0" dirty="0" err="1">
-                <a:solidFill>
-                  <a:srgbClr val="2D343C"/>
-                </a:solidFill>
-                <a:latin typeface="Arial"/>
-              </a:rPr>
-              <a:t>empatia</a:t>
-            </a:r>
-            <a:r>
-              <a:rPr sz="1340" b="0" dirty="0">
-                <a:solidFill>
-                  <a:srgbClr val="2D343C"/>
-                </a:solidFill>
-                <a:latin typeface="Arial"/>
-              </a:rPr>
-              <a:t>, </a:t>
-            </a:r>
-            <a:r>
-              <a:rPr sz="1340" b="0" dirty="0" err="1">
-                <a:solidFill>
-                  <a:srgbClr val="2D343C"/>
-                </a:solidFill>
-                <a:latin typeface="Arial"/>
-              </a:rPr>
-              <a:t>escolta</a:t>
-            </a:r>
-            <a:r>
-              <a:rPr sz="1340" b="0" dirty="0">
-                <a:solidFill>
-                  <a:srgbClr val="2D343C"/>
-                </a:solidFill>
-                <a:latin typeface="Arial"/>
-              </a:rPr>
-              <a:t> </a:t>
-            </a:r>
-            <a:r>
-              <a:rPr sz="1340" b="0" dirty="0" err="1">
-                <a:solidFill>
-                  <a:srgbClr val="2D343C"/>
-                </a:solidFill>
-                <a:latin typeface="Arial"/>
-              </a:rPr>
-              <a:t>activa</a:t>
-            </a:r>
-            <a:r>
-              <a:rPr sz="1340" b="0" dirty="0">
-                <a:solidFill>
-                  <a:srgbClr val="2D343C"/>
-                </a:solidFill>
-                <a:latin typeface="Arial"/>
-              </a:rPr>
-              <a:t>
-</a:t>
-            </a:r>
-            <a:r>
-              <a:rPr sz="1340" b="0" dirty="0" err="1">
-                <a:solidFill>
-                  <a:srgbClr val="2D343C"/>
-                </a:solidFill>
-                <a:latin typeface="Arial"/>
-              </a:rPr>
-              <a:t>comunicació</a:t>
-            </a:r>
-            <a:r>
-              <a:rPr sz="1340" b="0" dirty="0">
-                <a:solidFill>
-                  <a:srgbClr val="2D343C"/>
-                </a:solidFill>
-                <a:latin typeface="Arial"/>
-              </a:rPr>
-              <a:t> </a:t>
-            </a:r>
-            <a:r>
-              <a:rPr sz="1340" b="0" dirty="0" err="1">
-                <a:solidFill>
-                  <a:srgbClr val="2D343C"/>
-                </a:solidFill>
-                <a:latin typeface="Arial"/>
-              </a:rPr>
-              <a:t>asertiva</a:t>
+              <a:t/>
+            </a:r>
+            <a:r>
+              <a:rPr lang="es-ES" sz="1340" b="0" dirty="0" err="1">
+                <a:solidFill>
+                  <a:srgbClr val="2D343C"/>
+                </a:solidFill>
+                <a:latin typeface="Arial"/>
+              </a:rPr>
+              <a:t/>
             </a:r>
             <a:r>
               <a:rPr lang="es-ES" sz="1340" b="0" dirty="0">
@@ -11170,7 +11876,7 @@
                 </a:solidFill>
                 <a:latin typeface="Arial"/>
               </a:rPr>
-              <a:t> en </a:t>
+              <a:t/>
             </a:r>
             <a:r>
               <a:rPr lang="es-ES" sz="1340" b="0" dirty="0" err="1">
@@ -11179,7 +11885,7 @@
                 </a:solidFill>
                 <a:latin typeface="Arial"/>
               </a:rPr>
-              <a:t>l'ensenyament</a:t>
+              <a:t/>
             </a:r>
             <a:r>
               <a:rPr lang="es-ES" sz="1340" b="0" dirty="0">
@@ -11188,25 +11894,7 @@
                 </a:solidFill>
                 <a:latin typeface="Arial"/>
               </a:rPr>
-              <a:t> de </a:t>
-            </a:r>
-            <a:r>
-              <a:rPr lang="es-ES" sz="1340" b="0" dirty="0" err="1">
-                <a:solidFill>
-                  <a:srgbClr val="2D343C"/>
-                </a:solidFill>
-                <a:latin typeface="Arial"/>
-              </a:rPr>
-              <a:t>l'enginyeria</a:t>
-            </a:r>
-            <a:r>
-              <a:rPr lang="es-ES" sz="1340" b="0" dirty="0">
-                <a:solidFill>
-                  <a:srgbClr val="2D343C"/>
-                </a:solidFill>
-                <a:latin typeface="Arial"/>
-              </a:rPr>
-              <a:t> al software. </a:t>
+              <a:t/>
             </a:r>
             <a:endParaRPr sz="1340" b="0" dirty="0">
               <a:solidFill>

</xml_diff>

<commit_message>
Update Catalan style wording in presentation
</commit_message>
<xml_diff>
--- a/doc/presentations/defensa-placa-permanent-dsi-ports-sortida-hexagonal/output/defensa-trajectoria-10-minuts.pptx
+++ b/doc/presentations/defensa-placa-permanent-dsi-ports-sortida-hexagonal/output/defensa-trajectoria-10-minuts.pptx
@@ -432,7 +432,7 @@
 </file>
 
 <file path=ppt/notesSlides/notesSlide3.xml><?xml version="1.0" encoding="utf-8"?>
-<p:notes xmlns:a="http://schemas.openxmlformats.org/drawingml/2006/main" xmlns:p="http://schemas.openxmlformats.org/presentationml/2006/main">
+<p:notes xmlns:a="http://schemas.openxmlformats.org/drawingml/2006/main" xmlns:r="http://schemas.openxmlformats.org/officeDocument/2006/relationships" xmlns:p="http://schemas.openxmlformats.org/presentationml/2006/main">
   <p:cSld>
     <p:spTree>
       <p:nvGrpSpPr>
@@ -1165,7 +1165,7 @@
           <a:p>
             <a:fld id="{5BCAD085-E8A6-8845-BD4E-CB4CCA059FC4}" type="datetimeFigureOut">
               <a:rPr lang="en-US" smtClean="0"/>
-              <a:t>7/6/26</a:t>
+              <a:t>7/7/26</a:t>
             </a:fld>
             <a:endParaRPr lang="en-US"/>
           </a:p>
@@ -1333,7 +1333,7 @@
           <a:p>
             <a:fld id="{5BCAD085-E8A6-8845-BD4E-CB4CCA059FC4}" type="datetimeFigureOut">
               <a:rPr lang="en-US" smtClean="0"/>
-              <a:t>7/6/26</a:t>
+              <a:t>7/7/26</a:t>
             </a:fld>
             <a:endParaRPr lang="en-US"/>
           </a:p>
@@ -1511,7 +1511,7 @@
           <a:p>
             <a:fld id="{5BCAD085-E8A6-8845-BD4E-CB4CCA059FC4}" type="datetimeFigureOut">
               <a:rPr lang="en-US" smtClean="0"/>
-              <a:t>7/6/26</a:t>
+              <a:t>7/7/26</a:t>
             </a:fld>
             <a:endParaRPr lang="en-US"/>
           </a:p>
@@ -1679,7 +1679,7 @@
           <a:p>
             <a:fld id="{5BCAD085-E8A6-8845-BD4E-CB4CCA059FC4}" type="datetimeFigureOut">
               <a:rPr lang="en-US" smtClean="0"/>
-              <a:t>7/6/26</a:t>
+              <a:t>7/7/26</a:t>
             </a:fld>
             <a:endParaRPr lang="en-US"/>
           </a:p>
@@ -1924,7 +1924,7 @@
           <a:p>
             <a:fld id="{5BCAD085-E8A6-8845-BD4E-CB4CCA059FC4}" type="datetimeFigureOut">
               <a:rPr lang="en-US" smtClean="0"/>
-              <a:t>7/6/26</a:t>
+              <a:t>7/7/26</a:t>
             </a:fld>
             <a:endParaRPr lang="en-US"/>
           </a:p>
@@ -2209,7 +2209,7 @@
           <a:p>
             <a:fld id="{5BCAD085-E8A6-8845-BD4E-CB4CCA059FC4}" type="datetimeFigureOut">
               <a:rPr lang="en-US" smtClean="0"/>
-              <a:t>7/6/26</a:t>
+              <a:t>7/7/26</a:t>
             </a:fld>
             <a:endParaRPr lang="en-US"/>
           </a:p>
@@ -2628,7 +2628,7 @@
           <a:p>
             <a:fld id="{5BCAD085-E8A6-8845-BD4E-CB4CCA059FC4}" type="datetimeFigureOut">
               <a:rPr lang="en-US" smtClean="0"/>
-              <a:t>7/6/26</a:t>
+              <a:t>7/7/26</a:t>
             </a:fld>
             <a:endParaRPr lang="en-US"/>
           </a:p>
@@ -2745,7 +2745,7 @@
           <a:p>
             <a:fld id="{5BCAD085-E8A6-8845-BD4E-CB4CCA059FC4}" type="datetimeFigureOut">
               <a:rPr lang="en-US" smtClean="0"/>
-              <a:t>7/6/26</a:t>
+              <a:t>7/7/26</a:t>
             </a:fld>
             <a:endParaRPr lang="en-US"/>
           </a:p>
@@ -2840,7 +2840,7 @@
           <a:p>
             <a:fld id="{5BCAD085-E8A6-8845-BD4E-CB4CCA059FC4}" type="datetimeFigureOut">
               <a:rPr lang="en-US" smtClean="0"/>
-              <a:t>7/6/26</a:t>
+              <a:t>7/7/26</a:t>
             </a:fld>
             <a:endParaRPr lang="en-US"/>
           </a:p>
@@ -3115,7 +3115,7 @@
           <a:p>
             <a:fld id="{5BCAD085-E8A6-8845-BD4E-CB4CCA059FC4}" type="datetimeFigureOut">
               <a:rPr lang="en-US" smtClean="0"/>
-              <a:t>7/6/26</a:t>
+              <a:t>7/7/26</a:t>
             </a:fld>
             <a:endParaRPr lang="en-US"/>
           </a:p>
@@ -3367,7 +3367,7 @@
           <a:p>
             <a:fld id="{5BCAD085-E8A6-8845-BD4E-CB4CCA059FC4}" type="datetimeFigureOut">
               <a:rPr lang="en-US" smtClean="0"/>
-              <a:t>7/6/26</a:t>
+              <a:t>7/7/26</a:t>
             </a:fld>
             <a:endParaRPr lang="en-US"/>
           </a:p>
@@ -3578,7 +3578,7 @@
           <a:p>
             <a:fld id="{5BCAD085-E8A6-8845-BD4E-CB4CCA059FC4}" type="datetimeFigureOut">
               <a:rPr lang="en-US" smtClean="0"/>
-              <a:t>7/6/26</a:t>
+              <a:t>7/7/26</a:t>
             </a:fld>
             <a:endParaRPr lang="en-US"/>
           </a:p>
@@ -3937,7 +3937,7 @@
 </file>
 
 <file path=ppt/slides/slide1.xml><?xml version="1.0" encoding="utf-8"?>
-<p:sld xmlns:a="http://schemas.openxmlformats.org/drawingml/2006/main" xmlns:p="http://schemas.openxmlformats.org/presentationml/2006/main" xmlns:r="http://schemas.openxmlformats.org/officeDocument/2006/relationships">
+<p:sld xmlns:a="http://schemas.openxmlformats.org/drawingml/2006/main" xmlns:r="http://schemas.openxmlformats.org/officeDocument/2006/relationships" xmlns:p="http://schemas.openxmlformats.org/presentationml/2006/main">
   <p:cSld>
     <p:spTree>
       <p:nvGrpSpPr>
@@ -4808,24 +4808,6 @@
               </a:rPr>
               <a:t> docent i acadèmic</a:t>
             </a:r>
-            <a:r>
-              <a:rPr sz="1080" b="0" dirty="0">
-                <a:solidFill>
-                  <a:srgbClr val="67717C"/>
-                </a:solidFill>
-                <a:latin typeface="Arial"/>
-              </a:rPr>
-              <a:t/>
-            </a:r>
-            <a:r>
-              <a:rPr sz="1080" b="0" dirty="0" err="1">
-                <a:solidFill>
-                  <a:srgbClr val="67717C"/>
-                </a:solidFill>
-                <a:latin typeface="Arial"/>
-              </a:rPr>
-              <a:t/>
-            </a:r>
             <a:endParaRPr sz="1080" b="0" dirty="0">
               <a:solidFill>
                 <a:srgbClr val="67717C"/>
@@ -5213,7 +5195,7 @@
 </file>
 
 <file path=ppt/slides/slide2.xml><?xml version="1.0" encoding="utf-8"?>
-<p:sld xmlns:a="http://schemas.openxmlformats.org/drawingml/2006/main" xmlns:ns3="http://schemas.microsoft.com/office/drawing/2014/main" xmlns:ns4="http://schemas.microsoft.com/office/drawing/2010/main" xmlns:p="http://schemas.openxmlformats.org/presentationml/2006/main" xmlns:r="http://schemas.openxmlformats.org/officeDocument/2006/relationships">
+<p:sld xmlns:a="http://schemas.openxmlformats.org/drawingml/2006/main" xmlns:r="http://schemas.openxmlformats.org/officeDocument/2006/relationships" xmlns:p="http://schemas.openxmlformats.org/presentationml/2006/main">
   <p:cSld>
     <p:spTree>
       <p:nvGrpSpPr>
@@ -5750,15 +5732,7 @@
             </a:r>
             <a:r>
               <a:rPr lang="es-ES" dirty="0"/>
-              <a:t> a apps per a dispositius Nokia/Symbian</a:t>
-            </a:r>
-            <a:r>
-              <a:rPr lang="es-ES" dirty="0" err="1"/>
-              <a:t/>
-            </a:r>
-            <a:r>
-              <a:rPr lang="es-ES" dirty="0"/>
-              <a:t>.</a:t>
+              <a:t> a apps per a dispositius Nokia/Symbian.</a:t>
             </a:r>
           </a:p>
           <a:p>
@@ -5811,15 +5785,7 @@
             </a:r>
             <a:r>
               <a:rPr lang="es-ES" dirty="0"/>
-              <a:t> de memòria, CPU</a:t>
-            </a:r>
-            <a:r>
-              <a:rPr lang="es-ES" dirty="0" err="1"/>
-              <a:t/>
-            </a:r>
-            <a:r>
-              <a:rPr lang="es-ES" dirty="0"/>
-              <a:t> i </a:t>
+              <a:t> de memòria, CPU i </a:t>
             </a:r>
             <a:r>
               <a:rPr lang="es-ES" dirty="0" err="1"/>
@@ -6245,14 +6211,6 @@
             </a:r>
             <a:r>
               <a:rPr lang="es-ES" dirty="0"/>
-              <a:t/>
-            </a:r>
-            <a:r>
-              <a:rPr dirty="0" err="1"/>
-              <a:t/>
-            </a:r>
-            <a:r>
-              <a:rPr lang="es-ES" dirty="0"/>
               <a:t> i comercial</a:t>
             </a:r>
             <a:r>
@@ -6842,7 +6800,7 @@
           <p:cNvPr id="12" name="Picture 2">
             <a:extLst>
               <a:ext uri="{FF2B5EF4-FFF2-40B4-BE49-F238E27FC236}">
-                <ns3:creationId id="{BB6ECFDF-B584-B54F-80A3-0D4117F0A159}"/>
+                <a16:creationId xmlns:a16="http://schemas.microsoft.com/office/drawing/2014/main" id="{BB6ECFDF-B584-B54F-80A3-0D4117F0A159}"/>
               </a:ext>
             </a:extLst>
           </p:cNvPr>
@@ -6855,7 +6813,7 @@
           <a:blip r:embed="rId4">
             <a:extLst>
               <a:ext uri="{28A0092B-C50C-407E-A947-70E740481C1C}">
-                <ns4:useLocalDpi val="0"/>
+                <a14:useLocalDpi xmlns:a14="http://schemas.microsoft.com/office/drawing/2010/main" val="0"/>
               </a:ext>
             </a:extLst>
           </a:blip>
@@ -6875,11 +6833,11 @@
           <a:noFill/>
           <a:extLst>
             <a:ext uri="{909E8E84-426E-40DD-AFC4-6F175D3DCCD1}">
-              <ns4:hiddenFill>
+              <a14:hiddenFill xmlns:a14="http://schemas.microsoft.com/office/drawing/2010/main">
                 <a:solidFill>
                   <a:srgbClr val="FFFFFF"/>
                 </a:solidFill>
-              </ns4:hiddenFill>
+              </a14:hiddenFill>
             </a:ext>
           </a:extLst>
         </p:spPr>
@@ -6893,7 +6851,7 @@
 </file>
 
 <file path=ppt/slides/slide3.xml><?xml version="1.0" encoding="utf-8"?>
-<p:sld xmlns:a="http://schemas.openxmlformats.org/drawingml/2006/main" xmlns:p="http://schemas.openxmlformats.org/presentationml/2006/main" xmlns:r="http://schemas.openxmlformats.org/officeDocument/2006/relationships">
+<p:sld xmlns:a="http://schemas.openxmlformats.org/drawingml/2006/main" xmlns:r="http://schemas.openxmlformats.org/officeDocument/2006/relationships" xmlns:p="http://schemas.openxmlformats.org/presentationml/2006/main">
   <p:cSld>
     <p:spTree>
       <p:nvGrpSpPr>
@@ -7906,33 +7864,6 @@
               <a:t> de sistemes</a:t>
             </a:r>
             <a:r>
-              <a:rPr sz="1370" b="0" dirty="0" err="1">
-                <a:solidFill>
-                  <a:srgbClr val="2D343C"/>
-                </a:solidFill>
-                <a:latin typeface="Arial"/>
-              </a:rPr>
-              <a:t/>
-            </a:r>
-            <a:r>
-              <a:rPr lang="es-ES" sz="1370" b="0" dirty="0">
-                <a:solidFill>
-                  <a:srgbClr val="2D343C"/>
-                </a:solidFill>
-                <a:latin typeface="Arial"/>
-              </a:rPr>
-              <a:t/>
-            </a:r>
-            <a:r>
-              <a:rPr sz="1370" b="0" dirty="0">
-                <a:solidFill>
-                  <a:srgbClr val="2D343C"/>
-                </a:solidFill>
-                <a:latin typeface="Arial"/>
-              </a:rPr>
-              <a:t/>
-            </a:r>
-            <a:r>
               <a:rPr lang="es-ES" sz="1370" dirty="0">
                 <a:solidFill>
                   <a:srgbClr val="2D343C"/>
@@ -8002,25 +7933,7 @@
                 </a:solidFill>
                 <a:latin typeface="Arial"/>
               </a:rPr>
-              <a:t> positiva de l’FP</a:t>
-            </a:r>
-            <a:r>
-              <a:rPr sz="1600" b="1" dirty="0">
-                <a:solidFill>
-                  <a:srgbClr val="1C2B3B"/>
-                </a:solidFill>
-                <a:latin typeface="Arial"/>
-              </a:rPr>
-              <a:t/>
-            </a:r>
-            <a:r>
-              <a:rPr lang="es-ES" sz="1600" b="1" dirty="0">
-                <a:solidFill>
-                  <a:srgbClr val="1C2B3B"/>
-                </a:solidFill>
-                <a:latin typeface="Arial"/>
-              </a:rPr>
-              <a:t>.</a:t>
+              <a:t> positiva de l’FP.</a:t>
             </a:r>
             <a:r>
               <a:rPr sz="1600" b="1" dirty="0">
@@ -8193,7 +8106,7 @@
 </file>
 
 <file path=ppt/slides/slide4.xml><?xml version="1.0" encoding="utf-8"?>
-<p:sld xmlns:a="http://schemas.openxmlformats.org/drawingml/2006/main" xmlns:p="http://schemas.openxmlformats.org/presentationml/2006/main" xmlns:r="http://schemas.openxmlformats.org/officeDocument/2006/relationships">
+<p:sld xmlns:a="http://schemas.openxmlformats.org/drawingml/2006/main" xmlns:r="http://schemas.openxmlformats.org/officeDocument/2006/relationships" xmlns:p="http://schemas.openxmlformats.org/presentationml/2006/main">
   <p:cSld>
     <p:spTree>
       <p:nvGrpSpPr>
@@ -8920,7 +8833,7 @@
         <p:spPr>
           <a:xfrm>
             <a:off x="7699246" y="2048256"/>
-            <a:ext cx="1800671" cy="340822"/>
+            <a:ext cx="2391378" cy="452628"/>
           </a:xfrm>
           <a:prstGeom prst="rect">
             <a:avLst/>
@@ -8935,7 +8848,7 @@
         </p:nvSpPr>
         <p:spPr>
           <a:xfrm>
-            <a:off x="8128302" y="2462274"/>
+            <a:off x="8128302" y="2528949"/>
             <a:ext cx="1653789" cy="397665"/>
           </a:xfrm>
           <a:prstGeom prst="rect">
@@ -8980,7 +8893,7 @@
         </p:nvSpPr>
         <p:spPr>
           <a:xfrm>
-            <a:off x="7818119" y="2873502"/>
+            <a:off x="7818119" y="2930652"/>
             <a:ext cx="2103120" cy="914400"/>
           </a:xfrm>
           <a:prstGeom prst="rect">
@@ -9342,33 +9255,6 @@
                 <a:latin typeface="Arial"/>
               </a:rPr>
               <a:t> coherència</a:t>
-            </a:r>
-            <a:r>
-              <a:rPr sz="1650" b="1" dirty="0" err="1">
-                <a:solidFill>
-                  <a:srgbClr val="1C2B3B"/>
-                </a:solidFill>
-                <a:latin typeface="Arial"/>
-              </a:rPr>
-              <a:t/>
-            </a:r>
-            <a:r>
-              <a:rPr lang="es-ES" sz="1650" b="1" dirty="0">
-                <a:solidFill>
-                  <a:srgbClr val="1C2B3B"/>
-                </a:solidFill>
-                <a:latin typeface="Arial"/>
-              </a:rPr>
-              <a:t/>
-            </a:r>
-            <a:r>
-              <a:rPr sz="1650" b="1" dirty="0" err="1">
-                <a:solidFill>
-                  <a:srgbClr val="1C2B3B"/>
-                </a:solidFill>
-                <a:latin typeface="Arial"/>
-              </a:rPr>
-              <a:t/>
             </a:r>
             <a:r>
               <a:rPr lang="es-ES" sz="1650" b="1" dirty="0">
@@ -9475,7 +9361,7 @@
 </file>
 
 <file path=ppt/slides/slide5.xml><?xml version="1.0" encoding="utf-8"?>
-<p:sld xmlns:a="http://schemas.openxmlformats.org/drawingml/2006/main" xmlns:p="http://schemas.openxmlformats.org/presentationml/2006/main" xmlns:r="http://schemas.openxmlformats.org/officeDocument/2006/relationships">
+<p:sld xmlns:a="http://schemas.openxmlformats.org/drawingml/2006/main" xmlns:r="http://schemas.openxmlformats.org/officeDocument/2006/relationships" xmlns:p="http://schemas.openxmlformats.org/presentationml/2006/main">
   <p:cSld>
     <p:spTree>
       <p:nvGrpSpPr>
@@ -9803,15 +9689,6 @@
               <a:rPr dirty="0"/>
               <a:t> estructura de dades</a:t>
             </a:r>
-            <a:r>
-              <a:rPr lang="es-ES" dirty="0"/>
-              <a:t/>
-            </a:r>
-            <a:r>
-              <a:rPr dirty="0" err="1"/>
-              <a:t/>
-            </a:r>
-            <a:endParaRPr dirty="0"/>
           </a:p>
           <a:p>
             <a:pPr>
@@ -9909,11 +9786,6 @@
               <a:rPr lang="es-ES" dirty="0"/>
               <a:t> d’informació</a:t>
             </a:r>
-            <a:r>
-              <a:rPr lang="es-ES" dirty="0" err="1"/>
-              <a:t/>
-            </a:r>
-            <a:endParaRPr lang="es-ES" dirty="0"/>
           </a:p>
           <a:p>
             <a:pPr>
@@ -11135,7 +11007,7 @@
 </file>
 
 <file path=ppt/slides/slide6.xml><?xml version="1.0" encoding="utf-8"?>
-<p:sld xmlns:a="http://schemas.openxmlformats.org/drawingml/2006/main" xmlns:p="http://schemas.openxmlformats.org/presentationml/2006/main" xmlns:r="http://schemas.openxmlformats.org/officeDocument/2006/relationships">
+<p:sld xmlns:a="http://schemas.openxmlformats.org/drawingml/2006/main" xmlns:r="http://schemas.openxmlformats.org/officeDocument/2006/relationships" xmlns:p="http://schemas.openxmlformats.org/presentationml/2006/main">
   <p:cSld>
     <p:spTree>
       <p:nvGrpSpPr>
@@ -11421,7 +11293,7 @@
         <p:spPr>
           <a:xfrm>
             <a:off x="1170432" y="2395727"/>
-            <a:ext cx="2308264" cy="1480533"/>
+            <a:ext cx="2449068" cy="1747648"/>
           </a:xfrm>
           <a:prstGeom prst="rect">
             <a:avLst/>
@@ -11430,7 +11302,7 @@
         </p:spPr>
         <p:txBody>
           <a:bodyPr wrap="square" anchor="t">
-            <a:normAutofit lnSpcReduction="10000"/>
+            <a:normAutofit/>
           </a:bodyPr>
           <a:lstStyle/>
           <a:p>
@@ -11460,6 +11332,15 @@
               <a:t> </a:t>
             </a:r>
             <a:r>
+              <a:rPr lang="es-ES" sz="1340" b="0" dirty="0">
+                <a:solidFill>
+                  <a:srgbClr val="2D343C"/>
+                </a:solidFill>
+                <a:latin typeface="Arial"/>
+              </a:rPr>
+              <a:t>en </a:t>
+            </a:r>
+            <a:r>
               <a:rPr lang="es-ES" sz="1340" b="0" dirty="0" err="1">
                 <a:solidFill>
                   <a:srgbClr val="2D343C"/>
@@ -11475,7 +11356,25 @@
                 </a:solidFill>
                 <a:latin typeface="Arial"/>
               </a:rPr>
-              <a:t> del software internacional</a:t>
+              <a:t> del software </a:t>
+            </a:r>
+            <a:r>
+              <a:rPr lang="es-ES" sz="1340" b="0" dirty="0" err="1">
+                <a:solidFill>
+                  <a:srgbClr val="2D343C"/>
+                </a:solidFill>
+                <a:latin typeface="Arial"/>
+              </a:rPr>
+              <a:t>àmbit</a:t>
+            </a:r>
+            <a:r>
+              <a:rPr lang="es-ES" sz="1340" b="0" dirty="0">
+                <a:solidFill>
+                  <a:srgbClr val="2D343C"/>
+                </a:solidFill>
+                <a:latin typeface="Arial"/>
+              </a:rPr>
+              <a:t> internacional</a:t>
             </a:r>
             <a:r>
               <a:rPr lang="es-ES" sz="1340" dirty="0">
@@ -11487,59 +11386,14 @@
               <a:t> </a:t>
             </a:r>
             <a:r>
-              <a:rPr lang="es-ES" sz="1340" b="0" dirty="0">
-                <a:solidFill>
-                  <a:srgbClr val="2D343C"/>
-                </a:solidFill>
-                <a:latin typeface="Arial"/>
-              </a:rPr>
-              <a:t>en </a:t>
-            </a:r>
-            <a:r>
-              <a:rPr sz="1340" b="0" dirty="0" err="1">
-                <a:solidFill>
-                  <a:srgbClr val="2D343C"/>
-                </a:solidFill>
-                <a:latin typeface="Arial"/>
-              </a:rPr>
-              <a:t>anglès</a:t>
-            </a:r>
-            <a:r>
               <a:rPr sz="1340" b="0" dirty="0">
                 <a:solidFill>
                   <a:srgbClr val="2D343C"/>
                 </a:solidFill>
                 <a:latin typeface="Arial"/>
               </a:rPr>
-              <a:t> 
-</a:t>
-            </a:r>
-            <a:r>
-              <a:rPr lang="es-ES" sz="1340" dirty="0" err="1">
-                <a:solidFill>
-                  <a:srgbClr val="2D343C"/>
-                </a:solidFill>
-                <a:latin typeface="Arial"/>
-              </a:rPr>
-              <a:t>soft</a:t>
-            </a:r>
-            <a:r>
-              <a:rPr lang="es-ES" sz="1340" dirty="0">
-                <a:solidFill>
-                  <a:srgbClr val="2D343C"/>
-                </a:solidFill>
-                <a:latin typeface="Arial"/>
-              </a:rPr>
-              <a:t> </a:t>
-            </a:r>
-            <a:r>
-              <a:rPr lang="es-ES" sz="1340" dirty="0" err="1">
-                <a:solidFill>
-                  <a:srgbClr val="2D343C"/>
-                </a:solidFill>
-                <a:latin typeface="Arial"/>
-              </a:rPr>
-              <a:t>skills</a:t>
+              <a:t>
+competències personals</a:t>
             </a:r>
             <a:r>
               <a:rPr lang="es-ES" sz="1340" dirty="0">
@@ -11725,177 +11579,6 @@
               </a:rPr>
               <a:t>Educació i Tecnologia / empatia, escolta activa i comunicació assertiva en l’ensenyament de l’enginyeria de software.</a:t>
             </a:r>
-            <a:r>
-              <a:rPr sz="1340" b="0" dirty="0">
-                <a:solidFill>
-                  <a:srgbClr val="2D343C"/>
-                </a:solidFill>
-                <a:latin typeface="Arial"/>
-              </a:rPr>
-              <a:t/>
-            </a:r>
-            <a:r>
-              <a:rPr sz="1340" b="0" dirty="0" err="1">
-                <a:solidFill>
-                  <a:srgbClr val="2D343C"/>
-                </a:solidFill>
-                <a:latin typeface="Arial"/>
-              </a:rPr>
-              <a:t/>
-            </a:r>
-            <a:r>
-              <a:rPr sz="1340" b="0" dirty="0">
-                <a:solidFill>
-                  <a:srgbClr val="2D343C"/>
-                </a:solidFill>
-                <a:latin typeface="Arial"/>
-              </a:rPr>
-              <a:t/>
-            </a:r>
-            <a:r>
-              <a:rPr sz="1340" b="0" dirty="0" err="1">
-                <a:solidFill>
-                  <a:srgbClr val="2D343C"/>
-                </a:solidFill>
-                <a:latin typeface="Arial"/>
-              </a:rPr>
-              <a:t/>
-            </a:r>
-            <a:r>
-              <a:rPr sz="1340" b="0" dirty="0">
-                <a:solidFill>
-                  <a:srgbClr val="2D343C"/>
-                </a:solidFill>
-                <a:latin typeface="Arial"/>
-              </a:rPr>
-              <a:t/>
-            </a:r>
-            <a:r>
-              <a:rPr sz="1340" b="0" dirty="0" err="1">
-                <a:solidFill>
-                  <a:srgbClr val="2D343C"/>
-                </a:solidFill>
-                <a:latin typeface="Arial"/>
-              </a:rPr>
-              <a:t/>
-            </a:r>
-            <a:r>
-              <a:rPr sz="1340" b="0" dirty="0">
-                <a:solidFill>
-                  <a:srgbClr val="2D343C"/>
-                </a:solidFill>
-                <a:latin typeface="Arial"/>
-              </a:rPr>
-              <a:t/>
-            </a:r>
-            <a:r>
-              <a:rPr sz="1340" b="0" dirty="0" err="1">
-                <a:solidFill>
-                  <a:srgbClr val="2D343C"/>
-                </a:solidFill>
-                <a:latin typeface="Arial"/>
-              </a:rPr>
-              <a:t/>
-            </a:r>
-            <a:r>
-              <a:rPr sz="1340" b="0" dirty="0">
-                <a:solidFill>
-                  <a:srgbClr val="2D343C"/>
-                </a:solidFill>
-                <a:latin typeface="Arial"/>
-              </a:rPr>
-              <a:t/>
-            </a:r>
-            <a:r>
-              <a:rPr sz="1340" b="0" dirty="0" err="1">
-                <a:solidFill>
-                  <a:srgbClr val="2D343C"/>
-                </a:solidFill>
-                <a:latin typeface="Arial"/>
-              </a:rPr>
-              <a:t/>
-            </a:r>
-            <a:r>
-              <a:rPr sz="1340" b="0" dirty="0">
-                <a:solidFill>
-                  <a:srgbClr val="2D343C"/>
-                </a:solidFill>
-                <a:latin typeface="Arial"/>
-              </a:rPr>
-              <a:t/>
-            </a:r>
-            <a:r>
-              <a:rPr sz="1340" b="0" dirty="0" err="1">
-                <a:solidFill>
-                  <a:srgbClr val="2D343C"/>
-                </a:solidFill>
-                <a:latin typeface="Arial"/>
-              </a:rPr>
-              <a:t/>
-            </a:r>
-            <a:r>
-              <a:rPr sz="1340" b="0" dirty="0">
-                <a:solidFill>
-                  <a:srgbClr val="2D343C"/>
-                </a:solidFill>
-                <a:latin typeface="Arial"/>
-              </a:rPr>
-              <a:t/>
-            </a:r>
-            <a:r>
-              <a:rPr sz="1340" b="0" dirty="0" err="1">
-                <a:solidFill>
-                  <a:srgbClr val="2D343C"/>
-                </a:solidFill>
-                <a:latin typeface="Arial"/>
-              </a:rPr>
-              <a:t/>
-            </a:r>
-            <a:r>
-              <a:rPr lang="es-ES" sz="1340" b="0" dirty="0">
-                <a:solidFill>
-                  <a:srgbClr val="2D343C"/>
-                </a:solidFill>
-                <a:latin typeface="Arial"/>
-              </a:rPr>
-              <a:t/>
-            </a:r>
-            <a:r>
-              <a:rPr lang="es-ES" sz="1340" b="0" dirty="0" err="1">
-                <a:solidFill>
-                  <a:srgbClr val="2D343C"/>
-                </a:solidFill>
-                <a:latin typeface="Arial"/>
-              </a:rPr>
-              <a:t/>
-            </a:r>
-            <a:r>
-              <a:rPr lang="es-ES" sz="1340" b="0" dirty="0">
-                <a:solidFill>
-                  <a:srgbClr val="2D343C"/>
-                </a:solidFill>
-                <a:latin typeface="Arial"/>
-              </a:rPr>
-              <a:t/>
-            </a:r>
-            <a:r>
-              <a:rPr lang="es-ES" sz="1340" b="0" dirty="0" err="1">
-                <a:solidFill>
-                  <a:srgbClr val="2D343C"/>
-                </a:solidFill>
-                <a:latin typeface="Arial"/>
-              </a:rPr>
-              <a:t/>
-            </a:r>
-            <a:r>
-              <a:rPr lang="es-ES" sz="1340" b="0" dirty="0">
-                <a:solidFill>
-                  <a:srgbClr val="2D343C"/>
-                </a:solidFill>
-                <a:latin typeface="Arial"/>
-              </a:rPr>
-              <a:t/>
-            </a:r>
             <a:endParaRPr sz="1340" b="0" dirty="0">
               <a:solidFill>
                 <a:srgbClr val="2D343C"/>
@@ -12091,50 +11774,8 @@
                 <a:latin typeface="Arial"/>
               </a:rPr>
               <a:t>
-</a:t>
-            </a:r>
-            <a:r>
-              <a:rPr sz="1340" b="0" dirty="0" err="1">
-                <a:solidFill>
-                  <a:srgbClr val="2D343C"/>
-                </a:solidFill>
-                <a:latin typeface="Arial"/>
-              </a:rPr>
-              <a:t>transferència</a:t>
-            </a:r>
-            <a:r>
-              <a:rPr sz="1340" b="0" dirty="0">
-                <a:solidFill>
-                  <a:srgbClr val="2D343C"/>
-                </a:solidFill>
-                <a:latin typeface="Arial"/>
-              </a:rPr>
-              <a:t> </a:t>
-            </a:r>
-            <a:r>
-              <a:rPr lang="es-ES" sz="1340" b="0" dirty="0" err="1">
-                <a:solidFill>
-                  <a:srgbClr val="2D343C"/>
-                </a:solidFill>
-                <a:latin typeface="Arial"/>
-              </a:rPr>
-              <a:t>universitat</a:t>
-            </a:r>
-            <a:r>
-              <a:rPr lang="es-ES" sz="1340" b="0" dirty="0">
-                <a:solidFill>
-                  <a:srgbClr val="2D343C"/>
-                </a:solidFill>
-                <a:latin typeface="Arial"/>
-              </a:rPr>
-              <a:t> i empresa</a:t>
-            </a:r>
-            <a:endParaRPr sz="1340" b="0" dirty="0">
-              <a:solidFill>
-                <a:srgbClr val="2D343C"/>
-              </a:solidFill>
-              <a:latin typeface="Arial"/>
-            </a:endParaRPr>
+transferència universitat-empresa</a:t>
+            </a:r>
           </a:p>
         </p:txBody>
       </p:sp>

</xml_diff>

<commit_message>
Soften AGAUR data-consultation wording for legal precision
Replace the categorical "la sol·licitud autoritza la consulta de
renda i patrimoni" phrasing with "d'acord amb la base jurídica
aplicable" in the diagram source, evidence doc, and functional-case
doc. Also include Alfredo's trajectory deck update.
</commit_message>
<xml_diff>
--- a/doc/presentations/defensa-placa-permanent-dsi-ports-sortida-hexagonal/output/defensa-trajectoria-10-minuts.pptx
+++ b/doc/presentations/defensa-placa-permanent-dsi-ports-sortida-hexagonal/output/defensa-trajectoria-10-minuts.pptx
@@ -112,6 +112,11 @@
       </a:defRPr>
     </a:lvl9pPr>
   </p:defaultTextStyle>
+  <p:extLst>
+    <p:ext uri="{EFAFB233-063F-42B5-8137-9DF3F51BA10A}">
+      <p15:sldGuideLst xmlns:p15="http://schemas.microsoft.com/office/powerpoint/2012/main"/>
+    </p:ext>
+  </p:extLst>
 </p:presentation>
 </file>
 
@@ -10976,7 +10981,7 @@
         </p:style>
         <p:txBody>
           <a:bodyPr lIns="90000" tIns="45000" rIns="90000" bIns="45000" anchor="t">
-            <a:normAutofit fontScale="85000" lnSpcReduction="9999"/>
+            <a:normAutofit fontScale="92500" lnSpcReduction="19999"/>
           </a:bodyPr>
           <a:lstStyle/>
           <a:p>
@@ -12315,7 +12320,7 @@
         </p:style>
         <p:txBody>
           <a:bodyPr lIns="90000" tIns="45000" rIns="90000" bIns="45000" anchor="t">
-            <a:normAutofit fontScale="85000" lnSpcReduction="9999"/>
+            <a:normAutofit fontScale="85000" lnSpcReduction="19999"/>
           </a:bodyPr>
           <a:lstStyle/>
           <a:p>
@@ -12747,7 +12752,7 @@
         </p:style>
         <p:txBody>
           <a:bodyPr wrap="none" lIns="90000" tIns="45000" rIns="90000" bIns="45000" anchor="t">
-            <a:normAutofit fontScale="85000" lnSpcReduction="9999"/>
+            <a:normAutofit fontScale="92500" lnSpcReduction="19999"/>
           </a:bodyPr>
           <a:lstStyle/>
           <a:p>
@@ -15094,8 +15099,8 @@
         </p:nvSpPr>
         <p:spPr>
           <a:xfrm>
-            <a:off x="7818120" y="2930760"/>
-            <a:ext cx="2102760" cy="914040"/>
+            <a:off x="7699320" y="2930760"/>
+            <a:ext cx="2391120" cy="1098315"/>
           </a:xfrm>
           <a:prstGeom prst="rect">
             <a:avLst/>
@@ -15123,8 +15128,12 @@
           </a:bodyPr>
           <a:lstStyle/>
           <a:p>
-            <a:r>
-              <a:rPr lang="es-ES" sz="1350" b="0" u="none" strike="noStrike" dirty="0">
+            <a:pPr marL="171450" indent="-171450">
+              <a:buFont typeface="Arial" panose="020B0604020202020204" pitchFamily="34" charset="0"/>
+              <a:buChar char="•"/>
+            </a:pPr>
+            <a:r>
+              <a:rPr lang="es-ES" sz="1200" b="0" u="none" strike="noStrike" dirty="0">
                 <a:solidFill>
                   <a:srgbClr val="2D343C"/>
                 </a:solidFill>
@@ -15135,7 +15144,7 @@
               <a:t>La Dra. Ester </a:t>
             </a:r>
             <a:r>
-              <a:rPr lang="es-ES" sz="1350" b="0" u="none" strike="noStrike" dirty="0" err="1">
+              <a:rPr lang="es-ES" sz="1200" b="0" u="none" strike="noStrike" dirty="0" err="1">
                 <a:solidFill>
                   <a:srgbClr val="2D343C"/>
                 </a:solidFill>
@@ -15146,7 +15155,7 @@
               <a:t>Bernadó</a:t>
             </a:r>
             <a:r>
-              <a:rPr lang="es-ES" sz="1350" b="0" u="none" strike="noStrike" dirty="0">
+              <a:rPr lang="es-ES" sz="1200" b="0" u="none" strike="noStrike" dirty="0">
                 <a:solidFill>
                   <a:srgbClr val="2D343C"/>
                 </a:solidFill>
@@ -15157,7 +15166,7 @@
               <a:t> va facilitar el contacte </a:t>
             </a:r>
             <a:r>
-              <a:rPr lang="es-ES" sz="1350" b="0" u="none" strike="noStrike" dirty="0" err="1">
+              <a:rPr lang="es-ES" sz="1200" b="0" u="none" strike="noStrike" dirty="0" err="1">
                 <a:solidFill>
                   <a:srgbClr val="2D343C"/>
                 </a:solidFill>
@@ -15167,7 +15176,7 @@
               </a:rPr>
               <a:t>acadèmic</a:t>
             </a:r>
-            <a:endParaRPr lang="es-ES" sz="1350" b="0" u="none" strike="noStrike" dirty="0">
+            <a:endParaRPr lang="es-ES" sz="1200" b="0" u="none" strike="noStrike" dirty="0">
               <a:solidFill>
                 <a:srgbClr val="000000"/>
               </a:solidFill>
@@ -15177,23 +15186,43 @@
             </a:endParaRPr>
           </a:p>
           <a:p>
-            <a:pPr marL="285750" indent="-285750">
+            <a:pPr marL="171450" indent="-171450">
               <a:buFont typeface="Arial" panose="020B0604020202020204" pitchFamily="34" charset="0"/>
               <a:buChar char="•"/>
             </a:pPr>
             <a:r>
-              <a:rPr lang="es-ES" sz="1350" b="0" u="none" strike="noStrike" dirty="0">
-                <a:solidFill>
-                  <a:srgbClr val="2D343C"/>
-                </a:solidFill>
-                <a:effectLst/>
-                <a:uFillTx/>
-                <a:latin typeface="Arial"/>
-              </a:rPr>
-              <a:t>software i </a:t>
-            </a:r>
-            <a:r>
-              <a:rPr lang="es-ES" sz="1350" b="0" u="none" strike="noStrike" dirty="0" err="1">
+              <a:rPr lang="es-ES" sz="1200" dirty="0" err="1">
+                <a:solidFill>
+                  <a:srgbClr val="2D343C"/>
+                </a:solidFill>
+                <a:latin typeface="Arial"/>
+              </a:rPr>
+              <a:t>e</a:t>
+            </a:r>
+            <a:r>
+              <a:rPr lang="es-ES" sz="1200" b="0" u="none" strike="noStrike" dirty="0" err="1">
+                <a:solidFill>
+                  <a:srgbClr val="2D343C"/>
+                </a:solidFill>
+                <a:effectLst/>
+                <a:uFillTx/>
+                <a:latin typeface="Arial"/>
+              </a:rPr>
+              <a:t>nginyeria</a:t>
+            </a:r>
+            <a:r>
+              <a:rPr lang="es-ES" sz="1200" b="0" u="none" strike="noStrike" dirty="0">
+                <a:solidFill>
+                  <a:srgbClr val="2D343C"/>
+                </a:solidFill>
+                <a:effectLst/>
+                <a:uFillTx/>
+                <a:latin typeface="Arial"/>
+              </a:rPr>
+              <a:t> del software i </a:t>
+            </a:r>
+            <a:r>
+              <a:rPr lang="es-ES" sz="1200" b="0" u="none" strike="noStrike" dirty="0" err="1">
                 <a:solidFill>
                   <a:srgbClr val="2D343C"/>
                 </a:solidFill>
@@ -15204,7 +15233,7 @@
               <a:t>sistemes</a:t>
             </a:r>
             <a:r>
-              <a:rPr lang="es-ES" sz="1350" b="0" u="none" strike="noStrike" dirty="0">
+              <a:rPr lang="es-ES" sz="1200" b="0" u="none" strike="noStrike" dirty="0">
                 <a:solidFill>
                   <a:srgbClr val="2D343C"/>
                 </a:solidFill>
@@ -15215,7 +15244,7 @@
               <a:t> </a:t>
             </a:r>
             <a:r>
-              <a:rPr lang="es-ES" sz="1350" b="0" u="none" strike="noStrike" dirty="0" err="1">
+              <a:rPr lang="es-ES" sz="1200" b="0" u="none" strike="noStrike" dirty="0" err="1">
                 <a:solidFill>
                   <a:srgbClr val="2D343C"/>
                 </a:solidFill>
@@ -15225,7 +15254,7 @@
               </a:rPr>
               <a:t>d’informació</a:t>
             </a:r>
-            <a:endParaRPr lang="es-ES" sz="1350" b="0" u="none" strike="noStrike" dirty="0">
+            <a:endParaRPr lang="es-ES" sz="1200" b="0" u="none" strike="noStrike" dirty="0">
               <a:solidFill>
                 <a:srgbClr val="000000"/>
               </a:solidFill>
@@ -15235,7 +15264,7 @@
             </a:endParaRPr>
           </a:p>
           <a:p>
-            <a:pPr marL="285750" indent="-285750" defTabSz="457200">
+            <a:pPr marL="171450" indent="-171450" defTabSz="457200">
               <a:lnSpc>
                 <a:spcPct val="100000"/>
               </a:lnSpc>
@@ -15243,7 +15272,7 @@
               <a:buChar char="•"/>
             </a:pPr>
             <a:r>
-              <a:rPr lang="es-ES" sz="1350" b="0" u="none" strike="noStrike" dirty="0" err="1">
+              <a:rPr lang="es-ES" sz="1200" b="0" u="none" strike="noStrike" dirty="0" err="1">
                 <a:solidFill>
                   <a:srgbClr val="2D343C"/>
                 </a:solidFill>
@@ -15254,7 +15283,7 @@
               <a:t>projecte</a:t>
             </a:r>
             <a:r>
-              <a:rPr lang="es-ES" sz="1350" b="0" u="none" strike="noStrike" dirty="0">
+              <a:rPr lang="es-ES" sz="1200" b="0" u="none" strike="noStrike" dirty="0">
                 <a:solidFill>
                   <a:srgbClr val="2D343C"/>
                 </a:solidFill>
@@ -15265,7 +15294,7 @@
               <a:t> </a:t>
             </a:r>
             <a:r>
-              <a:rPr lang="es-ES" sz="1350" b="0" u="none" strike="noStrike" dirty="0" err="1">
+              <a:rPr lang="es-ES" sz="1200" b="0" u="none" strike="noStrike" dirty="0" err="1">
                 <a:solidFill>
                   <a:srgbClr val="2D343C"/>
                 </a:solidFill>
@@ -15275,7 +15304,7 @@
               </a:rPr>
               <a:t>acadèmic</a:t>
             </a:r>
-            <a:endParaRPr lang="es-ES" sz="1350" b="0" u="none" strike="noStrike" dirty="0">
+            <a:endParaRPr lang="es-ES" sz="1200" b="0" u="none" strike="noStrike" dirty="0">
               <a:solidFill>
                 <a:srgbClr val="000000"/>
               </a:solidFill>
@@ -15829,7 +15858,7 @@
         </p:style>
         <p:txBody>
           <a:bodyPr lIns="90000" tIns="45000" rIns="90000" bIns="45000" anchor="t">
-            <a:normAutofit fontScale="85000" lnSpcReduction="9999"/>
+            <a:normAutofit fontScale="92500" lnSpcReduction="19999"/>
           </a:bodyPr>
           <a:lstStyle/>
           <a:p>
@@ -15890,7 +15919,7 @@
         <p:spPr>
           <a:xfrm>
             <a:off x="1024200" y="3401640"/>
-            <a:ext cx="2514240" cy="1840217"/>
+            <a:ext cx="2514240" cy="1636700"/>
           </a:xfrm>
           <a:prstGeom prst="rect">
             <a:avLst/>
@@ -16052,6 +16081,28 @@
                 <a:uFillTx/>
                 <a:latin typeface="Arial"/>
               </a:rPr>
+              <a:t>laboratori</a:t>
+            </a:r>
+            <a:r>
+              <a:rPr lang="en-US" sz="1180" b="0" u="none" strike="noStrike" dirty="0">
+                <a:solidFill>
+                  <a:srgbClr val="2D343C"/>
+                </a:solidFill>
+                <a:effectLst/>
+                <a:uFillTx/>
+                <a:latin typeface="Arial"/>
+              </a:rPr>
+              <a:t> </a:t>
+            </a:r>
+            <a:r>
+              <a:rPr lang="en-US" sz="1180" b="0" u="none" strike="noStrike" dirty="0" err="1">
+                <a:solidFill>
+                  <a:srgbClr val="2D343C"/>
+                </a:solidFill>
+                <a:effectLst/>
+                <a:uFillTx/>
+                <a:latin typeface="Arial"/>
+              </a:rPr>
               <a:t>aplicacions</a:t>
             </a:r>
             <a:r>
@@ -16075,57 +16126,6 @@
                 <a:latin typeface="Arial"/>
               </a:rPr>
               <a:t>d’Internet</a:t>
-            </a:r>
-            <a:endParaRPr lang="es-ES" sz="1180" b="0" u="none" strike="noStrike" dirty="0">
-              <a:solidFill>
-                <a:srgbClr val="000000"/>
-              </a:solidFill>
-              <a:effectLst/>
-              <a:uFillTx/>
-              <a:latin typeface="Arial"/>
-            </a:endParaRPr>
-          </a:p>
-          <a:p>
-            <a:pPr defTabSz="457200">
-              <a:lnSpc>
-                <a:spcPct val="105000"/>
-              </a:lnSpc>
-              <a:spcAft>
-                <a:spcPts val="119"/>
-              </a:spcAft>
-            </a:pPr>
-            <a:r>
-              <a:rPr lang="en-US" sz="1180" b="0" u="none" strike="noStrike" dirty="0">
-                <a:solidFill>
-                  <a:srgbClr val="2D343C"/>
-                </a:solidFill>
-                <a:effectLst/>
-                <a:uFillTx/>
-                <a:latin typeface="Arial"/>
-              </a:rPr>
-              <a:t>• </a:t>
-            </a:r>
-            <a:r>
-              <a:rPr lang="en-US" sz="1180" b="0" u="none" strike="noStrike" dirty="0" err="1">
-                <a:solidFill>
-                  <a:srgbClr val="2D343C"/>
-                </a:solidFill>
-                <a:effectLst/>
-                <a:uFillTx/>
-                <a:latin typeface="Arial"/>
-              </a:rPr>
-              <a:t>enginyeria</a:t>
-            </a:r>
-            <a:r>
-              <a:rPr lang="en-US" sz="1180" b="0" u="none" strike="noStrike" dirty="0">
-                <a:solidFill>
-                  <a:srgbClr val="2D343C"/>
-                </a:solidFill>
-                <a:effectLst/>
-                <a:uFillTx/>
-                <a:latin typeface="Arial"/>
-              </a:rPr>
-              <a:t> del software</a:t>
             </a:r>
             <a:endParaRPr lang="es-ES" sz="1180" b="0" u="none" strike="noStrike" dirty="0">
               <a:solidFill>
@@ -16548,7 +16548,7 @@
         </p:style>
         <p:txBody>
           <a:bodyPr lIns="90000" tIns="45000" rIns="90000" bIns="45000" anchor="t">
-            <a:normAutofit fontScale="85000" lnSpcReduction="9999"/>
+            <a:normAutofit fontScale="92500" lnSpcReduction="19999"/>
           </a:bodyPr>
           <a:lstStyle/>
           <a:p>
@@ -17201,7 +17201,7 @@
               </a:lnSpc>
             </a:pPr>
             <a:r>
-              <a:rPr lang="en-US" sz="1200" b="1" u="none" strike="noStrike">
+              <a:rPr lang="en-US" sz="1200" b="1" u="none" strike="noStrike" dirty="0">
                 <a:solidFill>
                   <a:srgbClr val="2A5C84"/>
                 </a:solidFill>
@@ -17211,7 +17211,7 @@
               </a:rPr>
               <a:t>SQAI</a:t>
             </a:r>
-            <a:endParaRPr lang="es-ES" sz="1200" b="0" u="none" strike="noStrike">
+            <a:endParaRPr lang="es-ES" sz="1200" b="0" u="none" strike="noStrike" dirty="0">
               <a:solidFill>
                 <a:srgbClr val="000000"/>
               </a:solidFill>
@@ -17331,7 +17331,7 @@
         </p:style>
         <p:txBody>
           <a:bodyPr lIns="90000" tIns="45000" rIns="90000" bIns="45000" anchor="t">
-            <a:normAutofit fontScale="85000" lnSpcReduction="9999"/>
+            <a:normAutofit fontScale="85000" lnSpcReduction="19999"/>
           </a:bodyPr>
           <a:lstStyle/>
           <a:p>
@@ -17395,7 +17395,7 @@
         </p:style>
         <p:txBody>
           <a:bodyPr lIns="90000" tIns="45000" rIns="90000" bIns="45000" anchor="t">
-            <a:normAutofit fontScale="77500" lnSpcReduction="19999"/>
+            <a:normAutofit fontScale="85000" lnSpcReduction="9999"/>
           </a:bodyPr>
           <a:lstStyle/>
           <a:p>
@@ -17969,7 +17969,7 @@
         </p:style>
         <p:txBody>
           <a:bodyPr lIns="90000" tIns="45000" rIns="90000" bIns="45000" anchor="t">
-            <a:normAutofit fontScale="85000" lnSpcReduction="9999"/>
+            <a:normAutofit fontScale="92500" lnSpcReduction="19999"/>
           </a:bodyPr>
           <a:lstStyle/>
           <a:p>
@@ -18352,7 +18352,7 @@
         </p:style>
         <p:txBody>
           <a:bodyPr lIns="90000" tIns="45000" rIns="90000" bIns="45000" anchor="t">
-            <a:normAutofit fontScale="85000" lnSpcReduction="9999"/>
+            <a:normAutofit fontScale="92500" lnSpcReduction="19999"/>
           </a:bodyPr>
           <a:lstStyle/>
           <a:p>
@@ -18699,7 +18699,7 @@
         </p:style>
         <p:txBody>
           <a:bodyPr lIns="90000" tIns="45000" rIns="90000" bIns="45000" anchor="t">
-            <a:normAutofit fontScale="85000" lnSpcReduction="9999"/>
+            <a:normAutofit fontScale="92500" lnSpcReduction="19999"/>
           </a:bodyPr>
           <a:lstStyle/>
           <a:p>
@@ -18738,8 +18738,8 @@
         </p:nvSpPr>
         <p:spPr>
           <a:xfrm>
-            <a:off x="8028360" y="2395800"/>
-            <a:ext cx="2285640" cy="959760"/>
+            <a:off x="8028359" y="2395799"/>
+            <a:ext cx="2325316" cy="1671375"/>
           </a:xfrm>
           <a:prstGeom prst="rect">
             <a:avLst/>
@@ -18839,6 +18839,28 @@
                 <a:latin typeface="Arial"/>
               </a:rPr>
               <a:t> </a:t>
+            </a:r>
+            <a:r>
+              <a:rPr lang="es-ES" sz="1340" b="0" u="none" strike="noStrike" dirty="0" err="1">
+                <a:solidFill>
+                  <a:srgbClr val="2D343C"/>
+                </a:solidFill>
+                <a:effectLst/>
+                <a:uFillTx/>
+                <a:latin typeface="Arial"/>
+              </a:rPr>
+              <a:t>educació</a:t>
+            </a:r>
+            <a:r>
+              <a:rPr lang="es-ES" sz="1340" b="0" u="none" strike="noStrike" dirty="0">
+                <a:solidFill>
+                  <a:srgbClr val="2D343C"/>
+                </a:solidFill>
+                <a:effectLst/>
+                <a:uFillTx/>
+                <a:latin typeface="Arial"/>
+              </a:rPr>
+              <a:t> en </a:t>
             </a:r>
             <a:r>
               <a:rPr lang="es-ES" sz="1340" b="0" u="none" strike="noStrike" dirty="0" err="1">

</xml_diff>

<commit_message>
Despersonalitza la transició de La Salle al TecnoCampus
Substitueix la menció a una persona concreta per un argument
d'encaix curricular verificable: fonaments a La Salle (orientació
a objectes i aplicacions mòbils) com a llavor, i el grau de gestió
i sistemes d'informació del TecnoCampus com a espai natural de
creixement de l'especialització pròpia. Actualitza guió, notes,
taula de memorització, diapositiva 4 i registre de decisions.

Co-Authored-By: Claude Fable 5 <noreply@anthropic.com>
</commit_message>
<xml_diff>
--- a/doc/presentations/defensa-placa-permanent-dsi-ports-sortida-hexagonal/output/defensa-trajectoria-10-minuts.pptx
+++ b/doc/presentations/defensa-placa-permanent-dsi-ports-sortida-hexagonal/output/defensa-trajectoria-10-minuts.pptx
@@ -1366,7 +1366,7 @@
                 <a:uFillTx/>
                 <a:latin typeface="Arial"/>
               </a:rPr>
-              <a:t>La Dra. Ester Bernadó va facilitar el contacte acadèmic amb el TecnoCampus.</a:t>
+              <a:t>Encaix curricular: el grau porta la gestió i els sistemes d’informació al seu propi nom. No esmentar persones concretes.</a:t>
             </a:r>
           </a:p>
           <a:p>
@@ -15141,40 +15141,7 @@
                 <a:uFillTx/>
                 <a:latin typeface="Arial"/>
               </a:rPr>
-              <a:t>La Dra. Ester </a:t>
-            </a:r>
-            <a:r>
-              <a:rPr lang="es-ES" sz="1200" b="0" u="none" strike="noStrike" dirty="0" err="1">
-                <a:solidFill>
-                  <a:srgbClr val="2D343C"/>
-                </a:solidFill>
-                <a:effectLst/>
-                <a:uFillTx/>
-                <a:latin typeface="Arial"/>
-              </a:rPr>
-              <a:t>Bernadó</a:t>
-            </a:r>
-            <a:r>
-              <a:rPr lang="es-ES" sz="1200" b="0" u="none" strike="noStrike" dirty="0">
-                <a:solidFill>
-                  <a:srgbClr val="2D343C"/>
-                </a:solidFill>
-                <a:effectLst/>
-                <a:uFillTx/>
-                <a:latin typeface="Arial"/>
-              </a:rPr>
-              <a:t> va facilitar el contacte </a:t>
-            </a:r>
-            <a:r>
-              <a:rPr lang="es-ES" sz="1200" b="0" u="none" strike="noStrike" dirty="0" err="1">
-                <a:solidFill>
-                  <a:srgbClr val="2D343C"/>
-                </a:solidFill>
-                <a:effectLst/>
-                <a:uFillTx/>
-                <a:latin typeface="Arial"/>
-              </a:rPr>
-              <a:t>acadèmic</a:t>
+              <a:t>grau orientat a gestió i sistemes d’informació</a:t>
             </a:r>
             <a:endParaRPr lang="es-ES" sz="1200" b="0" u="none" strike="noStrike" dirty="0">
               <a:solidFill>

</xml_diff>

<commit_message>
Afina la diapositiva 4 amb els fonaments impartits a La Salle
Ajustos manuals: la columna de La Salle concreta programació OO,
Android i Projecte Sallefy / ABP, i la columna del TecnoCampus
precisa enginyeria del software i disseny de sistemes d'informació.

Co-Authored-By: Claude Fable 5 <noreply@anthropic.com>
</commit_message>
<xml_diff>
--- a/doc/presentations/defensa-placa-permanent-dsi-ports-sortida-hexagonal/output/defensa-trajectoria-10-minuts.pptx
+++ b/doc/presentations/defensa-placa-permanent-dsi-ports-sortida-hexagonal/output/defensa-trajectoria-10-minuts.pptx
@@ -1282,7 +1282,7 @@
               <a:buNone/>
             </a:pPr>
             <a:r>
-              <a:rPr lang="es-ES" sz="2000" b="0" u="none" strike="noStrike">
+              <a:rPr lang="es-ES" sz="2000" b="0" u="none" strike="noStrike" dirty="0">
                 <a:solidFill>
                   <a:srgbClr val="000000"/>
                 </a:solidFill>
@@ -1290,7 +1290,73 @@
                 <a:uFillTx/>
                 <a:latin typeface="Arial"/>
               </a:rPr>
-              <a:t>La Salle: etapa universitària exigent i valuosa.</a:t>
+              <a:t>La Salle: etapa </a:t>
+            </a:r>
+            <a:r>
+              <a:rPr lang="es-ES" sz="2000" b="0" u="none" strike="noStrike" dirty="0" err="1">
+                <a:solidFill>
+                  <a:srgbClr val="000000"/>
+                </a:solidFill>
+                <a:effectLst/>
+                <a:uFillTx/>
+                <a:latin typeface="Arial"/>
+              </a:rPr>
+              <a:t>universitària</a:t>
+            </a:r>
+            <a:r>
+              <a:rPr lang="es-ES" sz="2000" b="0" u="none" strike="noStrike" dirty="0">
+                <a:solidFill>
+                  <a:srgbClr val="000000"/>
+                </a:solidFill>
+                <a:effectLst/>
+                <a:uFillTx/>
+                <a:latin typeface="Arial"/>
+              </a:rPr>
+              <a:t> </a:t>
+            </a:r>
+            <a:r>
+              <a:rPr lang="es-ES" sz="2000" b="0" u="none" strike="noStrike" dirty="0" err="1">
+                <a:solidFill>
+                  <a:srgbClr val="000000"/>
+                </a:solidFill>
+                <a:effectLst/>
+                <a:uFillTx/>
+                <a:latin typeface="Arial"/>
+              </a:rPr>
+              <a:t>exigent</a:t>
+            </a:r>
+            <a:r>
+              <a:rPr lang="es-ES" sz="2000" b="0" u="none" strike="noStrike" dirty="0">
+                <a:solidFill>
+                  <a:srgbClr val="000000"/>
+                </a:solidFill>
+                <a:effectLst/>
+                <a:uFillTx/>
+                <a:latin typeface="Arial"/>
+              </a:rPr>
+              <a:t> i </a:t>
+            </a:r>
+            <a:r>
+              <a:rPr lang="es-ES" sz="2000" b="0" u="none" strike="noStrike" dirty="0" err="1">
+                <a:solidFill>
+                  <a:srgbClr val="000000"/>
+                </a:solidFill>
+                <a:effectLst/>
+                <a:uFillTx/>
+                <a:latin typeface="Arial"/>
+              </a:rPr>
+              <a:t>valuosa</a:t>
+            </a:r>
+            <a:r>
+              <a:rPr lang="es-ES" sz="2000" b="0" u="none" strike="noStrike" dirty="0">
+                <a:solidFill>
+                  <a:srgbClr val="000000"/>
+                </a:solidFill>
+                <a:effectLst/>
+                <a:uFillTx/>
+                <a:latin typeface="Arial"/>
+              </a:rPr>
+              <a:t>.</a:t>
             </a:r>
           </a:p>
           <a:p>
@@ -1301,7 +1367,7 @@
               <a:buNone/>
             </a:pPr>
             <a:r>
-              <a:rPr lang="es-ES" sz="2000" b="0" u="none" strike="noStrike">
+              <a:rPr lang="es-ES" sz="2000" b="0" u="none" strike="noStrike" dirty="0">
                 <a:solidFill>
                   <a:srgbClr val="000000"/>
                 </a:solidFill>
@@ -1309,7 +1375,73 @@
                 <a:uFillTx/>
                 <a:latin typeface="Arial"/>
               </a:rPr>
-              <a:t>Evitar comparacions jeràrquiques entre institucions.</a:t>
+              <a:t>Evitar </a:t>
+            </a:r>
+            <a:r>
+              <a:rPr lang="es-ES" sz="2000" b="0" u="none" strike="noStrike" dirty="0" err="1">
+                <a:solidFill>
+                  <a:srgbClr val="000000"/>
+                </a:solidFill>
+                <a:effectLst/>
+                <a:uFillTx/>
+                <a:latin typeface="Arial"/>
+              </a:rPr>
+              <a:t>comparacions</a:t>
+            </a:r>
+            <a:r>
+              <a:rPr lang="es-ES" sz="2000" b="0" u="none" strike="noStrike" dirty="0">
+                <a:solidFill>
+                  <a:srgbClr val="000000"/>
+                </a:solidFill>
+                <a:effectLst/>
+                <a:uFillTx/>
+                <a:latin typeface="Arial"/>
+              </a:rPr>
+              <a:t> </a:t>
+            </a:r>
+            <a:r>
+              <a:rPr lang="es-ES" sz="2000" b="0" u="none" strike="noStrike" dirty="0" err="1">
+                <a:solidFill>
+                  <a:srgbClr val="000000"/>
+                </a:solidFill>
+                <a:effectLst/>
+                <a:uFillTx/>
+                <a:latin typeface="Arial"/>
+              </a:rPr>
+              <a:t>jeràrquiques</a:t>
+            </a:r>
+            <a:r>
+              <a:rPr lang="es-ES" sz="2000" b="0" u="none" strike="noStrike" dirty="0">
+                <a:solidFill>
+                  <a:srgbClr val="000000"/>
+                </a:solidFill>
+                <a:effectLst/>
+                <a:uFillTx/>
+                <a:latin typeface="Arial"/>
+              </a:rPr>
+              <a:t> entre </a:t>
+            </a:r>
+            <a:r>
+              <a:rPr lang="es-ES" sz="2000" b="0" u="none" strike="noStrike" dirty="0" err="1">
+                <a:solidFill>
+                  <a:srgbClr val="000000"/>
+                </a:solidFill>
+                <a:effectLst/>
+                <a:uFillTx/>
+                <a:latin typeface="Arial"/>
+              </a:rPr>
+              <a:t>institucions</a:t>
+            </a:r>
+            <a:r>
+              <a:rPr lang="es-ES" sz="2000" b="0" u="none" strike="noStrike" dirty="0">
+                <a:solidFill>
+                  <a:srgbClr val="000000"/>
+                </a:solidFill>
+                <a:effectLst/>
+                <a:uFillTx/>
+                <a:latin typeface="Arial"/>
+              </a:rPr>
+              <a:t>.</a:t>
             </a:r>
           </a:p>
           <a:p>
@@ -1320,7 +1452,7 @@
               <a:buNone/>
             </a:pPr>
             <a:r>
-              <a:rPr lang="es-ES" sz="2000" b="0" u="none" strike="noStrike">
+              <a:rPr lang="es-ES" sz="2000" b="0" u="none" strike="noStrike" dirty="0" err="1">
                 <a:solidFill>
                   <a:srgbClr val="000000"/>
                 </a:solidFill>
@@ -1328,7 +1460,150 @@
                 <a:uFillTx/>
                 <a:latin typeface="Arial"/>
               </a:rPr>
-              <a:t>Motiu principal: alineació acadèmica amb enginyeria del software i sistemes d’informació.</a:t>
+              <a:t>Motiu</a:t>
+            </a:r>
+            <a:r>
+              <a:rPr lang="es-ES" sz="2000" b="0" u="none" strike="noStrike" dirty="0">
+                <a:solidFill>
+                  <a:srgbClr val="000000"/>
+                </a:solidFill>
+                <a:effectLst/>
+                <a:uFillTx/>
+                <a:latin typeface="Arial"/>
+              </a:rPr>
+              <a:t> principal: </a:t>
+            </a:r>
+            <a:r>
+              <a:rPr lang="es-ES" sz="2000" b="0" u="none" strike="noStrike" dirty="0" err="1">
+                <a:solidFill>
+                  <a:srgbClr val="000000"/>
+                </a:solidFill>
+                <a:effectLst/>
+                <a:uFillTx/>
+                <a:latin typeface="Arial"/>
+              </a:rPr>
+              <a:t>alineació</a:t>
+            </a:r>
+            <a:r>
+              <a:rPr lang="es-ES" sz="2000" b="0" u="none" strike="noStrike" dirty="0">
+                <a:solidFill>
+                  <a:srgbClr val="000000"/>
+                </a:solidFill>
+                <a:effectLst/>
+                <a:uFillTx/>
+                <a:latin typeface="Arial"/>
+              </a:rPr>
+              <a:t> </a:t>
+            </a:r>
+            <a:r>
+              <a:rPr lang="es-ES" sz="2000" b="0" u="none" strike="noStrike" dirty="0" err="1">
+                <a:solidFill>
+                  <a:srgbClr val="000000"/>
+                </a:solidFill>
+                <a:effectLst/>
+                <a:uFillTx/>
+                <a:latin typeface="Arial"/>
+              </a:rPr>
+              <a:t>acadèmica</a:t>
+            </a:r>
+            <a:r>
+              <a:rPr lang="es-ES" sz="2000" b="0" u="none" strike="noStrike" dirty="0">
+                <a:solidFill>
+                  <a:srgbClr val="000000"/>
+                </a:solidFill>
+                <a:effectLst/>
+                <a:uFillTx/>
+                <a:latin typeface="Arial"/>
+              </a:rPr>
+              <a:t> </a:t>
+            </a:r>
+            <a:r>
+              <a:rPr lang="es-ES" sz="2000" b="0" u="none" strike="noStrike" dirty="0" err="1">
+                <a:solidFill>
+                  <a:srgbClr val="000000"/>
+                </a:solidFill>
+                <a:effectLst/>
+                <a:uFillTx/>
+                <a:latin typeface="Arial"/>
+              </a:rPr>
+              <a:t>amb</a:t>
+            </a:r>
+            <a:r>
+              <a:rPr lang="es-ES" sz="2000" b="0" u="none" strike="noStrike" dirty="0">
+                <a:solidFill>
+                  <a:srgbClr val="000000"/>
+                </a:solidFill>
+                <a:effectLst/>
+                <a:uFillTx/>
+                <a:latin typeface="Arial"/>
+              </a:rPr>
+              <a:t> </a:t>
+            </a:r>
+            <a:r>
+              <a:rPr lang="es-ES" sz="2000" b="0" u="none" strike="noStrike" dirty="0" err="1">
+                <a:solidFill>
+                  <a:srgbClr val="000000"/>
+                </a:solidFill>
+                <a:effectLst/>
+                <a:uFillTx/>
+                <a:latin typeface="Arial"/>
+              </a:rPr>
+              <a:t>enginyeria</a:t>
+            </a:r>
+            <a:r>
+              <a:rPr lang="es-ES" sz="2000" b="0" u="none" strike="noStrike" dirty="0">
+                <a:solidFill>
+                  <a:srgbClr val="000000"/>
+                </a:solidFill>
+                <a:effectLst/>
+                <a:uFillTx/>
+                <a:latin typeface="Arial"/>
+              </a:rPr>
+              <a:t> del software i </a:t>
+            </a:r>
+            <a:r>
+              <a:rPr lang="es-ES" sz="2000" b="0" u="none" strike="noStrike" dirty="0" err="1">
+                <a:solidFill>
+                  <a:srgbClr val="000000"/>
+                </a:solidFill>
+                <a:effectLst/>
+                <a:uFillTx/>
+                <a:latin typeface="Arial"/>
+              </a:rPr>
+              <a:t>sistemes</a:t>
+            </a:r>
+            <a:r>
+              <a:rPr lang="es-ES" sz="2000" b="0" u="none" strike="noStrike" dirty="0">
+                <a:solidFill>
+                  <a:srgbClr val="000000"/>
+                </a:solidFill>
+                <a:effectLst/>
+                <a:uFillTx/>
+                <a:latin typeface="Arial"/>
+              </a:rPr>
+              <a:t> </a:t>
+            </a:r>
+            <a:r>
+              <a:rPr lang="es-ES" sz="2000" b="0" u="none" strike="noStrike" dirty="0" err="1">
+                <a:solidFill>
+                  <a:srgbClr val="000000"/>
+                </a:solidFill>
+                <a:effectLst/>
+                <a:uFillTx/>
+                <a:latin typeface="Arial"/>
+              </a:rPr>
+              <a:t>d’informació</a:t>
+            </a:r>
+            <a:r>
+              <a:rPr lang="es-ES" sz="2000" b="0" u="none" strike="noStrike" dirty="0">
+                <a:solidFill>
+                  <a:srgbClr val="000000"/>
+                </a:solidFill>
+                <a:effectLst/>
+                <a:uFillTx/>
+                <a:latin typeface="Arial"/>
+              </a:rPr>
+              <a:t>.</a:t>
             </a:r>
           </a:p>
           <a:p>
@@ -1339,7 +1614,7 @@
               <a:buNone/>
             </a:pPr>
             <a:r>
-              <a:rPr lang="es-ES" sz="2000" b="0" u="none" strike="noStrike">
+              <a:rPr lang="es-ES" sz="2000" b="0" u="none" strike="noStrike" dirty="0" err="1">
                 <a:solidFill>
                   <a:srgbClr val="000000"/>
                 </a:solidFill>
@@ -1347,7 +1622,84 @@
                 <a:uFillTx/>
                 <a:latin typeface="Arial"/>
               </a:rPr>
-              <a:t>Conciliació com a factor complementari de sostenibilitat.</a:t>
+              <a:t>Conciliació</a:t>
+            </a:r>
+            <a:r>
+              <a:rPr lang="es-ES" sz="2000" b="0" u="none" strike="noStrike" dirty="0">
+                <a:solidFill>
+                  <a:srgbClr val="000000"/>
+                </a:solidFill>
+                <a:effectLst/>
+                <a:uFillTx/>
+                <a:latin typeface="Arial"/>
+              </a:rPr>
+              <a:t> </a:t>
+            </a:r>
+            <a:r>
+              <a:rPr lang="es-ES" sz="2000" b="0" u="none" strike="noStrike" dirty="0" err="1">
+                <a:solidFill>
+                  <a:srgbClr val="000000"/>
+                </a:solidFill>
+                <a:effectLst/>
+                <a:uFillTx/>
+                <a:latin typeface="Arial"/>
+              </a:rPr>
+              <a:t>com</a:t>
+            </a:r>
+            <a:r>
+              <a:rPr lang="es-ES" sz="2000" b="0" u="none" strike="noStrike" dirty="0">
+                <a:solidFill>
+                  <a:srgbClr val="000000"/>
+                </a:solidFill>
+                <a:effectLst/>
+                <a:uFillTx/>
+                <a:latin typeface="Arial"/>
+              </a:rPr>
+              <a:t> a factor </a:t>
+            </a:r>
+            <a:r>
+              <a:rPr lang="es-ES" sz="2000" b="0" u="none" strike="noStrike" dirty="0" err="1">
+                <a:solidFill>
+                  <a:srgbClr val="000000"/>
+                </a:solidFill>
+                <a:effectLst/>
+                <a:uFillTx/>
+                <a:latin typeface="Arial"/>
+              </a:rPr>
+              <a:t>complementari</a:t>
+            </a:r>
+            <a:r>
+              <a:rPr lang="es-ES" sz="2000" b="0" u="none" strike="noStrike" dirty="0">
+                <a:solidFill>
+                  <a:srgbClr val="000000"/>
+                </a:solidFill>
+                <a:effectLst/>
+                <a:uFillTx/>
+                <a:latin typeface="Arial"/>
+              </a:rPr>
+              <a:t> de </a:t>
+            </a:r>
+            <a:r>
+              <a:rPr lang="es-ES" sz="2000" b="0" u="none" strike="noStrike" dirty="0" err="1">
+                <a:solidFill>
+                  <a:srgbClr val="000000"/>
+                </a:solidFill>
+                <a:effectLst/>
+                <a:uFillTx/>
+                <a:latin typeface="Arial"/>
+              </a:rPr>
+              <a:t>sostenibilitat</a:t>
+            </a:r>
+            <a:r>
+              <a:rPr lang="es-ES" sz="2000" b="0" u="none" strike="noStrike" dirty="0">
+                <a:solidFill>
+                  <a:srgbClr val="000000"/>
+                </a:solidFill>
+                <a:effectLst/>
+                <a:uFillTx/>
+                <a:latin typeface="Arial"/>
+              </a:rPr>
+              <a:t>.</a:t>
             </a:r>
           </a:p>
           <a:p>
@@ -1358,7 +1710,7 @@
               <a:buNone/>
             </a:pPr>
             <a:r>
-              <a:rPr lang="es-ES" sz="2000" b="0" u="none" strike="noStrike">
+              <a:rPr lang="es-ES" sz="2000" b="0" u="none" strike="noStrike" dirty="0" err="1">
                 <a:solidFill>
                   <a:srgbClr val="000000"/>
                 </a:solidFill>
@@ -1366,7 +1718,194 @@
                 <a:uFillTx/>
                 <a:latin typeface="Arial"/>
               </a:rPr>
-              <a:t>Encaix curricular: el grau porta la gestió i els sistemes d’informació al seu propi nom. No esmentar persones concretes.</a:t>
+              <a:t>Encaix</a:t>
+            </a:r>
+            <a:r>
+              <a:rPr lang="es-ES" sz="2000" b="0" u="none" strike="noStrike" dirty="0">
+                <a:solidFill>
+                  <a:srgbClr val="000000"/>
+                </a:solidFill>
+                <a:effectLst/>
+                <a:uFillTx/>
+                <a:latin typeface="Arial"/>
+              </a:rPr>
+              <a:t> curricular: el </a:t>
+            </a:r>
+            <a:r>
+              <a:rPr lang="es-ES" sz="2000" b="0" u="none" strike="noStrike" dirty="0" err="1">
+                <a:solidFill>
+                  <a:srgbClr val="000000"/>
+                </a:solidFill>
+                <a:effectLst/>
+                <a:uFillTx/>
+                <a:latin typeface="Arial"/>
+              </a:rPr>
+              <a:t>grau</a:t>
+            </a:r>
+            <a:r>
+              <a:rPr lang="es-ES" sz="2000" b="0" u="none" strike="noStrike" dirty="0">
+                <a:solidFill>
+                  <a:srgbClr val="000000"/>
+                </a:solidFill>
+                <a:effectLst/>
+                <a:uFillTx/>
+                <a:latin typeface="Arial"/>
+              </a:rPr>
+              <a:t> porta la </a:t>
+            </a:r>
+            <a:r>
+              <a:rPr lang="es-ES" sz="2000" b="0" u="none" strike="noStrike" dirty="0" err="1">
+                <a:solidFill>
+                  <a:srgbClr val="000000"/>
+                </a:solidFill>
+                <a:effectLst/>
+                <a:uFillTx/>
+                <a:latin typeface="Arial"/>
+              </a:rPr>
+              <a:t>gestió</a:t>
+            </a:r>
+            <a:r>
+              <a:rPr lang="es-ES" sz="2000" b="0" u="none" strike="noStrike" dirty="0">
+                <a:solidFill>
+                  <a:srgbClr val="000000"/>
+                </a:solidFill>
+                <a:effectLst/>
+                <a:uFillTx/>
+                <a:latin typeface="Arial"/>
+              </a:rPr>
+              <a:t> i </a:t>
+            </a:r>
+            <a:r>
+              <a:rPr lang="es-ES" sz="2000" b="0" u="none" strike="noStrike" dirty="0" err="1">
+                <a:solidFill>
+                  <a:srgbClr val="000000"/>
+                </a:solidFill>
+                <a:effectLst/>
+                <a:uFillTx/>
+                <a:latin typeface="Arial"/>
+              </a:rPr>
+              <a:t>els</a:t>
+            </a:r>
+            <a:r>
+              <a:rPr lang="es-ES" sz="2000" b="0" u="none" strike="noStrike" dirty="0">
+                <a:solidFill>
+                  <a:srgbClr val="000000"/>
+                </a:solidFill>
+                <a:effectLst/>
+                <a:uFillTx/>
+                <a:latin typeface="Arial"/>
+              </a:rPr>
+              <a:t> </a:t>
+            </a:r>
+            <a:r>
+              <a:rPr lang="es-ES" sz="2000" b="0" u="none" strike="noStrike" dirty="0" err="1">
+                <a:solidFill>
+                  <a:srgbClr val="000000"/>
+                </a:solidFill>
+                <a:effectLst/>
+                <a:uFillTx/>
+                <a:latin typeface="Arial"/>
+              </a:rPr>
+              <a:t>sistemes</a:t>
+            </a:r>
+            <a:r>
+              <a:rPr lang="es-ES" sz="2000" b="0" u="none" strike="noStrike" dirty="0">
+                <a:solidFill>
+                  <a:srgbClr val="000000"/>
+                </a:solidFill>
+                <a:effectLst/>
+                <a:uFillTx/>
+                <a:latin typeface="Arial"/>
+              </a:rPr>
+              <a:t> </a:t>
+            </a:r>
+            <a:r>
+              <a:rPr lang="es-ES" sz="2000" b="0" u="none" strike="noStrike" dirty="0" err="1">
+                <a:solidFill>
+                  <a:srgbClr val="000000"/>
+                </a:solidFill>
+                <a:effectLst/>
+                <a:uFillTx/>
+                <a:latin typeface="Arial"/>
+              </a:rPr>
+              <a:t>d’informació</a:t>
+            </a:r>
+            <a:r>
+              <a:rPr lang="es-ES" sz="2000" b="0" u="none" strike="noStrike" dirty="0">
+                <a:solidFill>
+                  <a:srgbClr val="000000"/>
+                </a:solidFill>
+                <a:effectLst/>
+                <a:uFillTx/>
+                <a:latin typeface="Arial"/>
+              </a:rPr>
+              <a:t> al </a:t>
+            </a:r>
+            <a:r>
+              <a:rPr lang="es-ES" sz="2000" b="0" u="none" strike="noStrike" dirty="0" err="1">
+                <a:solidFill>
+                  <a:srgbClr val="000000"/>
+                </a:solidFill>
+                <a:effectLst/>
+                <a:uFillTx/>
+                <a:latin typeface="Arial"/>
+              </a:rPr>
+              <a:t>seu</a:t>
+            </a:r>
+            <a:r>
+              <a:rPr lang="es-ES" sz="2000" b="0" u="none" strike="noStrike" dirty="0">
+                <a:solidFill>
+                  <a:srgbClr val="000000"/>
+                </a:solidFill>
+                <a:effectLst/>
+                <a:uFillTx/>
+                <a:latin typeface="Arial"/>
+              </a:rPr>
+              <a:t> propi </a:t>
+            </a:r>
+            <a:r>
+              <a:rPr lang="es-ES" sz="2000" b="0" u="none" strike="noStrike" dirty="0" err="1">
+                <a:solidFill>
+                  <a:srgbClr val="000000"/>
+                </a:solidFill>
+                <a:effectLst/>
+                <a:uFillTx/>
+                <a:latin typeface="Arial"/>
+              </a:rPr>
+              <a:t>nom</a:t>
+            </a:r>
+            <a:r>
+              <a:rPr lang="es-ES" sz="2000" b="0" u="none" strike="noStrike" dirty="0">
+                <a:solidFill>
+                  <a:srgbClr val="000000"/>
+                </a:solidFill>
+                <a:effectLst/>
+                <a:uFillTx/>
+                <a:latin typeface="Arial"/>
+              </a:rPr>
+              <a:t>. No </a:t>
+            </a:r>
+            <a:r>
+              <a:rPr lang="es-ES" sz="2000" b="0" u="none" strike="noStrike" dirty="0" err="1">
+                <a:solidFill>
+                  <a:srgbClr val="000000"/>
+                </a:solidFill>
+                <a:effectLst/>
+                <a:uFillTx/>
+                <a:latin typeface="Arial"/>
+              </a:rPr>
+              <a:t>esmentar</a:t>
+            </a:r>
+            <a:r>
+              <a:rPr lang="es-ES" sz="2000" b="0" u="none" strike="noStrike" dirty="0">
+                <a:solidFill>
+                  <a:srgbClr val="000000"/>
+                </a:solidFill>
+                <a:effectLst/>
+                <a:uFillTx/>
+                <a:latin typeface="Arial"/>
+              </a:rPr>
+              <a:t> persones concretes.</a:t>
             </a:r>
           </a:p>
           <a:p>
@@ -1377,7 +1916,7 @@
               <a:buNone/>
             </a:pPr>
             <a:r>
-              <a:rPr lang="es-ES" sz="2000" b="0" u="none" strike="noStrike">
+              <a:rPr lang="es-ES" sz="2000" b="0" u="none" strike="noStrike" dirty="0">
                 <a:solidFill>
                   <a:srgbClr val="000000"/>
                 </a:solidFill>
@@ -1385,7 +1924,73 @@
                 <a:uFillTx/>
                 <a:latin typeface="Arial"/>
               </a:rPr>
-              <a:t>Frase clau: el desig de consolidar-se ve de lluny.</a:t>
+              <a:t>Frase </a:t>
+            </a:r>
+            <a:r>
+              <a:rPr lang="es-ES" sz="2000" b="0" u="none" strike="noStrike" dirty="0" err="1">
+                <a:solidFill>
+                  <a:srgbClr val="000000"/>
+                </a:solidFill>
+                <a:effectLst/>
+                <a:uFillTx/>
+                <a:latin typeface="Arial"/>
+              </a:rPr>
+              <a:t>clau</a:t>
+            </a:r>
+            <a:r>
+              <a:rPr lang="es-ES" sz="2000" b="0" u="none" strike="noStrike" dirty="0">
+                <a:solidFill>
+                  <a:srgbClr val="000000"/>
+                </a:solidFill>
+                <a:effectLst/>
+                <a:uFillTx/>
+                <a:latin typeface="Arial"/>
+              </a:rPr>
+              <a:t>: el </a:t>
+            </a:r>
+            <a:r>
+              <a:rPr lang="es-ES" sz="2000" b="0" u="none" strike="noStrike" dirty="0" err="1">
+                <a:solidFill>
+                  <a:srgbClr val="000000"/>
+                </a:solidFill>
+                <a:effectLst/>
+                <a:uFillTx/>
+                <a:latin typeface="Arial"/>
+              </a:rPr>
+              <a:t>desig</a:t>
+            </a:r>
+            <a:r>
+              <a:rPr lang="es-ES" sz="2000" b="0" u="none" strike="noStrike" dirty="0">
+                <a:solidFill>
+                  <a:srgbClr val="000000"/>
+                </a:solidFill>
+                <a:effectLst/>
+                <a:uFillTx/>
+                <a:latin typeface="Arial"/>
+              </a:rPr>
+              <a:t> de consolidar-se ve de </a:t>
+            </a:r>
+            <a:r>
+              <a:rPr lang="es-ES" sz="2000" b="0" u="none" strike="noStrike" dirty="0" err="1">
+                <a:solidFill>
+                  <a:srgbClr val="000000"/>
+                </a:solidFill>
+                <a:effectLst/>
+                <a:uFillTx/>
+                <a:latin typeface="Arial"/>
+              </a:rPr>
+              <a:t>lluny</a:t>
+            </a:r>
+            <a:r>
+              <a:rPr lang="es-ES" sz="2000" b="0" u="none" strike="noStrike" dirty="0">
+                <a:solidFill>
+                  <a:srgbClr val="000000"/>
+                </a:solidFill>
+                <a:effectLst/>
+                <a:uFillTx/>
+                <a:latin typeface="Arial"/>
+              </a:rPr>
+              <a:t>.</a:t>
             </a:r>
           </a:p>
         </p:txBody>
@@ -14407,7 +15012,7 @@
         </p:style>
         <p:txBody>
           <a:bodyPr lIns="90000" tIns="45000" rIns="90000" bIns="45000" anchor="t">
-            <a:normAutofit fontScale="92500"/>
+            <a:normAutofit fontScale="92500" lnSpcReduction="10000"/>
           </a:bodyPr>
           <a:lstStyle/>
           <a:p>
@@ -14463,6 +15068,15 @@
               <a:buChar char="•"/>
             </a:pPr>
             <a:r>
+              <a:rPr lang="en-US" sz="1350" dirty="0" err="1">
+                <a:solidFill>
+                  <a:srgbClr val="2D343C"/>
+                </a:solidFill>
+                <a:latin typeface="Arial"/>
+              </a:rPr>
+              <a:t>p</a:t>
+            </a:r>
+            <a:r>
               <a:rPr lang="en-US" sz="1350" b="0" u="none" strike="noStrike" dirty="0" err="1">
                 <a:solidFill>
                   <a:srgbClr val="2D343C"/>
@@ -14471,7 +15085,7 @@
                 <a:uFillTx/>
                 <a:latin typeface="Arial"/>
               </a:rPr>
-              <a:t>enginyeria</a:t>
+              <a:t>rogramació</a:t>
             </a:r>
             <a:r>
               <a:rPr lang="en-US" sz="1350" b="0" u="none" strike="noStrike" dirty="0">
@@ -14482,7 +15096,7 @@
                 <a:uFillTx/>
                 <a:latin typeface="Arial"/>
               </a:rPr>
-              <a:t> del software</a:t>
+              <a:t> OO</a:t>
             </a:r>
             <a:endParaRPr lang="es-ES" sz="1350" b="0" u="none" strike="noStrike" dirty="0">
               <a:solidFill>
@@ -14545,6 +15159,45 @@
               <a:buFont typeface="Arial" panose="020B0604020202020204" pitchFamily="34" charset="0"/>
               <a:buChar char="•"/>
             </a:pPr>
+            <a:r>
+              <a:rPr lang="en-US" sz="1350" b="0" u="none" strike="noStrike" dirty="0">
+                <a:solidFill>
+                  <a:srgbClr val="2D343C"/>
+                </a:solidFill>
+                <a:effectLst/>
+                <a:uFillTx/>
+                <a:latin typeface="Arial"/>
+              </a:rPr>
+              <a:t>Android</a:t>
+            </a:r>
+          </a:p>
+          <a:p>
+            <a:pPr marL="285750" indent="-285750">
+              <a:buFont typeface="Arial" panose="020B0604020202020204" pitchFamily="34" charset="0"/>
+              <a:buChar char="•"/>
+            </a:pPr>
+            <a:r>
+              <a:rPr lang="en-US" sz="1350" b="0" u="none" strike="noStrike" dirty="0" err="1">
+                <a:solidFill>
+                  <a:srgbClr val="2D343C"/>
+                </a:solidFill>
+                <a:effectLst/>
+                <a:uFillTx/>
+                <a:latin typeface="Arial"/>
+              </a:rPr>
+              <a:t>Projecte</a:t>
+            </a:r>
+            <a:r>
+              <a:rPr lang="en-US" sz="1350" b="0" u="none" strike="noStrike" dirty="0">
+                <a:solidFill>
+                  <a:srgbClr val="2D343C"/>
+                </a:solidFill>
+                <a:effectLst/>
+                <a:uFillTx/>
+                <a:latin typeface="Arial"/>
+              </a:rPr>
+              <a:t> </a:t>
+            </a:r>
             <a:r>
               <a:rPr lang="en-US" sz="1350" b="0" u="none" strike="noStrike" dirty="0" err="1">
                 <a:solidFill>
@@ -15070,7 +15723,7 @@
               </a:lnSpc>
             </a:pPr>
             <a:r>
-              <a:rPr lang="en-US" sz="1600" b="1" u="none" strike="noStrike">
+              <a:rPr lang="en-US" sz="1600" b="1" u="none" strike="noStrike" dirty="0" err="1">
                 <a:solidFill>
                   <a:srgbClr val="1C2B3B"/>
                 </a:solidFill>
@@ -15080,7 +15733,7 @@
               </a:rPr>
               <a:t>TecnoCampus</a:t>
             </a:r>
-            <a:endParaRPr lang="es-ES" sz="1600" b="0" u="none" strike="noStrike">
+            <a:endParaRPr lang="es-ES" sz="1600" b="0" u="none" strike="noStrike" dirty="0">
               <a:solidFill>
                 <a:srgbClr val="000000"/>
               </a:solidFill>
@@ -15100,7 +15753,7 @@
         <p:spPr>
           <a:xfrm>
             <a:off x="7699320" y="2930760"/>
-            <a:ext cx="2391120" cy="1098315"/>
+            <a:ext cx="2541600" cy="1229400"/>
           </a:xfrm>
           <a:prstGeom prst="rect">
             <a:avLst/>
@@ -15133,6 +15786,17 @@
               <a:buChar char="•"/>
             </a:pPr>
             <a:r>
+              <a:rPr lang="es-ES" sz="1200" b="0" u="none" strike="noStrike" dirty="0" err="1">
+                <a:solidFill>
+                  <a:srgbClr val="2D343C"/>
+                </a:solidFill>
+                <a:effectLst/>
+                <a:uFillTx/>
+                <a:latin typeface="Arial"/>
+              </a:rPr>
+              <a:t>grau</a:t>
+            </a:r>
+            <a:r>
               <a:rPr lang="es-ES" sz="1200" b="0" u="none" strike="noStrike" dirty="0">
                 <a:solidFill>
                   <a:srgbClr val="2D343C"/>
@@ -15141,7 +15805,84 @@
                 <a:uFillTx/>
                 <a:latin typeface="Arial"/>
               </a:rPr>
-              <a:t>grau orientat a gestió i sistemes d’informació</a:t>
+              <a:t> </a:t>
+            </a:r>
+            <a:r>
+              <a:rPr lang="es-ES" sz="1200" b="0" u="none" strike="noStrike" dirty="0" err="1">
+                <a:solidFill>
+                  <a:srgbClr val="2D343C"/>
+                </a:solidFill>
+                <a:effectLst/>
+                <a:uFillTx/>
+                <a:latin typeface="Arial"/>
+              </a:rPr>
+              <a:t>orientat</a:t>
+            </a:r>
+            <a:r>
+              <a:rPr lang="es-ES" sz="1200" b="0" u="none" strike="noStrike" dirty="0">
+                <a:solidFill>
+                  <a:srgbClr val="2D343C"/>
+                </a:solidFill>
+                <a:effectLst/>
+                <a:uFillTx/>
+                <a:latin typeface="Arial"/>
+              </a:rPr>
+              <a:t> a </a:t>
+            </a:r>
+            <a:r>
+              <a:rPr lang="es-ES" sz="1200" b="0" u="none" strike="noStrike" dirty="0" err="1">
+                <a:solidFill>
+                  <a:srgbClr val="2D343C"/>
+                </a:solidFill>
+                <a:effectLst/>
+                <a:uFillTx/>
+                <a:latin typeface="Arial"/>
+              </a:rPr>
+              <a:t>gestió</a:t>
+            </a:r>
+            <a:r>
+              <a:rPr lang="es-ES" sz="1200" b="0" u="none" strike="noStrike" dirty="0">
+                <a:solidFill>
+                  <a:srgbClr val="2D343C"/>
+                </a:solidFill>
+                <a:effectLst/>
+                <a:uFillTx/>
+                <a:latin typeface="Arial"/>
+              </a:rPr>
+              <a:t> i </a:t>
+            </a:r>
+            <a:r>
+              <a:rPr lang="es-ES" sz="1200" b="0" u="none" strike="noStrike" dirty="0" err="1">
+                <a:solidFill>
+                  <a:srgbClr val="2D343C"/>
+                </a:solidFill>
+                <a:effectLst/>
+                <a:uFillTx/>
+                <a:latin typeface="Arial"/>
+              </a:rPr>
+              <a:t>sistemes</a:t>
+            </a:r>
+            <a:r>
+              <a:rPr lang="es-ES" sz="1200" b="0" u="none" strike="noStrike" dirty="0">
+                <a:solidFill>
+                  <a:srgbClr val="2D343C"/>
+                </a:solidFill>
+                <a:effectLst/>
+                <a:uFillTx/>
+                <a:latin typeface="Arial"/>
+              </a:rPr>
+              <a:t> </a:t>
+            </a:r>
+            <a:r>
+              <a:rPr lang="es-ES" sz="1200" b="0" u="none" strike="noStrike" dirty="0" err="1">
+                <a:solidFill>
+                  <a:srgbClr val="2D343C"/>
+                </a:solidFill>
+                <a:effectLst/>
+                <a:uFillTx/>
+                <a:latin typeface="Arial"/>
+              </a:rPr>
+              <a:t>d’informació</a:t>
             </a:r>
             <a:endParaRPr lang="es-ES" sz="1200" b="0" u="none" strike="noStrike" dirty="0">
               <a:solidFill>
@@ -15187,6 +15928,28 @@
                 <a:latin typeface="Arial"/>
               </a:rPr>
               <a:t> del software i </a:t>
+            </a:r>
+            <a:r>
+              <a:rPr lang="es-ES" sz="1200" b="0" u="none" strike="noStrike" dirty="0" err="1">
+                <a:solidFill>
+                  <a:srgbClr val="2D343C"/>
+                </a:solidFill>
+                <a:effectLst/>
+                <a:uFillTx/>
+                <a:latin typeface="Arial"/>
+              </a:rPr>
+              <a:t>disseny</a:t>
+            </a:r>
+            <a:r>
+              <a:rPr lang="es-ES" sz="1200" b="0" u="none" strike="noStrike" dirty="0">
+                <a:solidFill>
+                  <a:srgbClr val="2D343C"/>
+                </a:solidFill>
+                <a:effectLst/>
+                <a:uFillTx/>
+                <a:latin typeface="Arial"/>
+              </a:rPr>
+              <a:t> de </a:t>
             </a:r>
             <a:r>
               <a:rPr lang="es-ES" sz="1200" b="0" u="none" strike="noStrike" dirty="0" err="1">
@@ -15325,7 +16088,7 @@
               </a:lnSpc>
             </a:pPr>
             <a:r>
-              <a:rPr lang="en-US" sz="1650" b="1" u="none" strike="noStrike">
+              <a:rPr lang="en-US" sz="1650" b="1" u="none" strike="noStrike" dirty="0">
                 <a:solidFill>
                   <a:srgbClr val="1C2B3B"/>
                 </a:solidFill>
@@ -15333,9 +16096,339 @@
                 <a:uFillTx/>
                 <a:latin typeface="Arial"/>
               </a:rPr>
-              <a:t>El desig de consolidar una plaça al TecnoCampus no neix ara: ve d’una trajectòria que hi ha trobat alineació acadèmica i institucional.</a:t>
-            </a:r>
-            <a:endParaRPr lang="es-ES" sz="1650" b="0" u="none" strike="noStrike">
+              <a:t>El </a:t>
+            </a:r>
+            <a:r>
+              <a:rPr lang="en-US" sz="1650" b="1" u="none" strike="noStrike" dirty="0" err="1">
+                <a:solidFill>
+                  <a:srgbClr val="1C2B3B"/>
+                </a:solidFill>
+                <a:effectLst/>
+                <a:uFillTx/>
+                <a:latin typeface="Arial"/>
+              </a:rPr>
+              <a:t>desig</a:t>
+            </a:r>
+            <a:r>
+              <a:rPr lang="en-US" sz="1650" b="1" u="none" strike="noStrike" dirty="0">
+                <a:solidFill>
+                  <a:srgbClr val="1C2B3B"/>
+                </a:solidFill>
+                <a:effectLst/>
+                <a:uFillTx/>
+                <a:latin typeface="Arial"/>
+              </a:rPr>
+              <a:t> de </a:t>
+            </a:r>
+            <a:r>
+              <a:rPr lang="en-US" sz="1650" b="1" u="none" strike="noStrike" dirty="0" err="1">
+                <a:solidFill>
+                  <a:srgbClr val="1C2B3B"/>
+                </a:solidFill>
+                <a:effectLst/>
+                <a:uFillTx/>
+                <a:latin typeface="Arial"/>
+              </a:rPr>
+              <a:t>consolidar</a:t>
+            </a:r>
+            <a:r>
+              <a:rPr lang="en-US" sz="1650" b="1" u="none" strike="noStrike" dirty="0">
+                <a:solidFill>
+                  <a:srgbClr val="1C2B3B"/>
+                </a:solidFill>
+                <a:effectLst/>
+                <a:uFillTx/>
+                <a:latin typeface="Arial"/>
+              </a:rPr>
+              <a:t> </a:t>
+            </a:r>
+            <a:r>
+              <a:rPr lang="en-US" sz="1650" b="1" u="none" strike="noStrike" dirty="0" err="1">
+                <a:solidFill>
+                  <a:srgbClr val="1C2B3B"/>
+                </a:solidFill>
+                <a:effectLst/>
+                <a:uFillTx/>
+                <a:latin typeface="Arial"/>
+              </a:rPr>
+              <a:t>una</a:t>
+            </a:r>
+            <a:r>
+              <a:rPr lang="en-US" sz="1650" b="1" u="none" strike="noStrike" dirty="0">
+                <a:solidFill>
+                  <a:srgbClr val="1C2B3B"/>
+                </a:solidFill>
+                <a:effectLst/>
+                <a:uFillTx/>
+                <a:latin typeface="Arial"/>
+              </a:rPr>
+              <a:t> </a:t>
+            </a:r>
+            <a:r>
+              <a:rPr lang="en-US" sz="1650" b="1" u="none" strike="noStrike" dirty="0" err="1">
+                <a:solidFill>
+                  <a:srgbClr val="1C2B3B"/>
+                </a:solidFill>
+                <a:effectLst/>
+                <a:uFillTx/>
+                <a:latin typeface="Arial"/>
+              </a:rPr>
+              <a:t>plaça</a:t>
+            </a:r>
+            <a:r>
+              <a:rPr lang="en-US" sz="1650" b="1" u="none" strike="noStrike" dirty="0">
+                <a:solidFill>
+                  <a:srgbClr val="1C2B3B"/>
+                </a:solidFill>
+                <a:effectLst/>
+                <a:uFillTx/>
+                <a:latin typeface="Arial"/>
+              </a:rPr>
+              <a:t> al </a:t>
+            </a:r>
+            <a:r>
+              <a:rPr lang="en-US" sz="1650" b="1" u="none" strike="noStrike" dirty="0" err="1">
+                <a:solidFill>
+                  <a:srgbClr val="1C2B3B"/>
+                </a:solidFill>
+                <a:effectLst/>
+                <a:uFillTx/>
+                <a:latin typeface="Arial"/>
+              </a:rPr>
+              <a:t>TecnoCampus</a:t>
+            </a:r>
+            <a:r>
+              <a:rPr lang="en-US" sz="1650" b="1" u="none" strike="noStrike" dirty="0">
+                <a:solidFill>
+                  <a:srgbClr val="1C2B3B"/>
+                </a:solidFill>
+                <a:effectLst/>
+                <a:uFillTx/>
+                <a:latin typeface="Arial"/>
+              </a:rPr>
+              <a:t> no </a:t>
+            </a:r>
+            <a:r>
+              <a:rPr lang="en-US" sz="1650" b="1" u="none" strike="noStrike" dirty="0" err="1">
+                <a:solidFill>
+                  <a:srgbClr val="1C2B3B"/>
+                </a:solidFill>
+                <a:effectLst/>
+                <a:uFillTx/>
+                <a:latin typeface="Arial"/>
+              </a:rPr>
+              <a:t>neix</a:t>
+            </a:r>
+            <a:r>
+              <a:rPr lang="en-US" sz="1650" b="1" u="none" strike="noStrike" dirty="0">
+                <a:solidFill>
+                  <a:srgbClr val="1C2B3B"/>
+                </a:solidFill>
+                <a:effectLst/>
+                <a:uFillTx/>
+                <a:latin typeface="Arial"/>
+              </a:rPr>
+              <a:t> </a:t>
+            </a:r>
+            <a:r>
+              <a:rPr lang="en-US" sz="1650" b="1" u="none" strike="noStrike" dirty="0" err="1">
+                <a:solidFill>
+                  <a:srgbClr val="1C2B3B"/>
+                </a:solidFill>
+                <a:effectLst/>
+                <a:uFillTx/>
+                <a:latin typeface="Arial"/>
+              </a:rPr>
+              <a:t>ara</a:t>
+            </a:r>
+            <a:r>
+              <a:rPr lang="en-US" sz="1650" b="1" u="none" strike="noStrike" dirty="0">
+                <a:solidFill>
+                  <a:srgbClr val="1C2B3B"/>
+                </a:solidFill>
+                <a:effectLst/>
+                <a:uFillTx/>
+                <a:latin typeface="Arial"/>
+              </a:rPr>
+              <a:t>: </a:t>
+            </a:r>
+            <a:r>
+              <a:rPr lang="en-US" sz="1650" b="1" u="none" strike="noStrike" dirty="0" err="1">
+                <a:solidFill>
+                  <a:srgbClr val="1C2B3B"/>
+                </a:solidFill>
+                <a:effectLst/>
+                <a:uFillTx/>
+                <a:latin typeface="Arial"/>
+              </a:rPr>
+              <a:t>ve</a:t>
+            </a:r>
+            <a:r>
+              <a:rPr lang="en-US" sz="1650" b="1" u="none" strike="noStrike" dirty="0">
+                <a:solidFill>
+                  <a:srgbClr val="1C2B3B"/>
+                </a:solidFill>
+                <a:effectLst/>
+                <a:uFillTx/>
+                <a:latin typeface="Arial"/>
+              </a:rPr>
+              <a:t> </a:t>
+            </a:r>
+            <a:r>
+              <a:rPr lang="en-US" sz="1650" b="1" u="none" strike="noStrike" dirty="0" err="1">
+                <a:solidFill>
+                  <a:srgbClr val="1C2B3B"/>
+                </a:solidFill>
+                <a:effectLst/>
+                <a:uFillTx/>
+                <a:latin typeface="Arial"/>
+              </a:rPr>
+              <a:t>d’una</a:t>
+            </a:r>
+            <a:r>
+              <a:rPr lang="en-US" sz="1650" b="1" u="none" strike="noStrike" dirty="0">
+                <a:solidFill>
+                  <a:srgbClr val="1C2B3B"/>
+                </a:solidFill>
+                <a:effectLst/>
+                <a:uFillTx/>
+                <a:latin typeface="Arial"/>
+              </a:rPr>
+              <a:t> </a:t>
+            </a:r>
+            <a:r>
+              <a:rPr lang="en-US" sz="1650" b="1" u="none" strike="noStrike" dirty="0" err="1">
+                <a:solidFill>
+                  <a:srgbClr val="1C2B3B"/>
+                </a:solidFill>
+                <a:effectLst/>
+                <a:uFillTx/>
+                <a:latin typeface="Arial"/>
+              </a:rPr>
+              <a:t>trajectòria</a:t>
+            </a:r>
+            <a:r>
+              <a:rPr lang="en-US" sz="1650" b="1" u="none" strike="noStrike" dirty="0">
+                <a:solidFill>
+                  <a:srgbClr val="1C2B3B"/>
+                </a:solidFill>
+                <a:effectLst/>
+                <a:uFillTx/>
+                <a:latin typeface="Arial"/>
+              </a:rPr>
+              <a:t> que hi ha </a:t>
+            </a:r>
+            <a:r>
+              <a:rPr lang="en-US" sz="1650" b="1" u="none" strike="noStrike" dirty="0" err="1">
+                <a:solidFill>
+                  <a:srgbClr val="1C2B3B"/>
+                </a:solidFill>
+                <a:effectLst/>
+                <a:uFillTx/>
+                <a:latin typeface="Arial"/>
+              </a:rPr>
+              <a:t>trobat</a:t>
+            </a:r>
+            <a:r>
+              <a:rPr lang="en-US" sz="1650" b="1" u="none" strike="noStrike" dirty="0">
+                <a:solidFill>
+                  <a:srgbClr val="1C2B3B"/>
+                </a:solidFill>
+                <a:effectLst/>
+                <a:uFillTx/>
+                <a:latin typeface="Arial"/>
+              </a:rPr>
+              <a:t> </a:t>
+            </a:r>
+            <a:r>
+              <a:rPr lang="en-US" sz="1650" b="1" u="none" strike="noStrike" dirty="0" err="1">
+                <a:solidFill>
+                  <a:srgbClr val="1C2B3B"/>
+                </a:solidFill>
+                <a:effectLst/>
+                <a:uFillTx/>
+                <a:latin typeface="Arial"/>
+              </a:rPr>
+              <a:t>alineació</a:t>
+            </a:r>
+            <a:r>
+              <a:rPr lang="en-US" sz="1650" b="1" u="none" strike="noStrike" dirty="0">
+                <a:solidFill>
+                  <a:srgbClr val="1C2B3B"/>
+                </a:solidFill>
+                <a:effectLst/>
+                <a:uFillTx/>
+                <a:latin typeface="Arial"/>
+              </a:rPr>
+              <a:t> </a:t>
+            </a:r>
+            <a:r>
+              <a:rPr lang="en-US" sz="1650" b="1" u="none" strike="noStrike" dirty="0" err="1">
+                <a:solidFill>
+                  <a:srgbClr val="1C2B3B"/>
+                </a:solidFill>
+                <a:effectLst/>
+                <a:uFillTx/>
+                <a:latin typeface="Arial"/>
+              </a:rPr>
+              <a:t>acadèmica</a:t>
+            </a:r>
+            <a:r>
+              <a:rPr lang="en-US" sz="1650" b="1" u="none" strike="noStrike" dirty="0">
+                <a:solidFill>
+                  <a:srgbClr val="1C2B3B"/>
+                </a:solidFill>
+                <a:effectLst/>
+                <a:uFillTx/>
+                <a:latin typeface="Arial"/>
+              </a:rPr>
+              <a:t> </a:t>
+            </a:r>
+            <a:r>
+              <a:rPr lang="en-US" sz="1650" b="1" u="none" strike="noStrike" dirty="0" err="1">
+                <a:solidFill>
+                  <a:srgbClr val="1C2B3B"/>
+                </a:solidFill>
+                <a:effectLst/>
+                <a:uFillTx/>
+                <a:latin typeface="Arial"/>
+              </a:rPr>
+              <a:t>i</a:t>
+            </a:r>
+            <a:r>
+              <a:rPr lang="en-US" sz="1650" b="1" u="none" strike="noStrike" dirty="0">
+                <a:solidFill>
+                  <a:srgbClr val="1C2B3B"/>
+                </a:solidFill>
+                <a:effectLst/>
+                <a:uFillTx/>
+                <a:latin typeface="Arial"/>
+              </a:rPr>
+              <a:t> </a:t>
+            </a:r>
+            <a:r>
+              <a:rPr lang="en-US" sz="1650" b="1" u="none" strike="noStrike" dirty="0" err="1">
+                <a:solidFill>
+                  <a:srgbClr val="1C2B3B"/>
+                </a:solidFill>
+                <a:effectLst/>
+                <a:uFillTx/>
+                <a:latin typeface="Arial"/>
+              </a:rPr>
+              <a:t>institucional</a:t>
+            </a:r>
+            <a:r>
+              <a:rPr lang="en-US" sz="1650" b="1" u="none" strike="noStrike" dirty="0">
+                <a:solidFill>
+                  <a:srgbClr val="1C2B3B"/>
+                </a:solidFill>
+                <a:effectLst/>
+                <a:uFillTx/>
+                <a:latin typeface="Arial"/>
+              </a:rPr>
+              <a:t>.</a:t>
+            </a:r>
+            <a:endParaRPr lang="es-ES" sz="1650" b="0" u="none" strike="noStrike" dirty="0">
               <a:solidFill>
                 <a:srgbClr val="000000"/>
               </a:solidFill>

</xml_diff>

<commit_message>
Aplica l'auditoria lingüística a la trajectòria i regenera els derivats
Correccions a les diapositives 1-6 del deck de trajectòria (preposicions,
articles, denominacions oficials, Domain-Driven Design, títol «De La Salle
al TecnoCampus») i set esmenes al guió oral de 10 minuts (coma entre
subjecte i verb, universitat-empresa, formulacions més idiomàtiques).
Al deck de 20 minuts, el cas d'ús passa a «Venda d'accions» amb cometes
angulars. Es regeneren tots els materials derivats amb els scripts del
projecte.

Co-Authored-By: Claude Fable 5 <noreply@anthropic.com>
</commit_message>
<xml_diff>
--- a/doc/presentations/defensa-placa-permanent-dsi-ports-sortida-hexagonal/output/defensa-trajectoria-10-minuts.pptx
+++ b/doc/presentations/defensa-placa-permanent-dsi-ports-sortida-hexagonal/output/defensa-trajectoria-10-minuts.pptx
@@ -10410,8 +10410,8 @@
         </p:nvSpPr>
         <p:spPr>
           <a:xfrm>
-            <a:off x="3684959" y="3473415"/>
-            <a:ext cx="1630821" cy="605792"/>
+            <a:off x="3607308" y="3473415"/>
+            <a:ext cx="1792224" cy="605792"/>
           </a:xfrm>
           <a:prstGeom prst="rect">
             <a:avLst/>
@@ -10445,7 +10445,7 @@
               </a:lnSpc>
             </a:pPr>
             <a:r>
-              <a:rPr lang="ca-ES" sz="1450" b="0" u="none" strike="noStrike" dirty="0">
+              <a:rPr lang="ca-ES" sz="1320" b="0" u="none" strike="noStrike" dirty="0">
                 <a:solidFill>
                   <a:schemeClr val="dk1"/>
                 </a:solidFill>
@@ -10453,7 +10453,7 @@
                 <a:uFillTx/>
                 <a:latin typeface="Calibri"/>
               </a:rPr>
-              <a:t>software</a:t>
+              <a:t>enginyeria del software</a:t>
             </a:r>
             <a:endParaRPr lang="es-ES" sz="1450" b="0" u="none" strike="noStrike" dirty="0">
               <a:solidFill>
@@ -10471,7 +10471,7 @@
               </a:lnSpc>
             </a:pPr>
             <a:r>
-              <a:rPr lang="ca-ES" sz="1450" b="0" u="none" strike="noStrike" dirty="0">
+              <a:rPr lang="ca-ES" sz="1320" b="0" u="none" strike="noStrike" dirty="0">
                 <a:solidFill>
                   <a:schemeClr val="dk1"/>
                 </a:solidFill>
@@ -10691,7 +10691,7 @@
                 <a:uFillTx/>
                 <a:latin typeface="Calibri"/>
               </a:rPr>
-              <a:t>educació en</a:t>
+              <a:t>en Educació en</a:t>
             </a:r>
             <a:endParaRPr lang="es-ES" sz="1320" b="0" u="none" strike="noStrike" dirty="0">
               <a:solidFill>
@@ -12278,7 +12278,7 @@
                 <a:uFillTx/>
                 <a:latin typeface="Arial"/>
               </a:rPr>
-              <a:t> al 3GSM / Mobile </a:t>
+              <a:t> al 3GSM/Mobile </a:t>
             </a:r>
             <a:r>
               <a:rPr lang="es-ES" sz="1420" b="0" u="none" strike="noStrike" dirty="0" err="1">
@@ -14095,7 +14095,7 @@
                 <a:uFillTx/>
                 <a:latin typeface="Arial"/>
               </a:rPr>
-              <a:t>• Formació Professional: DAW / DAM</a:t>
+              <a:t>• Formació Professional: DAW i DAM</a:t>
             </a:r>
             <a:endParaRPr lang="es-ES" sz="1380" b="0" u="none" strike="noStrike">
               <a:solidFill>
@@ -14904,7 +14904,7 @@
                 <a:uFillTx/>
                 <a:latin typeface="Arial"/>
               </a:rPr>
-              <a:t>La Salle i el pont cap al TecnoCampus</a:t>
+              <a:t>De La Salle al TecnoCampus</a:t>
             </a:r>
             <a:endParaRPr lang="es-ES" sz="2700" b="0" u="none" strike="noStrike">
               <a:solidFill>
@@ -15305,7 +15305,7 @@
                 </a:solidFill>
                 <a:latin typeface="Arial"/>
               </a:rPr>
-              <a:t>p</a:t>
+              <a:t>programació orientada a objectes</a:t>
             </a:r>
             <a:r>
               <a:rPr lang="en-US" sz="1350" b="0" u="none" strike="noStrike" dirty="0" err="1">
@@ -15316,7 +15316,7 @@
                 <a:uFillTx/>
                 <a:latin typeface="Arial"/>
               </a:rPr>
-              <a:t>rogramació</a:t>
+              <a:t/>
             </a:r>
             <a:r>
               <a:rPr lang="en-US" sz="1350" b="0" u="none" strike="noStrike" dirty="0">
@@ -15327,7 +15327,7 @@
                 <a:uFillTx/>
                 <a:latin typeface="Arial"/>
               </a:rPr>
-              <a:t> OO</a:t>
+              <a:t/>
             </a:r>
             <a:endParaRPr lang="es-ES" sz="1350" b="0" u="none" strike="noStrike" dirty="0">
               <a:solidFill>
@@ -16025,7 +16025,7 @@
                 <a:uFillTx/>
                 <a:latin typeface="Arial"/>
               </a:rPr>
-              <a:t>grau</a:t>
+              <a:t>grau orientat a la gestió i als sistemes d’informació</a:t>
             </a:r>
             <a:r>
               <a:rPr lang="es-ES" sz="1200" b="0" u="none" strike="noStrike" dirty="0">
@@ -16036,7 +16036,7 @@
                 <a:uFillTx/>
                 <a:latin typeface="Arial"/>
               </a:rPr>
-              <a:t> </a:t>
+              <a:t/>
             </a:r>
             <a:r>
               <a:rPr lang="es-ES" sz="1200" b="0" u="none" strike="noStrike" dirty="0" err="1">
@@ -16047,7 +16047,7 @@
                 <a:uFillTx/>
                 <a:latin typeface="Arial"/>
               </a:rPr>
-              <a:t>orientat</a:t>
+              <a:t/>
             </a:r>
             <a:r>
               <a:rPr lang="es-ES" sz="1200" b="0" u="none" strike="noStrike" dirty="0">
@@ -16058,7 +16058,7 @@
                 <a:uFillTx/>
                 <a:latin typeface="Arial"/>
               </a:rPr>
-              <a:t> a </a:t>
+              <a:t/>
             </a:r>
             <a:r>
               <a:rPr lang="es-ES" sz="1200" b="0" u="none" strike="noStrike" dirty="0" err="1">
@@ -16069,7 +16069,7 @@
                 <a:uFillTx/>
                 <a:latin typeface="Arial"/>
               </a:rPr>
-              <a:t>gestió</a:t>
+              <a:t/>
             </a:r>
             <a:r>
               <a:rPr lang="es-ES" sz="1200" b="0" u="none" strike="noStrike" dirty="0">
@@ -16080,7 +16080,7 @@
                 <a:uFillTx/>
                 <a:latin typeface="Arial"/>
               </a:rPr>
-              <a:t> i </a:t>
+              <a:t/>
             </a:r>
             <a:r>
               <a:rPr lang="es-ES" sz="1200" b="0" u="none" strike="noStrike" dirty="0" err="1">
@@ -16091,7 +16091,7 @@
                 <a:uFillTx/>
                 <a:latin typeface="Arial"/>
               </a:rPr>
-              <a:t>sistemes</a:t>
+              <a:t/>
             </a:r>
             <a:r>
               <a:rPr lang="es-ES" sz="1200" b="0" u="none" strike="noStrike" dirty="0">
@@ -16102,7 +16102,7 @@
                 <a:uFillTx/>
                 <a:latin typeface="Arial"/>
               </a:rPr>
-              <a:t> </a:t>
+              <a:t/>
             </a:r>
             <a:r>
               <a:rPr lang="es-ES" sz="1200" b="0" u="none" strike="noStrike" dirty="0" err="1">
@@ -16113,7 +16113,7 @@
                 <a:uFillTx/>
                 <a:latin typeface="Arial"/>
               </a:rPr>
-              <a:t>d’informació</a:t>
+              <a:t/>
             </a:r>
             <a:endParaRPr lang="es-ES" sz="1200" b="0" u="none" strike="noStrike" dirty="0">
               <a:solidFill>
@@ -17361,7 +17361,7 @@
                 <a:uFillTx/>
                 <a:latin typeface="Arial"/>
               </a:rPr>
-              <a:t>• </a:t>
+              <a:t>• Laboratori d’Aplicacions Internet</a:t>
             </a:r>
             <a:r>
               <a:rPr lang="en-US" sz="1180" b="0" u="none" strike="noStrike" dirty="0" err="1">
@@ -17372,7 +17372,7 @@
                 <a:uFillTx/>
                 <a:latin typeface="Arial"/>
               </a:rPr>
-              <a:t>laboratori</a:t>
+              <a:t/>
             </a:r>
             <a:r>
               <a:rPr lang="en-US" sz="1180" b="0" u="none" strike="noStrike" dirty="0">
@@ -17383,7 +17383,7 @@
                 <a:uFillTx/>
                 <a:latin typeface="Arial"/>
               </a:rPr>
-              <a:t> </a:t>
+              <a:t/>
             </a:r>
             <a:r>
               <a:rPr lang="en-US" sz="1180" b="0" u="none" strike="noStrike" dirty="0" err="1">
@@ -17394,7 +17394,7 @@
                 <a:uFillTx/>
                 <a:latin typeface="Arial"/>
               </a:rPr>
-              <a:t>aplicacions</a:t>
+              <a:t/>
             </a:r>
             <a:r>
               <a:rPr lang="en-US" sz="1180" b="0" u="none" strike="noStrike" dirty="0">
@@ -17405,7 +17405,7 @@
                 <a:uFillTx/>
                 <a:latin typeface="Arial"/>
               </a:rPr>
-              <a:t> </a:t>
+              <a:t/>
             </a:r>
             <a:r>
               <a:rPr lang="en-US" sz="1180" b="0" u="none" strike="noStrike" dirty="0" err="1">
@@ -17416,7 +17416,7 @@
                 <a:uFillTx/>
                 <a:latin typeface="Arial"/>
               </a:rPr>
-              <a:t>d’Internet</a:t>
+              <a:t/>
             </a:r>
             <a:endParaRPr lang="es-ES" sz="1180" b="0" u="none" strike="noStrike" dirty="0">
               <a:solidFill>
@@ -17633,7 +17633,7 @@
                 <a:uFillTx/>
                 <a:latin typeface="Arial"/>
               </a:rPr>
-              <a:t>• 4 </a:t>
+              <a:t>• Quatre registres dels dos darrers cursos: mitjana 9,03/10</a:t>
             </a:r>
             <a:r>
               <a:rPr lang="en-US" sz="1180" b="0" u="none" strike="noStrike" dirty="0" err="1">
@@ -17644,7 +17644,7 @@
                 <a:uFillTx/>
                 <a:latin typeface="Arial"/>
               </a:rPr>
-              <a:t>registres</a:t>
+              <a:t/>
             </a:r>
             <a:r>
               <a:rPr lang="en-US" sz="1180" b="0" u="none" strike="noStrike" dirty="0">
@@ -17655,7 +17655,7 @@
                 <a:uFillTx/>
                 <a:latin typeface="Arial"/>
               </a:rPr>
-              <a:t> </a:t>
+              <a:t/>
             </a:r>
             <a:r>
               <a:rPr lang="en-US" sz="1180" dirty="0">
@@ -17664,7 +17664,7 @@
                 </a:solidFill>
                 <a:latin typeface="Arial"/>
               </a:rPr>
-              <a:t>dos </a:t>
+              <a:t/>
             </a:r>
             <a:r>
               <a:rPr lang="en-US" sz="1180" dirty="0" err="1">
@@ -17673,7 +17673,7 @@
                 </a:solidFill>
                 <a:latin typeface="Arial"/>
               </a:rPr>
-              <a:t>últims</a:t>
+              <a:t/>
             </a:r>
             <a:r>
               <a:rPr lang="en-US" sz="1180" dirty="0">
@@ -17682,7 +17682,7 @@
                 </a:solidFill>
                 <a:latin typeface="Arial"/>
               </a:rPr>
-              <a:t> </a:t>
+              <a:t/>
             </a:r>
             <a:r>
               <a:rPr lang="en-US" sz="1180">
@@ -17691,7 +17691,7 @@
                 </a:solidFill>
                 <a:latin typeface="Arial"/>
               </a:rPr>
-              <a:t>cursos:</a:t>
+              <a:t/>
             </a:r>
             <a:r>
               <a:rPr lang="en-US" sz="1180" b="0" u="none" strike="noStrike">
@@ -17702,7 +17702,7 @@
                 <a:uFillTx/>
                 <a:latin typeface="Arial"/>
               </a:rPr>
-              <a:t> </a:t>
+              <a:t/>
             </a:r>
             <a:r>
               <a:rPr lang="en-US" sz="1180" b="0" u="none" strike="noStrike" dirty="0" err="1">
@@ -17713,7 +17713,7 @@
                 <a:uFillTx/>
                 <a:latin typeface="Arial"/>
               </a:rPr>
-              <a:t>mitjana</a:t>
+              <a:t/>
             </a:r>
             <a:r>
               <a:rPr lang="en-US" sz="1180" b="0" u="none" strike="noStrike" dirty="0">
@@ -17724,7 +17724,7 @@
                 <a:uFillTx/>
                 <a:latin typeface="Arial"/>
               </a:rPr>
-              <a:t> 9,03/10</a:t>
+              <a:t/>
             </a:r>
             <a:endParaRPr lang="es-ES" sz="1180" b="0" u="none" strike="noStrike" dirty="0">
               <a:solidFill>
@@ -17988,7 +17988,7 @@
                 <a:uFillTx/>
                 <a:latin typeface="Arial"/>
               </a:rPr>
-              <a:t>Domain Driven Design </a:t>
+              <a:t>Domain-Driven Design</a:t>
             </a:r>
             <a:endParaRPr lang="es-ES" sz="1150" b="0" u="none" strike="noStrike">
               <a:solidFill>
@@ -20109,7 +20109,7 @@
                 <a:uFillTx/>
                 <a:latin typeface="Arial"/>
               </a:rPr>
-              <a:t>recerca</a:t>
+              <a:t>recerca en Educació en Enginyeria del Software</a:t>
             </a:r>
             <a:r>
               <a:rPr lang="es-ES" sz="1340" b="0" u="none" strike="noStrike" dirty="0">
@@ -20120,7 +20120,7 @@
                 <a:uFillTx/>
                 <a:latin typeface="Arial"/>
               </a:rPr>
-              <a:t> </a:t>
+              <a:t/>
             </a:r>
             <a:r>
               <a:rPr lang="es-ES" sz="1340" b="0" u="none" strike="noStrike" dirty="0" err="1">
@@ -20131,7 +20131,7 @@
                 <a:uFillTx/>
                 <a:latin typeface="Arial"/>
               </a:rPr>
-              <a:t>educació</a:t>
+              <a:t/>
             </a:r>
             <a:r>
               <a:rPr lang="es-ES" sz="1340" b="0" u="none" strike="noStrike" dirty="0">
@@ -20142,7 +20142,7 @@
                 <a:uFillTx/>
                 <a:latin typeface="Arial"/>
               </a:rPr>
-              <a:t> en </a:t>
+              <a:t/>
             </a:r>
             <a:r>
               <a:rPr lang="es-ES" sz="1340" b="0" u="none" strike="noStrike" dirty="0" err="1">
@@ -20153,7 +20153,7 @@
                 <a:uFillTx/>
                 <a:latin typeface="Arial"/>
               </a:rPr>
-              <a:t>enginyeria</a:t>
+              <a:t/>
             </a:r>
             <a:endParaRPr lang="es-ES" sz="1340" b="0" u="none" strike="noStrike" dirty="0">
               <a:solidFill>
@@ -20356,7 +20356,7 @@
                 <a:uFillTx/>
                 <a:latin typeface="Arial"/>
               </a:rPr>
-              <a:t>Disseny mixt i quasiexperimental en dues assignatures reals amb ABP. Buit: integració curricular, mesura i estudis longitudinals.</a:t>
+              <a:t>Disseny mixt i quasiexperimental en dues assignatures reals amb ABP. Buit de recerca: integració curricular, mesura i estudis longitudinals.</a:t>
             </a:r>
             <a:endParaRPr lang="es-ES" sz="1420" b="0" u="none" strike="noStrike">
               <a:solidFill>

</xml_diff>

<commit_message>
Insereix la diapositiva d'introducció al deck de trajectòria i renumera el guió
La portada queda només com a benvinguda (0:15) i la nova diapositiva 2
mostra el fil conductor des del 2004 i el recorregut de la presentació
(0:35). Renumera diapositives i referències del guió oral d'1-6 a 1-7
i regenera tots els materials derivats.
</commit_message>
<xml_diff>
--- a/doc/presentations/defensa-placa-permanent-dsi-ports-sortida-hexagonal/output/defensa-trajectoria-10-minuts.pptx
+++ b/doc/presentations/defensa-placa-permanent-dsi-ports-sortida-hexagonal/output/defensa-trajectoria-10-minuts.pptx
@@ -9,6 +9,7 @@
   </p:notesMasterIdLst>
   <p:sldIdLst>
     <p:sldId id="256" r:id="rId2"/>
+    <p:sldId id="263" r:id="rId14"/>
     <p:sldId id="257" r:id="rId3"/>
     <p:sldId id="258" r:id="rId4"/>
     <p:sldId id="259" r:id="rId5"/>
@@ -628,79 +629,18 @@
           </a:bodyPr>
           <a:lstStyle/>
           <a:p>
-            <a:pPr indent="0" algn="l">
-              <a:lnSpc>
-                <a:spcPct val="100000"/>
-              </a:lnSpc>
-              <a:buNone/>
-            </a:pPr>
-            <a:r>
-              <a:rPr lang="es-ES" sz="2000" b="0" u="none" strike="noStrike">
-                <a:solidFill>
-                  <a:srgbClr val="000000"/>
-                </a:solidFill>
-                <a:effectLst/>
-                <a:uFillTx/>
-                <a:latin typeface="Arial"/>
-              </a:rPr>
-              <a:t>Agrair breument al tribunal.</a:t>
-            </a:r>
-          </a:p>
-          <a:p>
-            <a:pPr indent="0" algn="l">
-              <a:lnSpc>
-                <a:spcPct val="100000"/>
-              </a:lnSpc>
-              <a:buNone/>
-            </a:pPr>
-            <a:r>
-              <a:rPr lang="es-ES" sz="2000" b="0" u="none" strike="noStrike">
-                <a:solidFill>
-                  <a:srgbClr val="000000"/>
-                </a:solidFill>
-                <a:effectLst/>
-                <a:uFillTx/>
-                <a:latin typeface="Arial"/>
-              </a:rPr>
-              <a:t>No llegir el CV: explicar el fil conductor.</a:t>
-            </a:r>
-          </a:p>
-          <a:p>
-            <a:pPr indent="0" algn="l">
-              <a:lnSpc>
-                <a:spcPct val="100000"/>
-              </a:lnSpc>
-              <a:buNone/>
-            </a:pPr>
-            <a:r>
-              <a:rPr lang="es-ES" sz="2000" b="0" u="none" strike="noStrike">
-                <a:solidFill>
-                  <a:srgbClr val="000000"/>
-                </a:solidFill>
-                <a:effectLst/>
-                <a:uFillTx/>
-                <a:latin typeface="Arial"/>
-              </a:rPr>
-              <a:t>Idees: 2004, indústria del software, docència universitària en software, innovació, transferència, recerca i TecnoCampus.</a:t>
-            </a:r>
-          </a:p>
-          <a:p>
-            <a:pPr indent="0" algn="l">
-              <a:lnSpc>
-                <a:spcPct val="100000"/>
-              </a:lnSpc>
-              <a:buNone/>
-            </a:pPr>
-            <a:r>
-              <a:rPr lang="es-ES" sz="2000" b="0" u="none" strike="noStrike">
-                <a:solidFill>
-                  <a:srgbClr val="000000"/>
-                </a:solidFill>
-                <a:effectLst/>
-                <a:uFillTx/>
-                <a:latin typeface="Arial"/>
-              </a:rPr>
-              <a:t>Transició: començar per la base professional en indústria del software.</a:t>
+            <a:r>
+              <a:t>Portada i benvinguda. Agrair breument al tribunal.</a:t>
+            </a:r>
+          </a:p>
+          <a:p>
+            <a:r>
+              <a:t>Només salutació: la introducció s’explica amb la diapositiva següent.</a:t>
+            </a:r>
+          </a:p>
+          <a:p>
+            <a:r>
+              <a:t>Transició: avançar a la diapositiva del fil conductor.</a:t>
             </a:r>
           </a:p>
         </p:txBody>
@@ -2795,6 +2735,96 @@
             </a:r>
           </a:p>
         </p:txBody>
+      </p:sp>
+    </p:spTree>
+  </p:cSld>
+  <p:clrMapOvr>
+    <a:masterClrMapping/>
+  </p:clrMapOvr>
+</p:notes>
+</file>
+
+<file path=ppt/notesSlides/notesSlide8.xml><?xml version="1.0" encoding="utf-8"?>
+<p:notes xmlns:a="http://schemas.openxmlformats.org/drawingml/2006/main" xmlns:p="http://schemas.openxmlformats.org/presentationml/2006/main" xmlns:r="http://schemas.openxmlformats.org/officeDocument/2006/relationships">
+  <p:cSld>
+    <p:spTree>
+      <p:nvGrpSpPr>
+        <p:cNvPr id="1" name=""/>
+        <p:cNvGrpSpPr/>
+        <p:nvPr/>
+      </p:nvGrpSpPr>
+      <p:grpSpPr>
+        <a:xfrm>
+          <a:off x="0" y="0"/>
+          <a:ext cx="0" cy="0"/>
+          <a:chOff x="0" y="0"/>
+          <a:chExt cx="0" cy="0"/>
+        </a:xfrm>
+      </p:grpSpPr>
+      <p:sp>
+        <p:nvSpPr>
+          <p:cNvPr id="2" name="Slide Image Placeholder 1"/>
+          <p:cNvSpPr>
+            <a:spLocks noGrp="1"/>
+          </p:cNvSpPr>
+          <p:nvPr>
+            <p:ph type="sldImg"/>
+          </p:nvPr>
+        </p:nvSpPr>
+        <p:spPr/>
+      </p:sp>
+      <p:sp>
+        <p:nvSpPr>
+          <p:cNvPr id="3" name="Notes Placeholder 2"/>
+          <p:cNvSpPr>
+            <a:spLocks noGrp="1"/>
+          </p:cNvSpPr>
+          <p:nvPr>
+            <p:ph type="body"/>
+          </p:nvPr>
+        </p:nvSpPr>
+        <p:spPr/>
+        <p:txBody>
+          <a:bodyPr/>
+          <a:lstStyle/>
+          <a:p>
+            <a:r>
+              <a:t>No llegir el CV: explicar el fil conductor.</a:t>
+            </a:r>
+          </a:p>
+          <a:p>
+            <a:r>
+              <a:t>Idees: 2004, indústria del software, docència universitària en software, innovació, transferència, recerca i TecnoCampus.</a:t>
+            </a:r>
+          </a:p>
+          <a:p>
+            <a:r>
+              <a:t>Recorregut: base professional, vocació docent, pas a la universitat, consolidació al TecnoCampus i projecte de futur.</a:t>
+            </a:r>
+          </a:p>
+          <a:p>
+            <a:r>
+              <a:t>És suport visual de la introducció, no un bloc nou: no allargar.</a:t>
+            </a:r>
+          </a:p>
+          <a:p>
+            <a:r>
+              <a:t>Transició: començar per la base professional en indústria del software.</a:t>
+            </a:r>
+          </a:p>
+        </p:txBody>
+      </p:sp>
+      <p:sp>
+        <p:nvSpPr>
+          <p:cNvPr id="4" name="Slide Number Placeholder 3"/>
+          <p:cNvSpPr>
+            <a:spLocks noGrp="1"/>
+          </p:cNvSpPr>
+          <p:nvPr>
+            <p:ph type="sldNum" idx="36"/>
+          </p:nvPr>
+        </p:nvSpPr>
+        <p:spPr/>
       </p:sp>
     </p:spTree>
   </p:cSld>
@@ -13542,7 +13572,7 @@
                 <a:uFillTx/>
                 <a:latin typeface="Arial"/>
               </a:rPr>
-              <a:t>2</a:t>
+              <a:t>3</a:t>
             </a:r>
             <a:endParaRPr lang="es-ES" sz="860" b="0" u="none" strike="noStrike">
               <a:solidFill>
@@ -14815,7 +14845,7 @@
                 <a:uFillTx/>
                 <a:latin typeface="Arial"/>
               </a:rPr>
-              <a:t>3</a:t>
+              <a:t>4</a:t>
             </a:r>
             <a:endParaRPr lang="es-ES" sz="860" b="0" u="none" strike="noStrike">
               <a:solidFill>
@@ -16785,7 +16815,7 @@
                 <a:uFillTx/>
                 <a:latin typeface="Arial"/>
               </a:rPr>
-              <a:t>4</a:t>
+              <a:t>5</a:t>
             </a:r>
             <a:endParaRPr lang="es-ES" sz="860" b="0" u="none" strike="noStrike">
               <a:solidFill>
@@ -18823,7 +18853,7 @@
                 <a:uFillTx/>
                 <a:latin typeface="Arial"/>
               </a:rPr>
-              <a:t>5</a:t>
+              <a:t>6</a:t>
             </a:r>
             <a:endParaRPr lang="es-ES" sz="860" b="0" u="none" strike="noStrike">
               <a:solidFill>
@@ -20548,7 +20578,7 @@
                 <a:uFillTx/>
                 <a:latin typeface="Arial"/>
               </a:rPr>
-              <a:t>6</a:t>
+              <a:t>7</a:t>
             </a:r>
             <a:endParaRPr lang="es-ES" sz="860" b="0" u="none" strike="noStrike">
               <a:solidFill>
@@ -21852,6 +21882,1100 @@
 </p:sld>
 </file>
 
+<file path=ppt/slides/slide8.xml><?xml version="1.0" encoding="utf-8"?>
+<p:sld xmlns:a="http://schemas.openxmlformats.org/drawingml/2006/main" xmlns:p="http://schemas.openxmlformats.org/presentationml/2006/main" xmlns:r="http://schemas.openxmlformats.org/officeDocument/2006/relationships">
+  <p:cSld>
+    <p:spTree>
+      <p:nvGrpSpPr>
+        <p:cNvPr id="1" name=""/>
+        <p:cNvGrpSpPr/>
+        <p:nvPr/>
+      </p:nvGrpSpPr>
+      <p:grpSpPr/>
+      <p:sp>
+        <p:nvSpPr>
+          <p:cNvPr id="2" name="Title 1"/>
+          <p:cNvSpPr>
+            <a:spLocks noGrp="1"/>
+          </p:cNvSpPr>
+          <p:nvPr>
+            <p:ph type="title"/>
+          </p:nvPr>
+        </p:nvSpPr>
+        <p:spPr/>
+        <p:txBody>
+          <a:bodyPr/>
+          <a:lstStyle/>
+          <a:p/>
+        </p:txBody>
+      </p:sp>
+      <p:sp>
+        <p:nvSpPr>
+          <p:cNvPr id="3" name="Text Placeholder 2"/>
+          <p:cNvSpPr>
+            <a:spLocks noGrp="1"/>
+          </p:cNvSpPr>
+          <p:nvPr>
+            <p:ph type="body"/>
+          </p:nvPr>
+        </p:nvSpPr>
+        <p:spPr/>
+        <p:txBody>
+          <a:bodyPr/>
+          <a:lstStyle/>
+          <a:p/>
+        </p:txBody>
+      </p:sp>
+      <p:sp>
+        <p:nvSpPr>
+          <p:cNvPr id="4" name="Titol"/>
+          <p:cNvSpPr txBox="1"/>
+          <p:nvPr/>
+        </p:nvSpPr>
+        <p:spPr>
+          <a:xfrm>
+            <a:off x="640080" y="384048"/>
+            <a:ext cx="8458200" cy="438912"/>
+          </a:xfrm>
+          <a:prstGeom prst="rect">
+            <a:avLst/>
+          </a:prstGeom>
+          <a:noFill/>
+        </p:spPr>
+        <p:txBody>
+          <a:bodyPr wrap="square" lIns="90000" tIns="45000" rIns="90000" bIns="45000">
+            <a:spAutoFit/>
+          </a:bodyPr>
+          <a:lstStyle/>
+          <a:p>
+            <a:pPr/>
+            <a:r>
+              <a:rPr sz="2700" b="1" lang="ca-ES">
+                <a:solidFill>
+                  <a:srgbClr val="1C2B3B"/>
+                </a:solidFill>
+                <a:latin typeface="Arial"/>
+              </a:rPr>
+              <a:t>Un fil conductor: l’enginyeria del software</a:t>
+            </a:r>
+          </a:p>
+        </p:txBody>
+      </p:sp>
+      <p:sp>
+        <p:nvSpPr>
+          <p:cNvPr id="5" name="Subtitol"/>
+          <p:cNvSpPr txBox="1"/>
+          <p:nvPr/>
+        </p:nvSpPr>
+        <p:spPr>
+          <a:xfrm>
+            <a:off x="658368" y="841248"/>
+            <a:ext cx="7955279" cy="292608"/>
+          </a:xfrm>
+          <a:prstGeom prst="rect">
+            <a:avLst/>
+          </a:prstGeom>
+          <a:noFill/>
+        </p:spPr>
+        <p:txBody>
+          <a:bodyPr wrap="square" lIns="90000" tIns="45000" rIns="90000" bIns="45000">
+            <a:spAutoFit/>
+          </a:bodyPr>
+          <a:lstStyle/>
+          <a:p>
+            <a:pPr/>
+            <a:r>
+              <a:rPr sz="1200" b="0" lang="ca-ES">
+                <a:solidFill>
+                  <a:srgbClr val="67717C"/>
+                </a:solidFill>
+                <a:latin typeface="Arial"/>
+              </a:rPr>
+              <a:t>Una trajectòria iniciada el 2004: el recorregut de la presentació</a:t>
+            </a:r>
+          </a:p>
+        </p:txBody>
+      </p:sp>
+      <p:pic>
+        <p:nvPicPr>
+          <p:cNvPr id="6" name="Picture 5" descr="image.png"/>
+          <p:cNvPicPr>
+            <a:picLocks noChangeAspect="1"/>
+          </p:cNvPicPr>
+          <p:nvPr/>
+        </p:nvPicPr>
+        <p:blipFill>
+          <a:blip r:embed="rId2"/>
+          <a:stretch>
+            <a:fillRect/>
+          </a:stretch>
+        </p:blipFill>
+        <p:spPr>
+          <a:xfrm>
+            <a:off x="9372600" y="310896"/>
+            <a:ext cx="1993392" cy="374904"/>
+          </a:xfrm>
+          <a:prstGeom prst="rect">
+            <a:avLst/>
+          </a:prstGeom>
+        </p:spPr>
+      </p:pic>
+      <p:sp>
+        <p:nvSpPr>
+          <p:cNvPr id="7" name="Linia divisoria"/>
+          <p:cNvSpPr/>
+          <p:nvPr/>
+        </p:nvSpPr>
+        <p:spPr>
+          <a:xfrm>
+            <a:off x="640080" y="1115568"/>
+            <a:ext cx="10789920" cy="13320"/>
+          </a:xfrm>
+          <a:prstGeom prst="rect">
+            <a:avLst/>
+          </a:prstGeom>
+          <a:solidFill>
+            <a:srgbClr val="D3DAE2"/>
+          </a:solidFill>
+          <a:ln>
+            <a:noFill/>
+          </a:ln>
+          <a:effectLst>
+            <a:outerShdw blurRad="39960" dist="23040" dir="5400000" rotWithShape="0">
+              <a:srgbClr val="000000">
+                <a:alpha val="35000"/>
+              </a:srgbClr>
+            </a:outerShdw>
+          </a:effectLst>
+        </p:spPr>
+        <p:style>
+          <a:lnRef idx="1">
+            <a:schemeClr val="accent1"/>
+          </a:lnRef>
+          <a:fillRef idx="3">
+            <a:schemeClr val="accent1"/>
+          </a:fillRef>
+          <a:effectRef idx="2">
+            <a:schemeClr val="accent1"/>
+          </a:effectRef>
+          <a:fontRef idx="minor">
+            <a:schemeClr val="lt1"/>
+          </a:fontRef>
+        </p:style>
+        <p:txBody>
+          <a:bodyPr rtlCol="0" anchor="ctr"/>
+          <a:lstStyle/>
+          <a:p>
+            <a:pPr algn="ctr"/>
+          </a:p>
+        </p:txBody>
+      </p:sp>
+      <p:sp>
+        <p:nvSpPr>
+          <p:cNvPr id="8" name="Pindola rol"/>
+          <p:cNvSpPr/>
+          <p:nvPr/>
+        </p:nvSpPr>
+        <p:spPr>
+          <a:xfrm>
+            <a:off x="1389888" y="1691640"/>
+            <a:ext cx="2423160" cy="384048"/>
+          </a:xfrm>
+          <a:prstGeom prst="rect">
+            <a:avLst/>
+          </a:prstGeom>
+          <a:solidFill>
+            <a:srgbClr val="FFFFFF"/>
+          </a:solidFill>
+          <a:ln>
+            <a:solidFill>
+              <a:srgbClr val="D3DAE2"/>
+            </a:solidFill>
+          </a:ln>
+          <a:effectLst>
+            <a:outerShdw blurRad="39960" dist="23040" dir="5400000" rotWithShape="0">
+              <a:srgbClr val="000000">
+                <a:alpha val="35000"/>
+              </a:srgbClr>
+            </a:outerShdw>
+          </a:effectLst>
+        </p:spPr>
+        <p:style>
+          <a:lnRef idx="1">
+            <a:schemeClr val="accent1"/>
+          </a:lnRef>
+          <a:fillRef idx="3">
+            <a:schemeClr val="accent1"/>
+          </a:fillRef>
+          <a:effectRef idx="2">
+            <a:schemeClr val="accent1"/>
+          </a:effectRef>
+          <a:fontRef idx="minor">
+            <a:schemeClr val="lt1"/>
+          </a:fontRef>
+        </p:style>
+        <p:txBody>
+          <a:bodyPr rtlCol="0" anchor="ctr" lIns="90000" tIns="45000" rIns="90000" bIns="45000" wrap="square"/>
+          <a:lstStyle/>
+          <a:p>
+            <a:pPr algn="ctr"/>
+            <a:r>
+              <a:rPr sz="1050" b="1" lang="ca-ES">
+                <a:solidFill>
+                  <a:srgbClr val="2A5C84"/>
+                </a:solidFill>
+                <a:latin typeface="Arial"/>
+              </a:rPr>
+              <a:t>Primer: enginyer a la indústria</a:t>
+            </a:r>
+          </a:p>
+        </p:txBody>
+      </p:sp>
+      <p:sp>
+        <p:nvSpPr>
+          <p:cNvPr id="9" name="Pindola rol"/>
+          <p:cNvSpPr/>
+          <p:nvPr/>
+        </p:nvSpPr>
+        <p:spPr>
+          <a:xfrm>
+            <a:off x="4133087" y="1691640"/>
+            <a:ext cx="1691640" cy="384048"/>
+          </a:xfrm>
+          <a:prstGeom prst="rect">
+            <a:avLst/>
+          </a:prstGeom>
+          <a:solidFill>
+            <a:srgbClr val="FFFFFF"/>
+          </a:solidFill>
+          <a:ln>
+            <a:solidFill>
+              <a:srgbClr val="D3DAE2"/>
+            </a:solidFill>
+          </a:ln>
+          <a:effectLst>
+            <a:outerShdw blurRad="39960" dist="23040" dir="5400000" rotWithShape="0">
+              <a:srgbClr val="000000">
+                <a:alpha val="35000"/>
+              </a:srgbClr>
+            </a:outerShdw>
+          </a:effectLst>
+        </p:spPr>
+        <p:style>
+          <a:lnRef idx="1">
+            <a:schemeClr val="accent1"/>
+          </a:lnRef>
+          <a:fillRef idx="3">
+            <a:schemeClr val="accent1"/>
+          </a:fillRef>
+          <a:effectRef idx="2">
+            <a:schemeClr val="accent1"/>
+          </a:effectRef>
+          <a:fontRef idx="minor">
+            <a:schemeClr val="lt1"/>
+          </a:fontRef>
+        </p:style>
+        <p:txBody>
+          <a:bodyPr rtlCol="0" anchor="ctr" lIns="90000" tIns="45000" rIns="90000" bIns="45000" wrap="square"/>
+          <a:lstStyle/>
+          <a:p>
+            <a:pPr algn="ctr"/>
+            <a:r>
+              <a:rPr sz="1050" b="1" lang="ca-ES">
+                <a:solidFill>
+                  <a:srgbClr val="2A5C84"/>
+                </a:solidFill>
+                <a:latin typeface="Arial"/>
+              </a:rPr>
+              <a:t>Després: professor</a:t>
+            </a:r>
+          </a:p>
+        </p:txBody>
+      </p:sp>
+      <p:sp>
+        <p:nvSpPr>
+          <p:cNvPr id="10" name="Pindola rol"/>
+          <p:cNvSpPr/>
+          <p:nvPr/>
+        </p:nvSpPr>
+        <p:spPr>
+          <a:xfrm>
+            <a:off x="6144768" y="1691640"/>
+            <a:ext cx="4663440" cy="384048"/>
+          </a:xfrm>
+          <a:prstGeom prst="rect">
+            <a:avLst/>
+          </a:prstGeom>
+          <a:solidFill>
+            <a:srgbClr val="FFFFFF"/>
+          </a:solidFill>
+          <a:ln>
+            <a:solidFill>
+              <a:srgbClr val="D3DAE2"/>
+            </a:solidFill>
+          </a:ln>
+          <a:effectLst>
+            <a:outerShdw blurRad="39960" dist="23040" dir="5400000" rotWithShape="0">
+              <a:srgbClr val="000000">
+                <a:alpha val="35000"/>
+              </a:srgbClr>
+            </a:outerShdw>
+          </a:effectLst>
+        </p:spPr>
+        <p:style>
+          <a:lnRef idx="1">
+            <a:schemeClr val="accent1"/>
+          </a:lnRef>
+          <a:fillRef idx="3">
+            <a:schemeClr val="accent1"/>
+          </a:fillRef>
+          <a:effectRef idx="2">
+            <a:schemeClr val="accent1"/>
+          </a:effectRef>
+          <a:fontRef idx="minor">
+            <a:schemeClr val="lt1"/>
+          </a:fontRef>
+        </p:style>
+        <p:txBody>
+          <a:bodyPr rtlCol="0" anchor="ctr" lIns="90000" tIns="45000" rIns="90000" bIns="45000" wrap="square"/>
+          <a:lstStyle/>
+          <a:p>
+            <a:pPr algn="ctr"/>
+            <a:r>
+              <a:rPr sz="1050" b="1" lang="ca-ES">
+                <a:solidFill>
+                  <a:srgbClr val="2A5C84"/>
+                </a:solidFill>
+                <a:latin typeface="Arial"/>
+              </a:rPr>
+              <a:t>Avui: investigador en Educació en Enginyeria del Software</a:t>
+            </a:r>
+          </a:p>
+        </p:txBody>
+      </p:sp>
+      <p:cxnSp>
+        <p:nvCxnSpPr>
+          <p:cNvPr id="11" name="Connector 10"/>
+          <p:cNvCxnSpPr/>
+          <p:nvPr/>
+        </p:nvCxnSpPr>
+        <p:spPr>
+          <a:xfrm>
+            <a:off x="3813048" y="1883664"/>
+            <a:ext cx="320039" cy="0"/>
+          </a:xfrm>
+          <a:prstGeom prst="line">
+            <a:avLst/>
+          </a:prstGeom>
+          <a:ln w="22860">
+            <a:solidFill>
+              <a:srgbClr val="D1891F"/>
+            </a:solidFill>
+          </a:ln>
+        </p:spPr>
+        <p:style>
+          <a:lnRef idx="2">
+            <a:schemeClr val="accent1"/>
+          </a:lnRef>
+          <a:fillRef idx="0">
+            <a:schemeClr val="accent1"/>
+          </a:fillRef>
+          <a:effectRef idx="1">
+            <a:schemeClr val="accent1"/>
+          </a:effectRef>
+          <a:fontRef idx="minor">
+            <a:schemeClr val="tx1"/>
+          </a:fontRef>
+        </p:style>
+      </p:cxnSp>
+      <p:cxnSp>
+        <p:nvCxnSpPr>
+          <p:cNvPr id="12" name="Connector 11"/>
+          <p:cNvCxnSpPr/>
+          <p:nvPr/>
+        </p:nvCxnSpPr>
+        <p:spPr>
+          <a:xfrm>
+            <a:off x="5824728" y="1883664"/>
+            <a:ext cx="320040" cy="0"/>
+          </a:xfrm>
+          <a:prstGeom prst="line">
+            <a:avLst/>
+          </a:prstGeom>
+          <a:ln w="22860">
+            <a:solidFill>
+              <a:srgbClr val="D1891F"/>
+            </a:solidFill>
+          </a:ln>
+        </p:spPr>
+        <p:style>
+          <a:lnRef idx="2">
+            <a:schemeClr val="accent1"/>
+          </a:lnRef>
+          <a:fillRef idx="0">
+            <a:schemeClr val="accent1"/>
+          </a:fillRef>
+          <a:effectRef idx="1">
+            <a:schemeClr val="accent1"/>
+          </a:effectRef>
+          <a:fontRef idx="minor">
+            <a:schemeClr val="tx1"/>
+          </a:fontRef>
+        </p:style>
+      </p:cxnSp>
+      <p:sp>
+        <p:nvSpPr>
+          <p:cNvPr id="13" name="Etiqueta recorregut"/>
+          <p:cNvSpPr txBox="1"/>
+          <p:nvPr/>
+        </p:nvSpPr>
+        <p:spPr>
+          <a:xfrm>
+            <a:off x="914400" y="2560320"/>
+            <a:ext cx="10360152" cy="274320"/>
+          </a:xfrm>
+          <a:prstGeom prst="rect">
+            <a:avLst/>
+          </a:prstGeom>
+          <a:noFill/>
+        </p:spPr>
+        <p:txBody>
+          <a:bodyPr wrap="square" lIns="90000" tIns="45000" rIns="90000" bIns="45000">
+            <a:spAutoFit/>
+          </a:bodyPr>
+          <a:lstStyle/>
+          <a:p>
+            <a:pPr algn="ctr"/>
+            <a:r>
+              <a:rPr sz="1200" b="1" lang="ca-ES">
+                <a:solidFill>
+                  <a:srgbClr val="2A5C84"/>
+                </a:solidFill>
+                <a:latin typeface="Arial"/>
+              </a:rPr>
+              <a:t>El recorregut de la presentació</a:t>
+            </a:r>
+          </a:p>
+        </p:txBody>
+      </p:sp>
+      <p:sp>
+        <p:nvSpPr>
+          <p:cNvPr id="14" name="Etapa recorregut"/>
+          <p:cNvSpPr/>
+          <p:nvPr/>
+        </p:nvSpPr>
+        <p:spPr>
+          <a:xfrm>
+            <a:off x="886968" y="2971800"/>
+            <a:ext cx="1828800" cy="1188720"/>
+          </a:xfrm>
+          <a:prstGeom prst="rect">
+            <a:avLst/>
+          </a:prstGeom>
+          <a:solidFill>
+            <a:srgbClr val="E8F1F8"/>
+          </a:solidFill>
+          <a:ln>
+            <a:solidFill>
+              <a:srgbClr val="D3DAE2"/>
+            </a:solidFill>
+          </a:ln>
+          <a:effectLst>
+            <a:outerShdw blurRad="39960" dist="23040" dir="5400000" rotWithShape="0">
+              <a:srgbClr val="000000">
+                <a:alpha val="35000"/>
+              </a:srgbClr>
+            </a:outerShdw>
+          </a:effectLst>
+        </p:spPr>
+        <p:style>
+          <a:lnRef idx="1">
+            <a:schemeClr val="accent1"/>
+          </a:lnRef>
+          <a:fillRef idx="3">
+            <a:schemeClr val="accent1"/>
+          </a:fillRef>
+          <a:effectRef idx="2">
+            <a:schemeClr val="accent1"/>
+          </a:effectRef>
+          <a:fontRef idx="minor">
+            <a:schemeClr val="lt1"/>
+          </a:fontRef>
+        </p:style>
+        <p:txBody>
+          <a:bodyPr rtlCol="0" anchor="ctr" lIns="90000" tIns="45000" rIns="90000" bIns="45000" wrap="square"/>
+          <a:lstStyle/>
+          <a:p>
+            <a:pPr algn="ctr"/>
+            <a:r>
+              <a:rPr sz="1350" b="1" lang="ca-ES">
+                <a:solidFill>
+                  <a:srgbClr val="1C2B3B"/>
+                </a:solidFill>
+                <a:latin typeface="Arial"/>
+              </a:rPr>
+              <a:t>Base professional</a:t>
+            </a:r>
+          </a:p>
+          <a:p>
+            <a:pPr algn="ctr"/>
+            <a:r>
+              <a:rPr sz="1150" b="0" lang="ca-ES">
+                <a:solidFill>
+                  <a:srgbClr val="2D343C"/>
+                </a:solidFill>
+                <a:latin typeface="Arial"/>
+              </a:rPr>
+              <a:t>indústria i consultoria</a:t>
+            </a:r>
+          </a:p>
+        </p:txBody>
+      </p:sp>
+      <p:sp>
+        <p:nvSpPr>
+          <p:cNvPr id="15" name="Etapa recorregut"/>
+          <p:cNvSpPr/>
+          <p:nvPr/>
+        </p:nvSpPr>
+        <p:spPr>
+          <a:xfrm>
+            <a:off x="3035808" y="2971800"/>
+            <a:ext cx="1828800" cy="1188720"/>
+          </a:xfrm>
+          <a:prstGeom prst="rect">
+            <a:avLst/>
+          </a:prstGeom>
+          <a:solidFill>
+            <a:srgbClr val="E8F1F8"/>
+          </a:solidFill>
+          <a:ln>
+            <a:solidFill>
+              <a:srgbClr val="D3DAE2"/>
+            </a:solidFill>
+          </a:ln>
+          <a:effectLst>
+            <a:outerShdw blurRad="39960" dist="23040" dir="5400000" rotWithShape="0">
+              <a:srgbClr val="000000">
+                <a:alpha val="35000"/>
+              </a:srgbClr>
+            </a:outerShdw>
+          </a:effectLst>
+        </p:spPr>
+        <p:style>
+          <a:lnRef idx="1">
+            <a:schemeClr val="accent1"/>
+          </a:lnRef>
+          <a:fillRef idx="3">
+            <a:schemeClr val="accent1"/>
+          </a:fillRef>
+          <a:effectRef idx="2">
+            <a:schemeClr val="accent1"/>
+          </a:effectRef>
+          <a:fontRef idx="minor">
+            <a:schemeClr val="lt1"/>
+          </a:fontRef>
+        </p:style>
+        <p:txBody>
+          <a:bodyPr rtlCol="0" anchor="ctr" lIns="90000" tIns="45000" rIns="90000" bIns="45000" wrap="square"/>
+          <a:lstStyle/>
+          <a:p>
+            <a:pPr algn="ctr"/>
+            <a:r>
+              <a:rPr sz="1350" b="1" lang="ca-ES">
+                <a:solidFill>
+                  <a:srgbClr val="1C2B3B"/>
+                </a:solidFill>
+                <a:latin typeface="Arial"/>
+              </a:rPr>
+              <a:t>Vocació docent</a:t>
+            </a:r>
+          </a:p>
+          <a:p>
+            <a:pPr algn="ctr"/>
+            <a:r>
+              <a:rPr sz="1150" b="0" lang="ca-ES">
+                <a:solidFill>
+                  <a:srgbClr val="2D343C"/>
+                </a:solidFill>
+                <a:latin typeface="Arial"/>
+              </a:rPr>
+              <a:t>Formació Professional</a:t>
+            </a:r>
+          </a:p>
+        </p:txBody>
+      </p:sp>
+      <p:cxnSp>
+        <p:nvCxnSpPr>
+          <p:cNvPr id="16" name="Connector 15"/>
+          <p:cNvCxnSpPr/>
+          <p:nvPr/>
+        </p:nvCxnSpPr>
+        <p:spPr>
+          <a:xfrm>
+            <a:off x="2715768" y="3566160"/>
+            <a:ext cx="320040" cy="0"/>
+          </a:xfrm>
+          <a:prstGeom prst="line">
+            <a:avLst/>
+          </a:prstGeom>
+          <a:ln w="22860">
+            <a:solidFill>
+              <a:srgbClr val="D1891F"/>
+            </a:solidFill>
+          </a:ln>
+        </p:spPr>
+        <p:style>
+          <a:lnRef idx="2">
+            <a:schemeClr val="accent1"/>
+          </a:lnRef>
+          <a:fillRef idx="0">
+            <a:schemeClr val="accent1"/>
+          </a:fillRef>
+          <a:effectRef idx="1">
+            <a:schemeClr val="accent1"/>
+          </a:effectRef>
+          <a:fontRef idx="minor">
+            <a:schemeClr val="tx1"/>
+          </a:fontRef>
+        </p:style>
+      </p:cxnSp>
+      <p:sp>
+        <p:nvSpPr>
+          <p:cNvPr id="17" name="Etapa recorregut"/>
+          <p:cNvSpPr/>
+          <p:nvPr/>
+        </p:nvSpPr>
+        <p:spPr>
+          <a:xfrm>
+            <a:off x="5184648" y="2971800"/>
+            <a:ext cx="1828800" cy="1188720"/>
+          </a:xfrm>
+          <a:prstGeom prst="rect">
+            <a:avLst/>
+          </a:prstGeom>
+          <a:solidFill>
+            <a:srgbClr val="E8F1F8"/>
+          </a:solidFill>
+          <a:ln>
+            <a:solidFill>
+              <a:srgbClr val="D3DAE2"/>
+            </a:solidFill>
+          </a:ln>
+          <a:effectLst>
+            <a:outerShdw blurRad="39960" dist="23040" dir="5400000" rotWithShape="0">
+              <a:srgbClr val="000000">
+                <a:alpha val="35000"/>
+              </a:srgbClr>
+            </a:outerShdw>
+          </a:effectLst>
+        </p:spPr>
+        <p:style>
+          <a:lnRef idx="1">
+            <a:schemeClr val="accent1"/>
+          </a:lnRef>
+          <a:fillRef idx="3">
+            <a:schemeClr val="accent1"/>
+          </a:fillRef>
+          <a:effectRef idx="2">
+            <a:schemeClr val="accent1"/>
+          </a:effectRef>
+          <a:fontRef idx="minor">
+            <a:schemeClr val="lt1"/>
+          </a:fontRef>
+        </p:style>
+        <p:txBody>
+          <a:bodyPr rtlCol="0" anchor="ctr" lIns="90000" tIns="45000" rIns="90000" bIns="45000" wrap="square"/>
+          <a:lstStyle/>
+          <a:p>
+            <a:pPr algn="ctr"/>
+            <a:r>
+              <a:rPr sz="1350" b="1" lang="ca-ES">
+                <a:solidFill>
+                  <a:srgbClr val="1C2B3B"/>
+                </a:solidFill>
+                <a:latin typeface="Arial"/>
+              </a:rPr>
+              <a:t>Universitat</a:t>
+            </a:r>
+          </a:p>
+          <a:p>
+            <a:pPr algn="ctr"/>
+            <a:r>
+              <a:rPr sz="1150" b="0" lang="ca-ES">
+                <a:solidFill>
+                  <a:srgbClr val="2D343C"/>
+                </a:solidFill>
+                <a:latin typeface="Arial"/>
+              </a:rPr>
+              <a:t>La Salle</a:t>
+            </a:r>
+          </a:p>
+        </p:txBody>
+      </p:sp>
+      <p:cxnSp>
+        <p:nvCxnSpPr>
+          <p:cNvPr id="18" name="Connector 17"/>
+          <p:cNvCxnSpPr/>
+          <p:nvPr/>
+        </p:nvCxnSpPr>
+        <p:spPr>
+          <a:xfrm>
+            <a:off x="4864608" y="3566160"/>
+            <a:ext cx="320040" cy="0"/>
+          </a:xfrm>
+          <a:prstGeom prst="line">
+            <a:avLst/>
+          </a:prstGeom>
+          <a:ln w="22860">
+            <a:solidFill>
+              <a:srgbClr val="D1891F"/>
+            </a:solidFill>
+          </a:ln>
+        </p:spPr>
+        <p:style>
+          <a:lnRef idx="2">
+            <a:schemeClr val="accent1"/>
+          </a:lnRef>
+          <a:fillRef idx="0">
+            <a:schemeClr val="accent1"/>
+          </a:fillRef>
+          <a:effectRef idx="1">
+            <a:schemeClr val="accent1"/>
+          </a:effectRef>
+          <a:fontRef idx="minor">
+            <a:schemeClr val="tx1"/>
+          </a:fontRef>
+        </p:style>
+      </p:cxnSp>
+      <p:sp>
+        <p:nvSpPr>
+          <p:cNvPr id="19" name="Etapa recorregut"/>
+          <p:cNvSpPr/>
+          <p:nvPr/>
+        </p:nvSpPr>
+        <p:spPr>
+          <a:xfrm>
+            <a:off x="7333488" y="2971800"/>
+            <a:ext cx="1828800" cy="1188720"/>
+          </a:xfrm>
+          <a:prstGeom prst="rect">
+            <a:avLst/>
+          </a:prstGeom>
+          <a:solidFill>
+            <a:srgbClr val="E8F1F8"/>
+          </a:solidFill>
+          <a:ln>
+            <a:solidFill>
+              <a:srgbClr val="D3DAE2"/>
+            </a:solidFill>
+          </a:ln>
+          <a:effectLst>
+            <a:outerShdw blurRad="39960" dist="23040" dir="5400000" rotWithShape="0">
+              <a:srgbClr val="000000">
+                <a:alpha val="35000"/>
+              </a:srgbClr>
+            </a:outerShdw>
+          </a:effectLst>
+        </p:spPr>
+        <p:style>
+          <a:lnRef idx="1">
+            <a:schemeClr val="accent1"/>
+          </a:lnRef>
+          <a:fillRef idx="3">
+            <a:schemeClr val="accent1"/>
+          </a:fillRef>
+          <a:effectRef idx="2">
+            <a:schemeClr val="accent1"/>
+          </a:effectRef>
+          <a:fontRef idx="minor">
+            <a:schemeClr val="lt1"/>
+          </a:fontRef>
+        </p:style>
+        <p:txBody>
+          <a:bodyPr rtlCol="0" anchor="ctr" lIns="90000" tIns="45000" rIns="90000" bIns="45000" wrap="square"/>
+          <a:lstStyle/>
+          <a:p>
+            <a:pPr algn="ctr"/>
+            <a:r>
+              <a:rPr sz="1350" b="1" lang="ca-ES">
+                <a:solidFill>
+                  <a:srgbClr val="1C2B3B"/>
+                </a:solidFill>
+                <a:latin typeface="Arial"/>
+              </a:rPr>
+              <a:t>Consolidació</a:t>
+            </a:r>
+          </a:p>
+          <a:p>
+            <a:pPr algn="ctr"/>
+            <a:r>
+              <a:rPr sz="1150" b="0" lang="ca-ES">
+                <a:solidFill>
+                  <a:srgbClr val="2D343C"/>
+                </a:solidFill>
+                <a:latin typeface="Arial"/>
+              </a:rPr>
+              <a:t>TecnoCampus</a:t>
+            </a:r>
+          </a:p>
+        </p:txBody>
+      </p:sp>
+      <p:cxnSp>
+        <p:nvCxnSpPr>
+          <p:cNvPr id="20" name="Connector 19"/>
+          <p:cNvCxnSpPr/>
+          <p:nvPr/>
+        </p:nvCxnSpPr>
+        <p:spPr>
+          <a:xfrm>
+            <a:off x="7013448" y="3566160"/>
+            <a:ext cx="320040" cy="0"/>
+          </a:xfrm>
+          <a:prstGeom prst="line">
+            <a:avLst/>
+          </a:prstGeom>
+          <a:ln w="22860">
+            <a:solidFill>
+              <a:srgbClr val="D1891F"/>
+            </a:solidFill>
+          </a:ln>
+        </p:spPr>
+        <p:style>
+          <a:lnRef idx="2">
+            <a:schemeClr val="accent1"/>
+          </a:lnRef>
+          <a:fillRef idx="0">
+            <a:schemeClr val="accent1"/>
+          </a:fillRef>
+          <a:effectRef idx="1">
+            <a:schemeClr val="accent1"/>
+          </a:effectRef>
+          <a:fontRef idx="minor">
+            <a:schemeClr val="tx1"/>
+          </a:fontRef>
+        </p:style>
+      </p:cxnSp>
+      <p:sp>
+        <p:nvSpPr>
+          <p:cNvPr id="21" name="Etapa recorregut"/>
+          <p:cNvSpPr/>
+          <p:nvPr/>
+        </p:nvSpPr>
+        <p:spPr>
+          <a:xfrm>
+            <a:off x="9482328" y="2971800"/>
+            <a:ext cx="1828800" cy="1188720"/>
+          </a:xfrm>
+          <a:prstGeom prst="rect">
+            <a:avLst/>
+          </a:prstGeom>
+          <a:solidFill>
+            <a:srgbClr val="E8F1F8"/>
+          </a:solidFill>
+          <a:ln>
+            <a:solidFill>
+              <a:srgbClr val="D3DAE2"/>
+            </a:solidFill>
+          </a:ln>
+          <a:effectLst>
+            <a:outerShdw blurRad="39960" dist="23040" dir="5400000" rotWithShape="0">
+              <a:srgbClr val="000000">
+                <a:alpha val="35000"/>
+              </a:srgbClr>
+            </a:outerShdw>
+          </a:effectLst>
+        </p:spPr>
+        <p:style>
+          <a:lnRef idx="1">
+            <a:schemeClr val="accent1"/>
+          </a:lnRef>
+          <a:fillRef idx="3">
+            <a:schemeClr val="accent1"/>
+          </a:fillRef>
+          <a:effectRef idx="2">
+            <a:schemeClr val="accent1"/>
+          </a:effectRef>
+          <a:fontRef idx="minor">
+            <a:schemeClr val="lt1"/>
+          </a:fontRef>
+        </p:style>
+        <p:txBody>
+          <a:bodyPr rtlCol="0" anchor="ctr" lIns="90000" tIns="45000" rIns="90000" bIns="45000" wrap="square"/>
+          <a:lstStyle/>
+          <a:p>
+            <a:pPr algn="ctr"/>
+            <a:r>
+              <a:rPr sz="1350" b="1" lang="ca-ES">
+                <a:solidFill>
+                  <a:srgbClr val="1C2B3B"/>
+                </a:solidFill>
+                <a:latin typeface="Arial"/>
+              </a:rPr>
+              <a:t>Projecte de futur</a:t>
+            </a:r>
+          </a:p>
+          <a:p>
+            <a:pPr algn="ctr"/>
+            <a:r>
+              <a:rPr sz="1150" b="0" lang="ca-ES">
+                <a:solidFill>
+                  <a:srgbClr val="2D343C"/>
+                </a:solidFill>
+                <a:latin typeface="Arial"/>
+              </a:rPr>
+              <a:t>recerca doctoral</a:t>
+            </a:r>
+          </a:p>
+        </p:txBody>
+      </p:sp>
+      <p:cxnSp>
+        <p:nvCxnSpPr>
+          <p:cNvPr id="22" name="Connector 21"/>
+          <p:cNvCxnSpPr/>
+          <p:nvPr/>
+        </p:nvCxnSpPr>
+        <p:spPr>
+          <a:xfrm>
+            <a:off x="9162288" y="3566160"/>
+            <a:ext cx="320040" cy="0"/>
+          </a:xfrm>
+          <a:prstGeom prst="line">
+            <a:avLst/>
+          </a:prstGeom>
+          <a:ln w="22860">
+            <a:solidFill>
+              <a:srgbClr val="D1891F"/>
+            </a:solidFill>
+          </a:ln>
+        </p:spPr>
+        <p:style>
+          <a:lnRef idx="2">
+            <a:schemeClr val="accent1"/>
+          </a:lnRef>
+          <a:fillRef idx="0">
+            <a:schemeClr val="accent1"/>
+          </a:fillRef>
+          <a:effectRef idx="1">
+            <a:schemeClr val="accent1"/>
+          </a:effectRef>
+          <a:fontRef idx="minor">
+            <a:schemeClr val="tx1"/>
+          </a:fontRef>
+        </p:style>
+      </p:cxnSp>
+      <p:sp>
+        <p:nvSpPr>
+          <p:cNvPr id="23" name="Missatge"/>
+          <p:cNvSpPr txBox="1"/>
+          <p:nvPr/>
+        </p:nvSpPr>
+        <p:spPr>
+          <a:xfrm>
+            <a:off x="914400" y="5120640"/>
+            <a:ext cx="10360152" cy="411480"/>
+          </a:xfrm>
+          <a:prstGeom prst="rect">
+            <a:avLst/>
+          </a:prstGeom>
+          <a:noFill/>
+        </p:spPr>
+        <p:txBody>
+          <a:bodyPr wrap="square" lIns="90000" tIns="45000" rIns="90000" bIns="45000">
+            <a:spAutoFit/>
+          </a:bodyPr>
+          <a:lstStyle/>
+          <a:p>
+            <a:pPr algn="ctr"/>
+            <a:r>
+              <a:rPr sz="1600" b="1" lang="ca-ES">
+                <a:solidFill>
+                  <a:srgbClr val="1C2B3B"/>
+                </a:solidFill>
+                <a:latin typeface="Arial"/>
+              </a:rPr>
+              <a:t>Una trajectòria coherent amb la plaça de professorat permanent.</a:t>
+            </a:r>
+          </a:p>
+        </p:txBody>
+      </p:sp>
+      <p:sp>
+        <p:nvSpPr>
+          <p:cNvPr id="24" name="Peu"/>
+          <p:cNvSpPr txBox="1"/>
+          <p:nvPr/>
+        </p:nvSpPr>
+        <p:spPr>
+          <a:xfrm>
+            <a:off x="640080" y="6446520"/>
+            <a:ext cx="8869680" cy="201168"/>
+          </a:xfrm>
+          <a:prstGeom prst="rect">
+            <a:avLst/>
+          </a:prstGeom>
+          <a:noFill/>
+        </p:spPr>
+        <p:txBody>
+          <a:bodyPr wrap="square" lIns="90000" tIns="45000" rIns="90000" bIns="45000">
+            <a:spAutoFit/>
+          </a:bodyPr>
+          <a:lstStyle/>
+          <a:p>
+            <a:pPr/>
+            <a:r>
+              <a:rPr sz="860" b="0" lang="ca-ES">
+                <a:solidFill>
+                  <a:srgbClr val="67717C"/>
+                </a:solidFill>
+                <a:latin typeface="Arial"/>
+              </a:rPr>
+              <a:t>Trajectòria professional, acadèmica i científica · Defensa de plaça de professorat permanent</a:t>
+            </a:r>
+          </a:p>
+        </p:txBody>
+      </p:sp>
+      <p:sp>
+        <p:nvSpPr>
+          <p:cNvPr id="25" name="Numero"/>
+          <p:cNvSpPr txBox="1"/>
+          <p:nvPr/>
+        </p:nvSpPr>
+        <p:spPr>
+          <a:xfrm>
+            <a:off x="11018520" y="6446520"/>
+            <a:ext cx="320040" cy="201168"/>
+          </a:xfrm>
+          <a:prstGeom prst="rect">
+            <a:avLst/>
+          </a:prstGeom>
+          <a:noFill/>
+        </p:spPr>
+        <p:txBody>
+          <a:bodyPr wrap="square" lIns="90000" tIns="45000" rIns="90000" bIns="45000">
+            <a:spAutoFit/>
+          </a:bodyPr>
+          <a:lstStyle/>
+          <a:p>
+            <a:pPr algn="r"/>
+            <a:r>
+              <a:rPr sz="860" b="0" lang="ca-ES">
+                <a:solidFill>
+                  <a:srgbClr val="67717C"/>
+                </a:solidFill>
+                <a:latin typeface="Arial"/>
+              </a:rPr>
+              <a:t>2</a:t>
+            </a:r>
+          </a:p>
+        </p:txBody>
+      </p:sp>
+    </p:spTree>
+  </p:cSld>
+  <p:clrMapOvr>
+    <a:masterClrMapping/>
+  </p:clrMapOvr>
+</p:sld>
+</file>
+
 <file path=ppt/theme/theme1.xml><?xml version="1.0" encoding="utf-8"?>
 <a:theme xmlns:a="http://schemas.openxmlformats.org/drawingml/2006/main" name="Office Theme">
   <a:themeElements>

</xml_diff>

<commit_message>
Revert "Insereix la diapositiva d'introducció al deck de trajectòria i renumera el guió"
This reverts commit 3e56ac70a2709e3653b0af28ee7a2525ff6a8569.
</commit_message>
<xml_diff>
--- a/doc/presentations/defensa-placa-permanent-dsi-ports-sortida-hexagonal/output/defensa-trajectoria-10-minuts.pptx
+++ b/doc/presentations/defensa-placa-permanent-dsi-ports-sortida-hexagonal/output/defensa-trajectoria-10-minuts.pptx
@@ -9,7 +9,6 @@
   </p:notesMasterIdLst>
   <p:sldIdLst>
     <p:sldId id="256" r:id="rId2"/>
-    <p:sldId id="263" r:id="rId14"/>
     <p:sldId id="257" r:id="rId3"/>
     <p:sldId id="258" r:id="rId4"/>
     <p:sldId id="259" r:id="rId5"/>
@@ -629,18 +628,79 @@
           </a:bodyPr>
           <a:lstStyle/>
           <a:p>
-            <a:r>
-              <a:t>Portada i benvinguda. Agrair breument al tribunal.</a:t>
-            </a:r>
-          </a:p>
-          <a:p>
-            <a:r>
-              <a:t>Només salutació: la introducció s’explica amb la diapositiva següent.</a:t>
-            </a:r>
-          </a:p>
-          <a:p>
-            <a:r>
-              <a:t>Transició: avançar a la diapositiva del fil conductor.</a:t>
+            <a:pPr indent="0" algn="l">
+              <a:lnSpc>
+                <a:spcPct val="100000"/>
+              </a:lnSpc>
+              <a:buNone/>
+            </a:pPr>
+            <a:r>
+              <a:rPr lang="es-ES" sz="2000" b="0" u="none" strike="noStrike">
+                <a:solidFill>
+                  <a:srgbClr val="000000"/>
+                </a:solidFill>
+                <a:effectLst/>
+                <a:uFillTx/>
+                <a:latin typeface="Arial"/>
+              </a:rPr>
+              <a:t>Agrair breument al tribunal.</a:t>
+            </a:r>
+          </a:p>
+          <a:p>
+            <a:pPr indent="0" algn="l">
+              <a:lnSpc>
+                <a:spcPct val="100000"/>
+              </a:lnSpc>
+              <a:buNone/>
+            </a:pPr>
+            <a:r>
+              <a:rPr lang="es-ES" sz="2000" b="0" u="none" strike="noStrike">
+                <a:solidFill>
+                  <a:srgbClr val="000000"/>
+                </a:solidFill>
+                <a:effectLst/>
+                <a:uFillTx/>
+                <a:latin typeface="Arial"/>
+              </a:rPr>
+              <a:t>No llegir el CV: explicar el fil conductor.</a:t>
+            </a:r>
+          </a:p>
+          <a:p>
+            <a:pPr indent="0" algn="l">
+              <a:lnSpc>
+                <a:spcPct val="100000"/>
+              </a:lnSpc>
+              <a:buNone/>
+            </a:pPr>
+            <a:r>
+              <a:rPr lang="es-ES" sz="2000" b="0" u="none" strike="noStrike">
+                <a:solidFill>
+                  <a:srgbClr val="000000"/>
+                </a:solidFill>
+                <a:effectLst/>
+                <a:uFillTx/>
+                <a:latin typeface="Arial"/>
+              </a:rPr>
+              <a:t>Idees: 2004, indústria del software, docència universitària en software, innovació, transferència, recerca i TecnoCampus.</a:t>
+            </a:r>
+          </a:p>
+          <a:p>
+            <a:pPr indent="0" algn="l">
+              <a:lnSpc>
+                <a:spcPct val="100000"/>
+              </a:lnSpc>
+              <a:buNone/>
+            </a:pPr>
+            <a:r>
+              <a:rPr lang="es-ES" sz="2000" b="0" u="none" strike="noStrike">
+                <a:solidFill>
+                  <a:srgbClr val="000000"/>
+                </a:solidFill>
+                <a:effectLst/>
+                <a:uFillTx/>
+                <a:latin typeface="Arial"/>
+              </a:rPr>
+              <a:t>Transició: començar per la base professional en indústria del software.</a:t>
             </a:r>
           </a:p>
         </p:txBody>
@@ -2735,96 +2795,6 @@
             </a:r>
           </a:p>
         </p:txBody>
-      </p:sp>
-    </p:spTree>
-  </p:cSld>
-  <p:clrMapOvr>
-    <a:masterClrMapping/>
-  </p:clrMapOvr>
-</p:notes>
-</file>
-
-<file path=ppt/notesSlides/notesSlide8.xml><?xml version="1.0" encoding="utf-8"?>
-<p:notes xmlns:a="http://schemas.openxmlformats.org/drawingml/2006/main" xmlns:p="http://schemas.openxmlformats.org/presentationml/2006/main" xmlns:r="http://schemas.openxmlformats.org/officeDocument/2006/relationships">
-  <p:cSld>
-    <p:spTree>
-      <p:nvGrpSpPr>
-        <p:cNvPr id="1" name=""/>
-        <p:cNvGrpSpPr/>
-        <p:nvPr/>
-      </p:nvGrpSpPr>
-      <p:grpSpPr>
-        <a:xfrm>
-          <a:off x="0" y="0"/>
-          <a:ext cx="0" cy="0"/>
-          <a:chOff x="0" y="0"/>
-          <a:chExt cx="0" cy="0"/>
-        </a:xfrm>
-      </p:grpSpPr>
-      <p:sp>
-        <p:nvSpPr>
-          <p:cNvPr id="2" name="Slide Image Placeholder 1"/>
-          <p:cNvSpPr>
-            <a:spLocks noGrp="1"/>
-          </p:cNvSpPr>
-          <p:nvPr>
-            <p:ph type="sldImg"/>
-          </p:nvPr>
-        </p:nvSpPr>
-        <p:spPr/>
-      </p:sp>
-      <p:sp>
-        <p:nvSpPr>
-          <p:cNvPr id="3" name="Notes Placeholder 2"/>
-          <p:cNvSpPr>
-            <a:spLocks noGrp="1"/>
-          </p:cNvSpPr>
-          <p:nvPr>
-            <p:ph type="body"/>
-          </p:nvPr>
-        </p:nvSpPr>
-        <p:spPr/>
-        <p:txBody>
-          <a:bodyPr/>
-          <a:lstStyle/>
-          <a:p>
-            <a:r>
-              <a:t>No llegir el CV: explicar el fil conductor.</a:t>
-            </a:r>
-          </a:p>
-          <a:p>
-            <a:r>
-              <a:t>Idees: 2004, indústria del software, docència universitària en software, innovació, transferència, recerca i TecnoCampus.</a:t>
-            </a:r>
-          </a:p>
-          <a:p>
-            <a:r>
-              <a:t>Recorregut: base professional, vocació docent, pas a la universitat, consolidació al TecnoCampus i projecte de futur.</a:t>
-            </a:r>
-          </a:p>
-          <a:p>
-            <a:r>
-              <a:t>És suport visual de la introducció, no un bloc nou: no allargar.</a:t>
-            </a:r>
-          </a:p>
-          <a:p>
-            <a:r>
-              <a:t>Transició: començar per la base professional en indústria del software.</a:t>
-            </a:r>
-          </a:p>
-        </p:txBody>
-      </p:sp>
-      <p:sp>
-        <p:nvSpPr>
-          <p:cNvPr id="4" name="Slide Number Placeholder 3"/>
-          <p:cNvSpPr>
-            <a:spLocks noGrp="1"/>
-          </p:cNvSpPr>
-          <p:nvPr>
-            <p:ph type="sldNum" idx="36"/>
-          </p:nvPr>
-        </p:nvSpPr>
-        <p:spPr/>
       </p:sp>
     </p:spTree>
   </p:cSld>
@@ -13572,7 +13542,7 @@
                 <a:uFillTx/>
                 <a:latin typeface="Arial"/>
               </a:rPr>
-              <a:t>3</a:t>
+              <a:t>2</a:t>
             </a:r>
             <a:endParaRPr lang="es-ES" sz="860" b="0" u="none" strike="noStrike">
               <a:solidFill>
@@ -14845,7 +14815,7 @@
                 <a:uFillTx/>
                 <a:latin typeface="Arial"/>
               </a:rPr>
-              <a:t>4</a:t>
+              <a:t>3</a:t>
             </a:r>
             <a:endParaRPr lang="es-ES" sz="860" b="0" u="none" strike="noStrike">
               <a:solidFill>
@@ -16815,7 +16785,7 @@
                 <a:uFillTx/>
                 <a:latin typeface="Arial"/>
               </a:rPr>
-              <a:t>5</a:t>
+              <a:t>4</a:t>
             </a:r>
             <a:endParaRPr lang="es-ES" sz="860" b="0" u="none" strike="noStrike">
               <a:solidFill>
@@ -18853,7 +18823,7 @@
                 <a:uFillTx/>
                 <a:latin typeface="Arial"/>
               </a:rPr>
-              <a:t>6</a:t>
+              <a:t>5</a:t>
             </a:r>
             <a:endParaRPr lang="es-ES" sz="860" b="0" u="none" strike="noStrike">
               <a:solidFill>
@@ -20578,7 +20548,7 @@
                 <a:uFillTx/>
                 <a:latin typeface="Arial"/>
               </a:rPr>
-              <a:t>7</a:t>
+              <a:t>6</a:t>
             </a:r>
             <a:endParaRPr lang="es-ES" sz="860" b="0" u="none" strike="noStrike">
               <a:solidFill>
@@ -21882,1100 +21852,6 @@
 </p:sld>
 </file>
 
-<file path=ppt/slides/slide8.xml><?xml version="1.0" encoding="utf-8"?>
-<p:sld xmlns:a="http://schemas.openxmlformats.org/drawingml/2006/main" xmlns:p="http://schemas.openxmlformats.org/presentationml/2006/main" xmlns:r="http://schemas.openxmlformats.org/officeDocument/2006/relationships">
-  <p:cSld>
-    <p:spTree>
-      <p:nvGrpSpPr>
-        <p:cNvPr id="1" name=""/>
-        <p:cNvGrpSpPr/>
-        <p:nvPr/>
-      </p:nvGrpSpPr>
-      <p:grpSpPr/>
-      <p:sp>
-        <p:nvSpPr>
-          <p:cNvPr id="2" name="Title 1"/>
-          <p:cNvSpPr>
-            <a:spLocks noGrp="1"/>
-          </p:cNvSpPr>
-          <p:nvPr>
-            <p:ph type="title"/>
-          </p:nvPr>
-        </p:nvSpPr>
-        <p:spPr/>
-        <p:txBody>
-          <a:bodyPr/>
-          <a:lstStyle/>
-          <a:p/>
-        </p:txBody>
-      </p:sp>
-      <p:sp>
-        <p:nvSpPr>
-          <p:cNvPr id="3" name="Text Placeholder 2"/>
-          <p:cNvSpPr>
-            <a:spLocks noGrp="1"/>
-          </p:cNvSpPr>
-          <p:nvPr>
-            <p:ph type="body"/>
-          </p:nvPr>
-        </p:nvSpPr>
-        <p:spPr/>
-        <p:txBody>
-          <a:bodyPr/>
-          <a:lstStyle/>
-          <a:p/>
-        </p:txBody>
-      </p:sp>
-      <p:sp>
-        <p:nvSpPr>
-          <p:cNvPr id="4" name="Titol"/>
-          <p:cNvSpPr txBox="1"/>
-          <p:nvPr/>
-        </p:nvSpPr>
-        <p:spPr>
-          <a:xfrm>
-            <a:off x="640080" y="384048"/>
-            <a:ext cx="8458200" cy="438912"/>
-          </a:xfrm>
-          <a:prstGeom prst="rect">
-            <a:avLst/>
-          </a:prstGeom>
-          <a:noFill/>
-        </p:spPr>
-        <p:txBody>
-          <a:bodyPr wrap="square" lIns="90000" tIns="45000" rIns="90000" bIns="45000">
-            <a:spAutoFit/>
-          </a:bodyPr>
-          <a:lstStyle/>
-          <a:p>
-            <a:pPr/>
-            <a:r>
-              <a:rPr sz="2700" b="1" lang="ca-ES">
-                <a:solidFill>
-                  <a:srgbClr val="1C2B3B"/>
-                </a:solidFill>
-                <a:latin typeface="Arial"/>
-              </a:rPr>
-              <a:t>Un fil conductor: l’enginyeria del software</a:t>
-            </a:r>
-          </a:p>
-        </p:txBody>
-      </p:sp>
-      <p:sp>
-        <p:nvSpPr>
-          <p:cNvPr id="5" name="Subtitol"/>
-          <p:cNvSpPr txBox="1"/>
-          <p:nvPr/>
-        </p:nvSpPr>
-        <p:spPr>
-          <a:xfrm>
-            <a:off x="658368" y="841248"/>
-            <a:ext cx="7955279" cy="292608"/>
-          </a:xfrm>
-          <a:prstGeom prst="rect">
-            <a:avLst/>
-          </a:prstGeom>
-          <a:noFill/>
-        </p:spPr>
-        <p:txBody>
-          <a:bodyPr wrap="square" lIns="90000" tIns="45000" rIns="90000" bIns="45000">
-            <a:spAutoFit/>
-          </a:bodyPr>
-          <a:lstStyle/>
-          <a:p>
-            <a:pPr/>
-            <a:r>
-              <a:rPr sz="1200" b="0" lang="ca-ES">
-                <a:solidFill>
-                  <a:srgbClr val="67717C"/>
-                </a:solidFill>
-                <a:latin typeface="Arial"/>
-              </a:rPr>
-              <a:t>Una trajectòria iniciada el 2004: el recorregut de la presentació</a:t>
-            </a:r>
-          </a:p>
-        </p:txBody>
-      </p:sp>
-      <p:pic>
-        <p:nvPicPr>
-          <p:cNvPr id="6" name="Picture 5" descr="image.png"/>
-          <p:cNvPicPr>
-            <a:picLocks noChangeAspect="1"/>
-          </p:cNvPicPr>
-          <p:nvPr/>
-        </p:nvPicPr>
-        <p:blipFill>
-          <a:blip r:embed="rId2"/>
-          <a:stretch>
-            <a:fillRect/>
-          </a:stretch>
-        </p:blipFill>
-        <p:spPr>
-          <a:xfrm>
-            <a:off x="9372600" y="310896"/>
-            <a:ext cx="1993392" cy="374904"/>
-          </a:xfrm>
-          <a:prstGeom prst="rect">
-            <a:avLst/>
-          </a:prstGeom>
-        </p:spPr>
-      </p:pic>
-      <p:sp>
-        <p:nvSpPr>
-          <p:cNvPr id="7" name="Linia divisoria"/>
-          <p:cNvSpPr/>
-          <p:nvPr/>
-        </p:nvSpPr>
-        <p:spPr>
-          <a:xfrm>
-            <a:off x="640080" y="1115568"/>
-            <a:ext cx="10789920" cy="13320"/>
-          </a:xfrm>
-          <a:prstGeom prst="rect">
-            <a:avLst/>
-          </a:prstGeom>
-          <a:solidFill>
-            <a:srgbClr val="D3DAE2"/>
-          </a:solidFill>
-          <a:ln>
-            <a:noFill/>
-          </a:ln>
-          <a:effectLst>
-            <a:outerShdw blurRad="39960" dist="23040" dir="5400000" rotWithShape="0">
-              <a:srgbClr val="000000">
-                <a:alpha val="35000"/>
-              </a:srgbClr>
-            </a:outerShdw>
-          </a:effectLst>
-        </p:spPr>
-        <p:style>
-          <a:lnRef idx="1">
-            <a:schemeClr val="accent1"/>
-          </a:lnRef>
-          <a:fillRef idx="3">
-            <a:schemeClr val="accent1"/>
-          </a:fillRef>
-          <a:effectRef idx="2">
-            <a:schemeClr val="accent1"/>
-          </a:effectRef>
-          <a:fontRef idx="minor">
-            <a:schemeClr val="lt1"/>
-          </a:fontRef>
-        </p:style>
-        <p:txBody>
-          <a:bodyPr rtlCol="0" anchor="ctr"/>
-          <a:lstStyle/>
-          <a:p>
-            <a:pPr algn="ctr"/>
-          </a:p>
-        </p:txBody>
-      </p:sp>
-      <p:sp>
-        <p:nvSpPr>
-          <p:cNvPr id="8" name="Pindola rol"/>
-          <p:cNvSpPr/>
-          <p:nvPr/>
-        </p:nvSpPr>
-        <p:spPr>
-          <a:xfrm>
-            <a:off x="1389888" y="1691640"/>
-            <a:ext cx="2423160" cy="384048"/>
-          </a:xfrm>
-          <a:prstGeom prst="rect">
-            <a:avLst/>
-          </a:prstGeom>
-          <a:solidFill>
-            <a:srgbClr val="FFFFFF"/>
-          </a:solidFill>
-          <a:ln>
-            <a:solidFill>
-              <a:srgbClr val="D3DAE2"/>
-            </a:solidFill>
-          </a:ln>
-          <a:effectLst>
-            <a:outerShdw blurRad="39960" dist="23040" dir="5400000" rotWithShape="0">
-              <a:srgbClr val="000000">
-                <a:alpha val="35000"/>
-              </a:srgbClr>
-            </a:outerShdw>
-          </a:effectLst>
-        </p:spPr>
-        <p:style>
-          <a:lnRef idx="1">
-            <a:schemeClr val="accent1"/>
-          </a:lnRef>
-          <a:fillRef idx="3">
-            <a:schemeClr val="accent1"/>
-          </a:fillRef>
-          <a:effectRef idx="2">
-            <a:schemeClr val="accent1"/>
-          </a:effectRef>
-          <a:fontRef idx="minor">
-            <a:schemeClr val="lt1"/>
-          </a:fontRef>
-        </p:style>
-        <p:txBody>
-          <a:bodyPr rtlCol="0" anchor="ctr" lIns="90000" tIns="45000" rIns="90000" bIns="45000" wrap="square"/>
-          <a:lstStyle/>
-          <a:p>
-            <a:pPr algn="ctr"/>
-            <a:r>
-              <a:rPr sz="1050" b="1" lang="ca-ES">
-                <a:solidFill>
-                  <a:srgbClr val="2A5C84"/>
-                </a:solidFill>
-                <a:latin typeface="Arial"/>
-              </a:rPr>
-              <a:t>Primer: enginyer a la indústria</a:t>
-            </a:r>
-          </a:p>
-        </p:txBody>
-      </p:sp>
-      <p:sp>
-        <p:nvSpPr>
-          <p:cNvPr id="9" name="Pindola rol"/>
-          <p:cNvSpPr/>
-          <p:nvPr/>
-        </p:nvSpPr>
-        <p:spPr>
-          <a:xfrm>
-            <a:off x="4133087" y="1691640"/>
-            <a:ext cx="1691640" cy="384048"/>
-          </a:xfrm>
-          <a:prstGeom prst="rect">
-            <a:avLst/>
-          </a:prstGeom>
-          <a:solidFill>
-            <a:srgbClr val="FFFFFF"/>
-          </a:solidFill>
-          <a:ln>
-            <a:solidFill>
-              <a:srgbClr val="D3DAE2"/>
-            </a:solidFill>
-          </a:ln>
-          <a:effectLst>
-            <a:outerShdw blurRad="39960" dist="23040" dir="5400000" rotWithShape="0">
-              <a:srgbClr val="000000">
-                <a:alpha val="35000"/>
-              </a:srgbClr>
-            </a:outerShdw>
-          </a:effectLst>
-        </p:spPr>
-        <p:style>
-          <a:lnRef idx="1">
-            <a:schemeClr val="accent1"/>
-          </a:lnRef>
-          <a:fillRef idx="3">
-            <a:schemeClr val="accent1"/>
-          </a:fillRef>
-          <a:effectRef idx="2">
-            <a:schemeClr val="accent1"/>
-          </a:effectRef>
-          <a:fontRef idx="minor">
-            <a:schemeClr val="lt1"/>
-          </a:fontRef>
-        </p:style>
-        <p:txBody>
-          <a:bodyPr rtlCol="0" anchor="ctr" lIns="90000" tIns="45000" rIns="90000" bIns="45000" wrap="square"/>
-          <a:lstStyle/>
-          <a:p>
-            <a:pPr algn="ctr"/>
-            <a:r>
-              <a:rPr sz="1050" b="1" lang="ca-ES">
-                <a:solidFill>
-                  <a:srgbClr val="2A5C84"/>
-                </a:solidFill>
-                <a:latin typeface="Arial"/>
-              </a:rPr>
-              <a:t>Després: professor</a:t>
-            </a:r>
-          </a:p>
-        </p:txBody>
-      </p:sp>
-      <p:sp>
-        <p:nvSpPr>
-          <p:cNvPr id="10" name="Pindola rol"/>
-          <p:cNvSpPr/>
-          <p:nvPr/>
-        </p:nvSpPr>
-        <p:spPr>
-          <a:xfrm>
-            <a:off x="6144768" y="1691640"/>
-            <a:ext cx="4663440" cy="384048"/>
-          </a:xfrm>
-          <a:prstGeom prst="rect">
-            <a:avLst/>
-          </a:prstGeom>
-          <a:solidFill>
-            <a:srgbClr val="FFFFFF"/>
-          </a:solidFill>
-          <a:ln>
-            <a:solidFill>
-              <a:srgbClr val="D3DAE2"/>
-            </a:solidFill>
-          </a:ln>
-          <a:effectLst>
-            <a:outerShdw blurRad="39960" dist="23040" dir="5400000" rotWithShape="0">
-              <a:srgbClr val="000000">
-                <a:alpha val="35000"/>
-              </a:srgbClr>
-            </a:outerShdw>
-          </a:effectLst>
-        </p:spPr>
-        <p:style>
-          <a:lnRef idx="1">
-            <a:schemeClr val="accent1"/>
-          </a:lnRef>
-          <a:fillRef idx="3">
-            <a:schemeClr val="accent1"/>
-          </a:fillRef>
-          <a:effectRef idx="2">
-            <a:schemeClr val="accent1"/>
-          </a:effectRef>
-          <a:fontRef idx="minor">
-            <a:schemeClr val="lt1"/>
-          </a:fontRef>
-        </p:style>
-        <p:txBody>
-          <a:bodyPr rtlCol="0" anchor="ctr" lIns="90000" tIns="45000" rIns="90000" bIns="45000" wrap="square"/>
-          <a:lstStyle/>
-          <a:p>
-            <a:pPr algn="ctr"/>
-            <a:r>
-              <a:rPr sz="1050" b="1" lang="ca-ES">
-                <a:solidFill>
-                  <a:srgbClr val="2A5C84"/>
-                </a:solidFill>
-                <a:latin typeface="Arial"/>
-              </a:rPr>
-              <a:t>Avui: investigador en Educació en Enginyeria del Software</a:t>
-            </a:r>
-          </a:p>
-        </p:txBody>
-      </p:sp>
-      <p:cxnSp>
-        <p:nvCxnSpPr>
-          <p:cNvPr id="11" name="Connector 10"/>
-          <p:cNvCxnSpPr/>
-          <p:nvPr/>
-        </p:nvCxnSpPr>
-        <p:spPr>
-          <a:xfrm>
-            <a:off x="3813048" y="1883664"/>
-            <a:ext cx="320039" cy="0"/>
-          </a:xfrm>
-          <a:prstGeom prst="line">
-            <a:avLst/>
-          </a:prstGeom>
-          <a:ln w="22860">
-            <a:solidFill>
-              <a:srgbClr val="D1891F"/>
-            </a:solidFill>
-          </a:ln>
-        </p:spPr>
-        <p:style>
-          <a:lnRef idx="2">
-            <a:schemeClr val="accent1"/>
-          </a:lnRef>
-          <a:fillRef idx="0">
-            <a:schemeClr val="accent1"/>
-          </a:fillRef>
-          <a:effectRef idx="1">
-            <a:schemeClr val="accent1"/>
-          </a:effectRef>
-          <a:fontRef idx="minor">
-            <a:schemeClr val="tx1"/>
-          </a:fontRef>
-        </p:style>
-      </p:cxnSp>
-      <p:cxnSp>
-        <p:nvCxnSpPr>
-          <p:cNvPr id="12" name="Connector 11"/>
-          <p:cNvCxnSpPr/>
-          <p:nvPr/>
-        </p:nvCxnSpPr>
-        <p:spPr>
-          <a:xfrm>
-            <a:off x="5824728" y="1883664"/>
-            <a:ext cx="320040" cy="0"/>
-          </a:xfrm>
-          <a:prstGeom prst="line">
-            <a:avLst/>
-          </a:prstGeom>
-          <a:ln w="22860">
-            <a:solidFill>
-              <a:srgbClr val="D1891F"/>
-            </a:solidFill>
-          </a:ln>
-        </p:spPr>
-        <p:style>
-          <a:lnRef idx="2">
-            <a:schemeClr val="accent1"/>
-          </a:lnRef>
-          <a:fillRef idx="0">
-            <a:schemeClr val="accent1"/>
-          </a:fillRef>
-          <a:effectRef idx="1">
-            <a:schemeClr val="accent1"/>
-          </a:effectRef>
-          <a:fontRef idx="minor">
-            <a:schemeClr val="tx1"/>
-          </a:fontRef>
-        </p:style>
-      </p:cxnSp>
-      <p:sp>
-        <p:nvSpPr>
-          <p:cNvPr id="13" name="Etiqueta recorregut"/>
-          <p:cNvSpPr txBox="1"/>
-          <p:nvPr/>
-        </p:nvSpPr>
-        <p:spPr>
-          <a:xfrm>
-            <a:off x="914400" y="2560320"/>
-            <a:ext cx="10360152" cy="274320"/>
-          </a:xfrm>
-          <a:prstGeom prst="rect">
-            <a:avLst/>
-          </a:prstGeom>
-          <a:noFill/>
-        </p:spPr>
-        <p:txBody>
-          <a:bodyPr wrap="square" lIns="90000" tIns="45000" rIns="90000" bIns="45000">
-            <a:spAutoFit/>
-          </a:bodyPr>
-          <a:lstStyle/>
-          <a:p>
-            <a:pPr algn="ctr"/>
-            <a:r>
-              <a:rPr sz="1200" b="1" lang="ca-ES">
-                <a:solidFill>
-                  <a:srgbClr val="2A5C84"/>
-                </a:solidFill>
-                <a:latin typeface="Arial"/>
-              </a:rPr>
-              <a:t>El recorregut de la presentació</a:t>
-            </a:r>
-          </a:p>
-        </p:txBody>
-      </p:sp>
-      <p:sp>
-        <p:nvSpPr>
-          <p:cNvPr id="14" name="Etapa recorregut"/>
-          <p:cNvSpPr/>
-          <p:nvPr/>
-        </p:nvSpPr>
-        <p:spPr>
-          <a:xfrm>
-            <a:off x="886968" y="2971800"/>
-            <a:ext cx="1828800" cy="1188720"/>
-          </a:xfrm>
-          <a:prstGeom prst="rect">
-            <a:avLst/>
-          </a:prstGeom>
-          <a:solidFill>
-            <a:srgbClr val="E8F1F8"/>
-          </a:solidFill>
-          <a:ln>
-            <a:solidFill>
-              <a:srgbClr val="D3DAE2"/>
-            </a:solidFill>
-          </a:ln>
-          <a:effectLst>
-            <a:outerShdw blurRad="39960" dist="23040" dir="5400000" rotWithShape="0">
-              <a:srgbClr val="000000">
-                <a:alpha val="35000"/>
-              </a:srgbClr>
-            </a:outerShdw>
-          </a:effectLst>
-        </p:spPr>
-        <p:style>
-          <a:lnRef idx="1">
-            <a:schemeClr val="accent1"/>
-          </a:lnRef>
-          <a:fillRef idx="3">
-            <a:schemeClr val="accent1"/>
-          </a:fillRef>
-          <a:effectRef idx="2">
-            <a:schemeClr val="accent1"/>
-          </a:effectRef>
-          <a:fontRef idx="minor">
-            <a:schemeClr val="lt1"/>
-          </a:fontRef>
-        </p:style>
-        <p:txBody>
-          <a:bodyPr rtlCol="0" anchor="ctr" lIns="90000" tIns="45000" rIns="90000" bIns="45000" wrap="square"/>
-          <a:lstStyle/>
-          <a:p>
-            <a:pPr algn="ctr"/>
-            <a:r>
-              <a:rPr sz="1350" b="1" lang="ca-ES">
-                <a:solidFill>
-                  <a:srgbClr val="1C2B3B"/>
-                </a:solidFill>
-                <a:latin typeface="Arial"/>
-              </a:rPr>
-              <a:t>Base professional</a:t>
-            </a:r>
-          </a:p>
-          <a:p>
-            <a:pPr algn="ctr"/>
-            <a:r>
-              <a:rPr sz="1150" b="0" lang="ca-ES">
-                <a:solidFill>
-                  <a:srgbClr val="2D343C"/>
-                </a:solidFill>
-                <a:latin typeface="Arial"/>
-              </a:rPr>
-              <a:t>indústria i consultoria</a:t>
-            </a:r>
-          </a:p>
-        </p:txBody>
-      </p:sp>
-      <p:sp>
-        <p:nvSpPr>
-          <p:cNvPr id="15" name="Etapa recorregut"/>
-          <p:cNvSpPr/>
-          <p:nvPr/>
-        </p:nvSpPr>
-        <p:spPr>
-          <a:xfrm>
-            <a:off x="3035808" y="2971800"/>
-            <a:ext cx="1828800" cy="1188720"/>
-          </a:xfrm>
-          <a:prstGeom prst="rect">
-            <a:avLst/>
-          </a:prstGeom>
-          <a:solidFill>
-            <a:srgbClr val="E8F1F8"/>
-          </a:solidFill>
-          <a:ln>
-            <a:solidFill>
-              <a:srgbClr val="D3DAE2"/>
-            </a:solidFill>
-          </a:ln>
-          <a:effectLst>
-            <a:outerShdw blurRad="39960" dist="23040" dir="5400000" rotWithShape="0">
-              <a:srgbClr val="000000">
-                <a:alpha val="35000"/>
-              </a:srgbClr>
-            </a:outerShdw>
-          </a:effectLst>
-        </p:spPr>
-        <p:style>
-          <a:lnRef idx="1">
-            <a:schemeClr val="accent1"/>
-          </a:lnRef>
-          <a:fillRef idx="3">
-            <a:schemeClr val="accent1"/>
-          </a:fillRef>
-          <a:effectRef idx="2">
-            <a:schemeClr val="accent1"/>
-          </a:effectRef>
-          <a:fontRef idx="minor">
-            <a:schemeClr val="lt1"/>
-          </a:fontRef>
-        </p:style>
-        <p:txBody>
-          <a:bodyPr rtlCol="0" anchor="ctr" lIns="90000" tIns="45000" rIns="90000" bIns="45000" wrap="square"/>
-          <a:lstStyle/>
-          <a:p>
-            <a:pPr algn="ctr"/>
-            <a:r>
-              <a:rPr sz="1350" b="1" lang="ca-ES">
-                <a:solidFill>
-                  <a:srgbClr val="1C2B3B"/>
-                </a:solidFill>
-                <a:latin typeface="Arial"/>
-              </a:rPr>
-              <a:t>Vocació docent</a:t>
-            </a:r>
-          </a:p>
-          <a:p>
-            <a:pPr algn="ctr"/>
-            <a:r>
-              <a:rPr sz="1150" b="0" lang="ca-ES">
-                <a:solidFill>
-                  <a:srgbClr val="2D343C"/>
-                </a:solidFill>
-                <a:latin typeface="Arial"/>
-              </a:rPr>
-              <a:t>Formació Professional</a:t>
-            </a:r>
-          </a:p>
-        </p:txBody>
-      </p:sp>
-      <p:cxnSp>
-        <p:nvCxnSpPr>
-          <p:cNvPr id="16" name="Connector 15"/>
-          <p:cNvCxnSpPr/>
-          <p:nvPr/>
-        </p:nvCxnSpPr>
-        <p:spPr>
-          <a:xfrm>
-            <a:off x="2715768" y="3566160"/>
-            <a:ext cx="320040" cy="0"/>
-          </a:xfrm>
-          <a:prstGeom prst="line">
-            <a:avLst/>
-          </a:prstGeom>
-          <a:ln w="22860">
-            <a:solidFill>
-              <a:srgbClr val="D1891F"/>
-            </a:solidFill>
-          </a:ln>
-        </p:spPr>
-        <p:style>
-          <a:lnRef idx="2">
-            <a:schemeClr val="accent1"/>
-          </a:lnRef>
-          <a:fillRef idx="0">
-            <a:schemeClr val="accent1"/>
-          </a:fillRef>
-          <a:effectRef idx="1">
-            <a:schemeClr val="accent1"/>
-          </a:effectRef>
-          <a:fontRef idx="minor">
-            <a:schemeClr val="tx1"/>
-          </a:fontRef>
-        </p:style>
-      </p:cxnSp>
-      <p:sp>
-        <p:nvSpPr>
-          <p:cNvPr id="17" name="Etapa recorregut"/>
-          <p:cNvSpPr/>
-          <p:nvPr/>
-        </p:nvSpPr>
-        <p:spPr>
-          <a:xfrm>
-            <a:off x="5184648" y="2971800"/>
-            <a:ext cx="1828800" cy="1188720"/>
-          </a:xfrm>
-          <a:prstGeom prst="rect">
-            <a:avLst/>
-          </a:prstGeom>
-          <a:solidFill>
-            <a:srgbClr val="E8F1F8"/>
-          </a:solidFill>
-          <a:ln>
-            <a:solidFill>
-              <a:srgbClr val="D3DAE2"/>
-            </a:solidFill>
-          </a:ln>
-          <a:effectLst>
-            <a:outerShdw blurRad="39960" dist="23040" dir="5400000" rotWithShape="0">
-              <a:srgbClr val="000000">
-                <a:alpha val="35000"/>
-              </a:srgbClr>
-            </a:outerShdw>
-          </a:effectLst>
-        </p:spPr>
-        <p:style>
-          <a:lnRef idx="1">
-            <a:schemeClr val="accent1"/>
-          </a:lnRef>
-          <a:fillRef idx="3">
-            <a:schemeClr val="accent1"/>
-          </a:fillRef>
-          <a:effectRef idx="2">
-            <a:schemeClr val="accent1"/>
-          </a:effectRef>
-          <a:fontRef idx="minor">
-            <a:schemeClr val="lt1"/>
-          </a:fontRef>
-        </p:style>
-        <p:txBody>
-          <a:bodyPr rtlCol="0" anchor="ctr" lIns="90000" tIns="45000" rIns="90000" bIns="45000" wrap="square"/>
-          <a:lstStyle/>
-          <a:p>
-            <a:pPr algn="ctr"/>
-            <a:r>
-              <a:rPr sz="1350" b="1" lang="ca-ES">
-                <a:solidFill>
-                  <a:srgbClr val="1C2B3B"/>
-                </a:solidFill>
-                <a:latin typeface="Arial"/>
-              </a:rPr>
-              <a:t>Universitat</a:t>
-            </a:r>
-          </a:p>
-          <a:p>
-            <a:pPr algn="ctr"/>
-            <a:r>
-              <a:rPr sz="1150" b="0" lang="ca-ES">
-                <a:solidFill>
-                  <a:srgbClr val="2D343C"/>
-                </a:solidFill>
-                <a:latin typeface="Arial"/>
-              </a:rPr>
-              <a:t>La Salle</a:t>
-            </a:r>
-          </a:p>
-        </p:txBody>
-      </p:sp>
-      <p:cxnSp>
-        <p:nvCxnSpPr>
-          <p:cNvPr id="18" name="Connector 17"/>
-          <p:cNvCxnSpPr/>
-          <p:nvPr/>
-        </p:nvCxnSpPr>
-        <p:spPr>
-          <a:xfrm>
-            <a:off x="4864608" y="3566160"/>
-            <a:ext cx="320040" cy="0"/>
-          </a:xfrm>
-          <a:prstGeom prst="line">
-            <a:avLst/>
-          </a:prstGeom>
-          <a:ln w="22860">
-            <a:solidFill>
-              <a:srgbClr val="D1891F"/>
-            </a:solidFill>
-          </a:ln>
-        </p:spPr>
-        <p:style>
-          <a:lnRef idx="2">
-            <a:schemeClr val="accent1"/>
-          </a:lnRef>
-          <a:fillRef idx="0">
-            <a:schemeClr val="accent1"/>
-          </a:fillRef>
-          <a:effectRef idx="1">
-            <a:schemeClr val="accent1"/>
-          </a:effectRef>
-          <a:fontRef idx="minor">
-            <a:schemeClr val="tx1"/>
-          </a:fontRef>
-        </p:style>
-      </p:cxnSp>
-      <p:sp>
-        <p:nvSpPr>
-          <p:cNvPr id="19" name="Etapa recorregut"/>
-          <p:cNvSpPr/>
-          <p:nvPr/>
-        </p:nvSpPr>
-        <p:spPr>
-          <a:xfrm>
-            <a:off x="7333488" y="2971800"/>
-            <a:ext cx="1828800" cy="1188720"/>
-          </a:xfrm>
-          <a:prstGeom prst="rect">
-            <a:avLst/>
-          </a:prstGeom>
-          <a:solidFill>
-            <a:srgbClr val="E8F1F8"/>
-          </a:solidFill>
-          <a:ln>
-            <a:solidFill>
-              <a:srgbClr val="D3DAE2"/>
-            </a:solidFill>
-          </a:ln>
-          <a:effectLst>
-            <a:outerShdw blurRad="39960" dist="23040" dir="5400000" rotWithShape="0">
-              <a:srgbClr val="000000">
-                <a:alpha val="35000"/>
-              </a:srgbClr>
-            </a:outerShdw>
-          </a:effectLst>
-        </p:spPr>
-        <p:style>
-          <a:lnRef idx="1">
-            <a:schemeClr val="accent1"/>
-          </a:lnRef>
-          <a:fillRef idx="3">
-            <a:schemeClr val="accent1"/>
-          </a:fillRef>
-          <a:effectRef idx="2">
-            <a:schemeClr val="accent1"/>
-          </a:effectRef>
-          <a:fontRef idx="minor">
-            <a:schemeClr val="lt1"/>
-          </a:fontRef>
-        </p:style>
-        <p:txBody>
-          <a:bodyPr rtlCol="0" anchor="ctr" lIns="90000" tIns="45000" rIns="90000" bIns="45000" wrap="square"/>
-          <a:lstStyle/>
-          <a:p>
-            <a:pPr algn="ctr"/>
-            <a:r>
-              <a:rPr sz="1350" b="1" lang="ca-ES">
-                <a:solidFill>
-                  <a:srgbClr val="1C2B3B"/>
-                </a:solidFill>
-                <a:latin typeface="Arial"/>
-              </a:rPr>
-              <a:t>Consolidació</a:t>
-            </a:r>
-          </a:p>
-          <a:p>
-            <a:pPr algn="ctr"/>
-            <a:r>
-              <a:rPr sz="1150" b="0" lang="ca-ES">
-                <a:solidFill>
-                  <a:srgbClr val="2D343C"/>
-                </a:solidFill>
-                <a:latin typeface="Arial"/>
-              </a:rPr>
-              <a:t>TecnoCampus</a:t>
-            </a:r>
-          </a:p>
-        </p:txBody>
-      </p:sp>
-      <p:cxnSp>
-        <p:nvCxnSpPr>
-          <p:cNvPr id="20" name="Connector 19"/>
-          <p:cNvCxnSpPr/>
-          <p:nvPr/>
-        </p:nvCxnSpPr>
-        <p:spPr>
-          <a:xfrm>
-            <a:off x="7013448" y="3566160"/>
-            <a:ext cx="320040" cy="0"/>
-          </a:xfrm>
-          <a:prstGeom prst="line">
-            <a:avLst/>
-          </a:prstGeom>
-          <a:ln w="22860">
-            <a:solidFill>
-              <a:srgbClr val="D1891F"/>
-            </a:solidFill>
-          </a:ln>
-        </p:spPr>
-        <p:style>
-          <a:lnRef idx="2">
-            <a:schemeClr val="accent1"/>
-          </a:lnRef>
-          <a:fillRef idx="0">
-            <a:schemeClr val="accent1"/>
-          </a:fillRef>
-          <a:effectRef idx="1">
-            <a:schemeClr val="accent1"/>
-          </a:effectRef>
-          <a:fontRef idx="minor">
-            <a:schemeClr val="tx1"/>
-          </a:fontRef>
-        </p:style>
-      </p:cxnSp>
-      <p:sp>
-        <p:nvSpPr>
-          <p:cNvPr id="21" name="Etapa recorregut"/>
-          <p:cNvSpPr/>
-          <p:nvPr/>
-        </p:nvSpPr>
-        <p:spPr>
-          <a:xfrm>
-            <a:off x="9482328" y="2971800"/>
-            <a:ext cx="1828800" cy="1188720"/>
-          </a:xfrm>
-          <a:prstGeom prst="rect">
-            <a:avLst/>
-          </a:prstGeom>
-          <a:solidFill>
-            <a:srgbClr val="E8F1F8"/>
-          </a:solidFill>
-          <a:ln>
-            <a:solidFill>
-              <a:srgbClr val="D3DAE2"/>
-            </a:solidFill>
-          </a:ln>
-          <a:effectLst>
-            <a:outerShdw blurRad="39960" dist="23040" dir="5400000" rotWithShape="0">
-              <a:srgbClr val="000000">
-                <a:alpha val="35000"/>
-              </a:srgbClr>
-            </a:outerShdw>
-          </a:effectLst>
-        </p:spPr>
-        <p:style>
-          <a:lnRef idx="1">
-            <a:schemeClr val="accent1"/>
-          </a:lnRef>
-          <a:fillRef idx="3">
-            <a:schemeClr val="accent1"/>
-          </a:fillRef>
-          <a:effectRef idx="2">
-            <a:schemeClr val="accent1"/>
-          </a:effectRef>
-          <a:fontRef idx="minor">
-            <a:schemeClr val="lt1"/>
-          </a:fontRef>
-        </p:style>
-        <p:txBody>
-          <a:bodyPr rtlCol="0" anchor="ctr" lIns="90000" tIns="45000" rIns="90000" bIns="45000" wrap="square"/>
-          <a:lstStyle/>
-          <a:p>
-            <a:pPr algn="ctr"/>
-            <a:r>
-              <a:rPr sz="1350" b="1" lang="ca-ES">
-                <a:solidFill>
-                  <a:srgbClr val="1C2B3B"/>
-                </a:solidFill>
-                <a:latin typeface="Arial"/>
-              </a:rPr>
-              <a:t>Projecte de futur</a:t>
-            </a:r>
-          </a:p>
-          <a:p>
-            <a:pPr algn="ctr"/>
-            <a:r>
-              <a:rPr sz="1150" b="0" lang="ca-ES">
-                <a:solidFill>
-                  <a:srgbClr val="2D343C"/>
-                </a:solidFill>
-                <a:latin typeface="Arial"/>
-              </a:rPr>
-              <a:t>recerca doctoral</a:t>
-            </a:r>
-          </a:p>
-        </p:txBody>
-      </p:sp>
-      <p:cxnSp>
-        <p:nvCxnSpPr>
-          <p:cNvPr id="22" name="Connector 21"/>
-          <p:cNvCxnSpPr/>
-          <p:nvPr/>
-        </p:nvCxnSpPr>
-        <p:spPr>
-          <a:xfrm>
-            <a:off x="9162288" y="3566160"/>
-            <a:ext cx="320040" cy="0"/>
-          </a:xfrm>
-          <a:prstGeom prst="line">
-            <a:avLst/>
-          </a:prstGeom>
-          <a:ln w="22860">
-            <a:solidFill>
-              <a:srgbClr val="D1891F"/>
-            </a:solidFill>
-          </a:ln>
-        </p:spPr>
-        <p:style>
-          <a:lnRef idx="2">
-            <a:schemeClr val="accent1"/>
-          </a:lnRef>
-          <a:fillRef idx="0">
-            <a:schemeClr val="accent1"/>
-          </a:fillRef>
-          <a:effectRef idx="1">
-            <a:schemeClr val="accent1"/>
-          </a:effectRef>
-          <a:fontRef idx="minor">
-            <a:schemeClr val="tx1"/>
-          </a:fontRef>
-        </p:style>
-      </p:cxnSp>
-      <p:sp>
-        <p:nvSpPr>
-          <p:cNvPr id="23" name="Missatge"/>
-          <p:cNvSpPr txBox="1"/>
-          <p:nvPr/>
-        </p:nvSpPr>
-        <p:spPr>
-          <a:xfrm>
-            <a:off x="914400" y="5120640"/>
-            <a:ext cx="10360152" cy="411480"/>
-          </a:xfrm>
-          <a:prstGeom prst="rect">
-            <a:avLst/>
-          </a:prstGeom>
-          <a:noFill/>
-        </p:spPr>
-        <p:txBody>
-          <a:bodyPr wrap="square" lIns="90000" tIns="45000" rIns="90000" bIns="45000">
-            <a:spAutoFit/>
-          </a:bodyPr>
-          <a:lstStyle/>
-          <a:p>
-            <a:pPr algn="ctr"/>
-            <a:r>
-              <a:rPr sz="1600" b="1" lang="ca-ES">
-                <a:solidFill>
-                  <a:srgbClr val="1C2B3B"/>
-                </a:solidFill>
-                <a:latin typeface="Arial"/>
-              </a:rPr>
-              <a:t>Una trajectòria coherent amb la plaça de professorat permanent.</a:t>
-            </a:r>
-          </a:p>
-        </p:txBody>
-      </p:sp>
-      <p:sp>
-        <p:nvSpPr>
-          <p:cNvPr id="24" name="Peu"/>
-          <p:cNvSpPr txBox="1"/>
-          <p:nvPr/>
-        </p:nvSpPr>
-        <p:spPr>
-          <a:xfrm>
-            <a:off x="640080" y="6446520"/>
-            <a:ext cx="8869680" cy="201168"/>
-          </a:xfrm>
-          <a:prstGeom prst="rect">
-            <a:avLst/>
-          </a:prstGeom>
-          <a:noFill/>
-        </p:spPr>
-        <p:txBody>
-          <a:bodyPr wrap="square" lIns="90000" tIns="45000" rIns="90000" bIns="45000">
-            <a:spAutoFit/>
-          </a:bodyPr>
-          <a:lstStyle/>
-          <a:p>
-            <a:pPr/>
-            <a:r>
-              <a:rPr sz="860" b="0" lang="ca-ES">
-                <a:solidFill>
-                  <a:srgbClr val="67717C"/>
-                </a:solidFill>
-                <a:latin typeface="Arial"/>
-              </a:rPr>
-              <a:t>Trajectòria professional, acadèmica i científica · Defensa de plaça de professorat permanent</a:t>
-            </a:r>
-          </a:p>
-        </p:txBody>
-      </p:sp>
-      <p:sp>
-        <p:nvSpPr>
-          <p:cNvPr id="25" name="Numero"/>
-          <p:cNvSpPr txBox="1"/>
-          <p:nvPr/>
-        </p:nvSpPr>
-        <p:spPr>
-          <a:xfrm>
-            <a:off x="11018520" y="6446520"/>
-            <a:ext cx="320040" cy="201168"/>
-          </a:xfrm>
-          <a:prstGeom prst="rect">
-            <a:avLst/>
-          </a:prstGeom>
-          <a:noFill/>
-        </p:spPr>
-        <p:txBody>
-          <a:bodyPr wrap="square" lIns="90000" tIns="45000" rIns="90000" bIns="45000">
-            <a:spAutoFit/>
-          </a:bodyPr>
-          <a:lstStyle/>
-          <a:p>
-            <a:pPr algn="r"/>
-            <a:r>
-              <a:rPr sz="860" b="0" lang="ca-ES">
-                <a:solidFill>
-                  <a:srgbClr val="67717C"/>
-                </a:solidFill>
-                <a:latin typeface="Arial"/>
-              </a:rPr>
-              <a:t>2</a:t>
-            </a:r>
-          </a:p>
-        </p:txBody>
-      </p:sp>
-    </p:spTree>
-  </p:cSld>
-  <p:clrMapOvr>
-    <a:masterClrMapping/>
-  </p:clrMapOvr>
-</p:sld>
-</file>
-
 <file path=ppt/theme/theme1.xml><?xml version="1.0" encoding="utf-8"?>
 <a:theme xmlns:a="http://schemas.openxmlformats.org/drawingml/2006/main" name="Office Theme">
   <a:themeElements>

</xml_diff>

<commit_message>
Add senior software job study to defense
</commit_message>
<xml_diff>
--- a/doc/presentations/defensa-placa-permanent-dsi-ports-sortida-hexagonal/output/defensa-trajectoria-10-minuts.pptx
+++ b/doc/presentations/defensa-placa-permanent-dsi-ports-sortida-hexagonal/output/defensa-trajectoria-10-minuts.pptx
@@ -15,6 +15,9 @@
     <p:sldId id="260" r:id="rId6"/>
     <p:sldId id="261" r:id="rId7"/>
     <p:sldId id="262" r:id="rId13"/>
+    <p:sldId id="263" r:id="rId14"/>
+    <p:sldId id="264" r:id="rId15"/>
+    <p:sldId id="265" r:id="rId16"/>
   </p:sldIdLst>
   <p:sldSz cx="12192000" cy="6858000"/>
   <p:notesSz cx="6858000" cy="9144000"/>
@@ -11465,6 +11468,1055 @@
               <a:uFillTx/>
               <a:latin typeface="Arial"/>
             </a:endParaRPr>
+          </a:p>
+        </p:txBody>
+      </p:sp>
+    </p:spTree>
+  </p:cSld>
+  <p:clrMapOvr>
+    <a:masterClrMapping/>
+  </p:clrMapOvr>
+</p:sld>
+</file>
+
+<file path=ppt/slides/slide10.xml><?xml version="1.0" encoding="utf-8"?>
+<p:sld xmlns:a="http://schemas.openxmlformats.org/drawingml/2006/main" xmlns:p="http://schemas.openxmlformats.org/presentationml/2006/main">
+  <p:cSld>
+    <p:spTree>
+      <p:nvGrpSpPr>
+        <p:cNvPr id="1" name=""/>
+        <p:cNvGrpSpPr/>
+        <p:nvPr/>
+      </p:nvGrpSpPr>
+      <p:grpSpPr>
+        <a:xfrm>
+          <a:off x="0" y="0"/>
+          <a:ext cx="0" cy="0"/>
+          <a:chOff x="0" y="0"/>
+          <a:chExt cx="0" cy="0"/>
+        </a:xfrm>
+      </p:grpSpPr>
+      <p:sp>
+        <p:nvSpPr>
+          <p:cNvPr id="2" name="Títol"/>
+          <p:cNvSpPr/>
+          <p:nvPr/>
+        </p:nvSpPr>
+        <p:spPr>
+          <a:xfrm>
+            <a:off x="640080" y="356616"/>
+            <a:ext cx="10652760" cy="438912"/>
+          </a:xfrm>
+          <a:prstGeom prst="rect">
+            <a:avLst/>
+          </a:prstGeom>
+          <a:noFill/>
+          <a:ln w="0">
+            <a:noFill/>
+          </a:ln>
+        </p:spPr>
+        <p:txBody>
+          <a:bodyPr lIns="0" tIns="0" rIns="0" bIns="0" anchor="ctr" wrap="square">
+            <a:normAutofit fontScale="92000" lnSpcReduction="8000"/>
+          </a:bodyPr>
+          <a:lstStyle/>
+          <a:p>
+            <a:pPr algn="l">
+              <a:spcAft>
+                <a:spcPts val="0"/>
+              </a:spcAft>
+            </a:pPr>
+            <a:r>
+              <a:rPr lang="ca-ES" sz="2500" b="1">
+                <a:solidFill>
+                  <a:srgbClr val="1C2B3B"/>
+                </a:solidFill>
+                <a:latin typeface="Arial"/>
+              </a:rPr>
+              <a:t>Annex D. Demanda professional de competències socioemocionals</a:t>
+            </a:r>
+          </a:p>
+        </p:txBody>
+      </p:sp>
+      <p:sp>
+        <p:nvSpPr>
+          <p:cNvPr id="3" name="Subtítol"/>
+          <p:cNvSpPr/>
+          <p:nvPr/>
+        </p:nvSpPr>
+        <p:spPr>
+          <a:xfrm>
+            <a:off x="649224" y="804672"/>
+            <a:ext cx="10149840" cy="274320"/>
+          </a:xfrm>
+          <a:prstGeom prst="rect">
+            <a:avLst/>
+          </a:prstGeom>
+          <a:noFill/>
+          <a:ln w="0">
+            <a:noFill/>
+          </a:ln>
+        </p:spPr>
+        <p:txBody>
+          <a:bodyPr lIns="0" tIns="0" rIns="0" bIns="0" anchor="ctr" wrap="square">
+            <a:normAutofit fontScale="92000" lnSpcReduction="8000"/>
+          </a:bodyPr>
+          <a:lstStyle/>
+          <a:p>
+            <a:pPr algn="l">
+              <a:spcAft>
+                <a:spcPts val="0"/>
+              </a:spcAft>
+            </a:pPr>
+            <a:r>
+              <a:rPr lang="ca-ES" sz="1150" b="0">
+                <a:solidFill>
+                  <a:srgbClr val="67717C"/>
+                </a:solidFill>
+                <a:latin typeface="Arial"/>
+              </a:rPr>
+              <a:t>Mostra internacional actual · resultats amb controls de concentració per empresa</a:t>
+            </a:r>
+          </a:p>
+        </p:txBody>
+      </p:sp>
+      <p:sp>
+        <p:nvSpPr>
+          <p:cNvPr id="4" name="Separador"/>
+          <p:cNvSpPr/>
+          <p:nvPr/>
+        </p:nvSpPr>
+        <p:spPr>
+          <a:xfrm>
+            <a:off x="640080" y="1097280"/>
+            <a:ext cx="10789920" cy="13716"/>
+          </a:xfrm>
+          <a:prstGeom prst="rect">
+            <a:avLst/>
+          </a:prstGeom>
+          <a:solidFill>
+            <a:srgbClr val="D3DAE2"/>
+          </a:solidFill>
+          <a:ln w="0">
+            <a:noFill/>
+          </a:ln>
+        </p:spPr>
+        <p:txBody>
+          <a:bodyPr lIns="88900" tIns="50800" rIns="88900" bIns="50800" anchor="ctr" wrap="square">
+            <a:normAutofit fontScale="92000" lnSpcReduction="8000"/>
+          </a:bodyPr>
+          <a:lstStyle/>
+          <a:p>
+            <a:pPr algn="l">
+              <a:spcAft>
+                <a:spcPts val="200"/>
+              </a:spcAft>
+            </a:pPr>
+            <a:r>
+              <a:rPr lang="ca-ES" sz="100" b="0">
+                <a:solidFill>
+                  <a:srgbClr val="2D343C"/>
+                </a:solidFill>
+                <a:latin typeface="Arial"/>
+              </a:rPr>
+              <a:t/>
+            </a:r>
+          </a:p>
+        </p:txBody>
+      </p:sp>
+      <p:sp>
+        <p:nvSpPr>
+          <p:cNvPr id="5" name="Peu esquerre"/>
+          <p:cNvSpPr/>
+          <p:nvPr/>
+        </p:nvSpPr>
+        <p:spPr>
+          <a:xfrm>
+            <a:off x="731520" y="6519672"/>
+            <a:ext cx="8686800" cy="182880"/>
+          </a:xfrm>
+          <a:prstGeom prst="rect">
+            <a:avLst/>
+          </a:prstGeom>
+          <a:noFill/>
+          <a:ln w="0">
+            <a:noFill/>
+          </a:ln>
+        </p:spPr>
+        <p:txBody>
+          <a:bodyPr lIns="0" tIns="0" rIns="0" bIns="0" anchor="ctr" wrap="square">
+            <a:normAutofit fontScale="92000" lnSpcReduction="8000"/>
+          </a:bodyPr>
+          <a:lstStyle/>
+          <a:p>
+            <a:pPr algn="l">
+              <a:spcAft>
+                <a:spcPts val="0"/>
+              </a:spcAft>
+            </a:pPr>
+            <a:r>
+              <a:rPr lang="ca-ES" sz="740" b="0">
+                <a:solidFill>
+                  <a:srgbClr val="67717C"/>
+                </a:solidFill>
+                <a:latin typeface="Arial"/>
+              </a:rPr>
+              <a:t>Trajectòria professional, acadèmica i científica · Defensa de plaça de professorat permanent</a:t>
+            </a:r>
+          </a:p>
+        </p:txBody>
+      </p:sp>
+      <p:sp>
+        <p:nvSpPr>
+          <p:cNvPr id="6" name="Peu dret"/>
+          <p:cNvSpPr/>
+          <p:nvPr/>
+        </p:nvSpPr>
+        <p:spPr>
+          <a:xfrm>
+            <a:off x="10744200" y="6519672"/>
+            <a:ext cx="685800" cy="182880"/>
+          </a:xfrm>
+          <a:prstGeom prst="rect">
+            <a:avLst/>
+          </a:prstGeom>
+          <a:noFill/>
+          <a:ln w="0">
+            <a:noFill/>
+          </a:ln>
+        </p:spPr>
+        <p:txBody>
+          <a:bodyPr lIns="0" tIns="0" rIns="0" bIns="0" anchor="ctr" wrap="square">
+            <a:normAutofit fontScale="92000" lnSpcReduction="8000"/>
+          </a:bodyPr>
+          <a:lstStyle/>
+          <a:p>
+            <a:pPr algn="r">
+              <a:spcAft>
+                <a:spcPts val="0"/>
+              </a:spcAft>
+            </a:pPr>
+            <a:r>
+              <a:rPr lang="ca-ES" sz="740" b="0">
+                <a:solidFill>
+                  <a:srgbClr val="67717C"/>
+                </a:solidFill>
+                <a:latin typeface="Arial"/>
+              </a:rPr>
+              <a:t>Annex D</a:t>
+            </a:r>
+          </a:p>
+        </p:txBody>
+      </p:sp>
+      <p:sp>
+        <p:nvSpPr>
+          <p:cNvPr id="7" name="Etiqueta cas"/>
+          <p:cNvSpPr/>
+          <p:nvPr/>
+        </p:nvSpPr>
+        <p:spPr>
+          <a:xfrm>
+            <a:off x="768096" y="1280160"/>
+            <a:ext cx="5669280" cy="256032"/>
+          </a:xfrm>
+          <a:prstGeom prst="rect">
+            <a:avLst/>
+          </a:prstGeom>
+          <a:noFill/>
+          <a:ln w="0">
+            <a:noFill/>
+          </a:ln>
+        </p:spPr>
+        <p:txBody>
+          <a:bodyPr lIns="0" tIns="0" rIns="0" bIns="0" anchor="ctr" wrap="square">
+            <a:normAutofit fontScale="92000" lnSpcReduction="8000"/>
+          </a:bodyPr>
+          <a:lstStyle/>
+          <a:p>
+            <a:pPr algn="ctr">
+              <a:spcAft>
+                <a:spcPts val="0"/>
+              </a:spcAft>
+            </a:pPr>
+            <a:r>
+              <a:rPr lang="ca-ES" sz="830" b="1">
+                <a:solidFill>
+                  <a:srgbClr val="2A5C84"/>
+                </a:solidFill>
+                <a:latin typeface="Arial"/>
+              </a:rPr>
+              <a:t>222 OFERTES · 102 EMPRESES · 6 FONTS</a:t>
+            </a:r>
+          </a:p>
+        </p:txBody>
+      </p:sp>
+      <p:sp>
+        <p:nvSpPr>
+          <p:cNvPr id="8" name="Segment 1"/>
+          <p:cNvSpPr/>
+          <p:nvPr/>
+        </p:nvSpPr>
+        <p:spPr>
+          <a:xfrm>
+            <a:off x="822960" y="1664208"/>
+            <a:ext cx="1581912" cy="713232"/>
+          </a:xfrm>
+          <a:prstGeom prst="rect">
+            <a:avLst/>
+          </a:prstGeom>
+          <a:solidFill>
+            <a:srgbClr val="E8F1F8"/>
+          </a:solidFill>
+          <a:ln w="19050">
+            <a:solidFill>
+              <a:srgbClr val="FFFFFF"/>
+            </a:solidFill>
+          </a:ln>
+        </p:spPr>
+        <p:txBody>
+          <a:bodyPr lIns="25400" tIns="25400" rIns="25400" bIns="25400" anchor="ctr" wrap="square">
+            <a:normAutofit fontScale="92000" lnSpcReduction="8000"/>
+          </a:bodyPr>
+          <a:lstStyle/>
+          <a:p>
+            <a:pPr algn="ctr">
+              <a:spcAft>
+                <a:spcPts val="0"/>
+              </a:spcAft>
+            </a:pPr>
+            <a:r>
+              <a:rPr lang="ca-ES" sz="870" b="1">
+                <a:solidFill>
+                  <a:srgbClr val="2D343C"/>
+                </a:solidFill>
+                <a:latin typeface="Arial"/>
+              </a:rPr>
+              <a:t>≥1 competència</a:t>
+            </a:r>
+          </a:p>
+          <a:p>
+            <a:pPr algn="ctr">
+              <a:spcAft>
+                <a:spcPts val="0"/>
+              </a:spcAft>
+            </a:pPr>
+            <a:r>
+              <a:rPr lang="ca-ES" sz="870" b="1">
+                <a:solidFill>
+                  <a:srgbClr val="2D343C"/>
+                </a:solidFill>
+                <a:latin typeface="Arial"/>
+              </a:rPr>
+              <a:t>84,7 %</a:t>
+            </a:r>
+          </a:p>
+          <a:p>
+            <a:pPr algn="ctr">
+              <a:spcAft>
+                <a:spcPts val="0"/>
+              </a:spcAft>
+            </a:pPr>
+            <a:r>
+              <a:rPr lang="ca-ES" sz="1100" b="1">
+                <a:solidFill>
+                  <a:srgbClr val="2A5C84"/>
+                </a:solidFill>
+                <a:latin typeface="Arial"/>
+              </a:rPr>
+              <a:t>188 de 222</a:t>
+            </a:r>
+          </a:p>
+        </p:txBody>
+      </p:sp>
+      <p:sp>
+        <p:nvSpPr>
+          <p:cNvPr id="9" name="Segment 2"/>
+          <p:cNvSpPr/>
+          <p:nvPr/>
+        </p:nvSpPr>
+        <p:spPr>
+          <a:xfrm>
+            <a:off x="2404872" y="1664208"/>
+            <a:ext cx="1581912" cy="713232"/>
+          </a:xfrm>
+          <a:prstGeom prst="rect">
+            <a:avLst/>
+          </a:prstGeom>
+          <a:solidFill>
+            <a:srgbClr val="FFF4DB"/>
+          </a:solidFill>
+          <a:ln w="19050">
+            <a:solidFill>
+              <a:srgbClr val="FFFFFF"/>
+            </a:solidFill>
+          </a:ln>
+        </p:spPr>
+        <p:txBody>
+          <a:bodyPr lIns="25400" tIns="25400" rIns="25400" bIns="25400" anchor="ctr" wrap="square">
+            <a:normAutofit fontScale="92000" lnSpcReduction="8000"/>
+          </a:bodyPr>
+          <a:lstStyle/>
+          <a:p>
+            <a:pPr algn="ctr">
+              <a:spcAft>
+                <a:spcPts val="0"/>
+              </a:spcAft>
+            </a:pPr>
+            <a:r>
+              <a:rPr lang="ca-ES" sz="870" b="1">
+                <a:solidFill>
+                  <a:srgbClr val="2D343C"/>
+                </a:solidFill>
+                <a:latin typeface="Arial"/>
+              </a:rPr>
+              <a:t>≥2 competències</a:t>
+            </a:r>
+          </a:p>
+          <a:p>
+            <a:pPr algn="ctr">
+              <a:spcAft>
+                <a:spcPts val="0"/>
+              </a:spcAft>
+            </a:pPr>
+            <a:r>
+              <a:rPr lang="ca-ES" sz="1100" b="1">
+                <a:solidFill>
+                  <a:srgbClr val="2A5C84"/>
+                </a:solidFill>
+                <a:latin typeface="Arial"/>
+              </a:rPr>
+              <a:t>60,8 %</a:t>
+            </a:r>
+          </a:p>
+        </p:txBody>
+      </p:sp>
+      <p:sp>
+        <p:nvSpPr>
+          <p:cNvPr id="10" name="Segment 3"/>
+          <p:cNvSpPr/>
+          <p:nvPr/>
+        </p:nvSpPr>
+        <p:spPr>
+          <a:xfrm>
+            <a:off x="3986784" y="1664208"/>
+            <a:ext cx="2368296" cy="713232"/>
+          </a:xfrm>
+          <a:prstGeom prst="rect">
+            <a:avLst/>
+          </a:prstGeom>
+          <a:solidFill>
+            <a:srgbClr val="EBF6F0"/>
+          </a:solidFill>
+          <a:ln w="19050">
+            <a:solidFill>
+              <a:srgbClr val="FFFFFF"/>
+            </a:solidFill>
+          </a:ln>
+        </p:spPr>
+        <p:txBody>
+          <a:bodyPr lIns="25400" tIns="25400" rIns="25400" bIns="25400" anchor="ctr" wrap="square">
+            <a:normAutofit fontScale="92000" lnSpcReduction="8000"/>
+          </a:bodyPr>
+          <a:lstStyle/>
+          <a:p>
+            <a:pPr algn="ctr">
+              <a:spcAft>
+                <a:spcPts val="0"/>
+              </a:spcAft>
+            </a:pPr>
+            <a:r>
+              <a:rPr lang="ca-ES" sz="870" b="1">
+                <a:solidFill>
+                  <a:srgbClr val="2D343C"/>
+                </a:solidFill>
+                <a:latin typeface="Arial"/>
+              </a:rPr>
+              <a:t>PES IGUAL</a:t>
+            </a:r>
+          </a:p>
+          <a:p>
+            <a:pPr algn="ctr">
+              <a:spcAft>
+                <a:spcPts val="0"/>
+              </a:spcAft>
+            </a:pPr>
+            <a:r>
+              <a:rPr lang="ca-ES" sz="870" b="1">
+                <a:solidFill>
+                  <a:srgbClr val="2D343C"/>
+                </a:solidFill>
+                <a:latin typeface="Arial"/>
+              </a:rPr>
+              <a:t>PER EMPRESA</a:t>
+            </a:r>
+          </a:p>
+          <a:p>
+            <a:pPr algn="ctr">
+              <a:spcAft>
+                <a:spcPts val="0"/>
+              </a:spcAft>
+            </a:pPr>
+            <a:r>
+              <a:rPr lang="ca-ES" sz="1100" b="1">
+                <a:solidFill>
+                  <a:srgbClr val="2A5C84"/>
+                </a:solidFill>
+                <a:latin typeface="Arial"/>
+              </a:rPr>
+              <a:t>79,1 %</a:t>
+            </a:r>
+          </a:p>
+        </p:txBody>
+      </p:sp>
+      <p:sp>
+        <p:nvSpPr>
+          <p:cNvPr id="11" name="Component estimat"/>
+          <p:cNvSpPr/>
+          <p:nvPr/>
+        </p:nvSpPr>
+        <p:spPr>
+          <a:xfrm>
+            <a:off x="1325880" y="2679192"/>
+            <a:ext cx="4526280" cy="713232"/>
+          </a:xfrm>
+          <a:prstGeom prst="roundRect">
+            <a:avLst/>
+          </a:prstGeom>
+          <a:solidFill>
+            <a:srgbClr val="1C2B3B"/>
+          </a:solidFill>
+          <a:ln w="9525">
+            <a:solidFill>
+              <a:srgbClr val="1C2B3B"/>
+            </a:solidFill>
+          </a:ln>
+          <a:effectLst>
+            <a:outerShdw blurRad="50000" dist="26000" dir="5400000" rotWithShape="0">
+              <a:srgbClr val="000000">
+                <a:alpha val="22000"/>
+              </a:srgbClr>
+            </a:outerShdw>
+          </a:effectLst>
+        </p:spPr>
+        <p:txBody>
+          <a:bodyPr lIns="88900" tIns="50800" rIns="88900" bIns="50800" anchor="ctr" wrap="square">
+            <a:normAutofit fontScale="92000" lnSpcReduction="8000"/>
+          </a:bodyPr>
+          <a:lstStyle/>
+          <a:p>
+            <a:pPr algn="ctr">
+              <a:spcAft>
+                <a:spcPts val="0"/>
+              </a:spcAft>
+            </a:pPr>
+            <a:r>
+              <a:rPr lang="ca-ES" sz="1500" b="1">
+                <a:solidFill>
+                  <a:srgbClr val="FFFFFF"/>
+                </a:solidFill>
+                <a:latin typeface="Arial"/>
+              </a:rPr>
+              <a:t>La hipòtesi es confirma en la mostra observada</a:t>
+            </a:r>
+          </a:p>
+        </p:txBody>
+      </p:sp>
+      <p:sp>
+        <p:nvSpPr>
+          <p:cNvPr id="12" name="Fórmula"/>
+          <p:cNvSpPr/>
+          <p:nvPr/>
+        </p:nvSpPr>
+        <p:spPr>
+          <a:xfrm>
+            <a:off x="1170432" y="3502152"/>
+            <a:ext cx="4846320" cy="457200"/>
+          </a:xfrm>
+          <a:prstGeom prst="rect">
+            <a:avLst/>
+          </a:prstGeom>
+          <a:noFill/>
+          <a:ln w="0">
+            <a:noFill/>
+          </a:ln>
+        </p:spPr>
+        <p:txBody>
+          <a:bodyPr lIns="0" tIns="0" rIns="0" bIns="0" anchor="ctr" wrap="square">
+            <a:normAutofit fontScale="92000" lnSpcReduction="8000"/>
+          </a:bodyPr>
+          <a:lstStyle/>
+          <a:p>
+            <a:pPr algn="ctr">
+              <a:spcAft>
+                <a:spcPts val="0"/>
+              </a:spcAft>
+            </a:pPr>
+            <a:r>
+              <a:rPr lang="ca-ES" sz="1140" b="1">
+                <a:solidFill>
+                  <a:srgbClr val="2A5C84"/>
+                </a:solidFill>
+                <a:latin typeface="Arial"/>
+              </a:rPr>
+              <a:t>IC95%: ≥1 79,4–88,8 · ≥2 54,3–67,0</a:t>
+            </a:r>
+          </a:p>
+          <a:p>
+            <a:pPr algn="ctr">
+              <a:spcAft>
+                <a:spcPts val="0"/>
+              </a:spcAft>
+            </a:pPr>
+            <a:r>
+              <a:rPr lang="ca-ES" sz="860" b="0">
+                <a:solidFill>
+                  <a:srgbClr val="67717C"/>
+                </a:solidFill>
+                <a:latin typeface="Arial"/>
+              </a:rPr>
+              <a:t>Pes igual per empresa: IC95% bootstrap 71,1–86,4</a:t>
+            </a:r>
+          </a:p>
+        </p:txBody>
+      </p:sp>
+      <p:sp>
+        <p:nvSpPr>
+          <p:cNvPr id="13" name="Competències"/>
+          <p:cNvSpPr/>
+          <p:nvPr/>
+        </p:nvSpPr>
+        <p:spPr>
+          <a:xfrm>
+            <a:off x="6748272" y="1298448"/>
+            <a:ext cx="4617720" cy="2688336"/>
+          </a:xfrm>
+          <a:prstGeom prst="roundRect">
+            <a:avLst/>
+          </a:prstGeom>
+          <a:solidFill>
+            <a:srgbClr val="FFF4DB"/>
+          </a:solidFill>
+          <a:ln w="9525">
+            <a:solidFill>
+              <a:srgbClr val="D3DAE2"/>
+            </a:solidFill>
+          </a:ln>
+          <a:effectLst>
+            <a:outerShdw blurRad="50000" dist="26000" dir="5400000" rotWithShape="0">
+              <a:srgbClr val="000000">
+                <a:alpha val="22000"/>
+              </a:srgbClr>
+            </a:outerShdw>
+          </a:effectLst>
+        </p:spPr>
+        <p:txBody>
+          <a:bodyPr lIns="88900" tIns="50800" rIns="88900" bIns="50800" anchor="ctr" wrap="square">
+            <a:normAutofit fontScale="92000" lnSpcReduction="8000"/>
+          </a:bodyPr>
+          <a:lstStyle/>
+          <a:p>
+            <a:pPr algn="l">
+              <a:spcAft>
+                <a:spcPts val="200"/>
+              </a:spcAft>
+            </a:pPr>
+            <a:r>
+              <a:rPr lang="ca-ES" sz="100" b="0">
+                <a:solidFill>
+                  <a:srgbClr val="2D343C"/>
+                </a:solidFill>
+                <a:latin typeface="Arial"/>
+              </a:rPr>
+              <a:t/>
+            </a:r>
+          </a:p>
+        </p:txBody>
+      </p:sp>
+      <p:sp>
+        <p:nvSpPr>
+          <p:cNvPr id="14" name="Títol competències"/>
+          <p:cNvSpPr/>
+          <p:nvPr/>
+        </p:nvSpPr>
+        <p:spPr>
+          <a:xfrm>
+            <a:off x="7059168" y="1508760"/>
+            <a:ext cx="3995928" cy="329184"/>
+          </a:xfrm>
+          <a:prstGeom prst="rect">
+            <a:avLst/>
+          </a:prstGeom>
+          <a:noFill/>
+          <a:ln w="0">
+            <a:noFill/>
+          </a:ln>
+        </p:spPr>
+        <p:txBody>
+          <a:bodyPr lIns="0" tIns="0" rIns="0" bIns="0" anchor="ctr" wrap="square">
+            <a:normAutofit fontScale="92000" lnSpcReduction="8000"/>
+          </a:bodyPr>
+          <a:lstStyle/>
+          <a:p>
+            <a:pPr algn="ctr">
+              <a:spcAft>
+                <a:spcPts val="0"/>
+              </a:spcAft>
+            </a:pPr>
+            <a:r>
+              <a:rPr lang="ca-ES" sz="1350" b="1">
+                <a:solidFill>
+                  <a:srgbClr val="1C2B3B"/>
+                </a:solidFill>
+                <a:latin typeface="Arial"/>
+              </a:rPr>
+              <a:t>Què apareix explícitament</a:t>
+            </a:r>
+          </a:p>
+        </p:txBody>
+      </p:sp>
+      <p:sp>
+        <p:nvSpPr>
+          <p:cNvPr id="15" name="Llista competències"/>
+          <p:cNvSpPr/>
+          <p:nvPr/>
+        </p:nvSpPr>
+        <p:spPr>
+          <a:xfrm>
+            <a:off x="7114032" y="1920240"/>
+            <a:ext cx="3931920" cy="1444752"/>
+          </a:xfrm>
+          <a:prstGeom prst="rect">
+            <a:avLst/>
+          </a:prstGeom>
+          <a:noFill/>
+          <a:ln w="0">
+            <a:noFill/>
+          </a:ln>
+        </p:spPr>
+        <p:txBody>
+          <a:bodyPr lIns="0" tIns="0" rIns="0" bIns="0" anchor="t" wrap="square">
+            <a:normAutofit fontScale="92000" lnSpcReduction="8000"/>
+          </a:bodyPr>
+          <a:lstStyle/>
+          <a:p>
+            <a:pPr algn="l" marL="240000" indent="-180000">
+              <a:spcAft>
+                <a:spcPts val="400"/>
+              </a:spcAft>
+              <a:buChar char="•"/>
+            </a:pPr>
+            <a:r>
+              <a:rPr lang="ca-ES" sz="970" b="0">
+                <a:solidFill>
+                  <a:srgbClr val="2D343C"/>
+                </a:solidFill>
+                <a:latin typeface="Arial"/>
+              </a:rPr>
+              <a:t>col·laboració 64,0 %</a:t>
+            </a:r>
+          </a:p>
+          <a:p>
+            <a:pPr algn="l" marL="240000" indent="-180000">
+              <a:spcAft>
+                <a:spcPts val="400"/>
+              </a:spcAft>
+              <a:buChar char="•"/>
+            </a:pPr>
+            <a:r>
+              <a:rPr lang="ca-ES" sz="970" b="0">
+                <a:solidFill>
+                  <a:srgbClr val="2D343C"/>
+                </a:solidFill>
+                <a:latin typeface="Arial"/>
+              </a:rPr>
+              <a:t>lideratge / influència 39,2 %</a:t>
+            </a:r>
+          </a:p>
+          <a:p>
+            <a:pPr algn="l" marL="240000" indent="-180000">
+              <a:spcAft>
+                <a:spcPts val="400"/>
+              </a:spcAft>
+              <a:buChar char="•"/>
+            </a:pPr>
+            <a:r>
+              <a:rPr lang="ca-ES" sz="970" b="0">
+                <a:solidFill>
+                  <a:srgbClr val="2D343C"/>
+                </a:solidFill>
+                <a:latin typeface="Arial"/>
+              </a:rPr>
+              <a:t>feedback / revisió 36,9 %</a:t>
+            </a:r>
+          </a:p>
+          <a:p>
+            <a:pPr algn="l" marL="240000" indent="-180000">
+              <a:spcAft>
+                <a:spcPts val="400"/>
+              </a:spcAft>
+              <a:buChar char="•"/>
+            </a:pPr>
+            <a:r>
+              <a:rPr lang="ca-ES" sz="970" b="0">
+                <a:solidFill>
+                  <a:srgbClr val="2D343C"/>
+                </a:solidFill>
+                <a:latin typeface="Arial"/>
+              </a:rPr>
+              <a:t>comunicació explícita 30,2 %</a:t>
+            </a:r>
+          </a:p>
+          <a:p>
+            <a:pPr algn="l" marL="240000" indent="-180000">
+              <a:spcAft>
+                <a:spcPts val="400"/>
+              </a:spcAft>
+              <a:buChar char="•"/>
+            </a:pPr>
+            <a:r>
+              <a:rPr lang="ca-ES" sz="970" b="0">
+                <a:solidFill>
+                  <a:srgbClr val="2D343C"/>
+                </a:solidFill>
+                <a:latin typeface="Arial"/>
+              </a:rPr>
+              <a:t>mentoria / coaching 28,8 %</a:t>
+            </a:r>
+          </a:p>
+          <a:p>
+            <a:pPr algn="l" marL="240000" indent="-180000">
+              <a:spcAft>
+                <a:spcPts val="400"/>
+              </a:spcAft>
+              <a:buChar char="•"/>
+            </a:pPr>
+            <a:r>
+              <a:rPr lang="ca-ES" sz="970" b="0">
+                <a:solidFill>
+                  <a:srgbClr val="2D343C"/>
+                </a:solidFill>
+                <a:latin typeface="Arial"/>
+              </a:rPr>
+              <a:t>aprenentatge / adaptabilitat 15,8 %</a:t>
+            </a:r>
+          </a:p>
+        </p:txBody>
+      </p:sp>
+      <p:sp>
+        <p:nvSpPr>
+          <p:cNvPr id="16" name="Base tècnica"/>
+          <p:cNvSpPr/>
+          <p:nvPr/>
+        </p:nvSpPr>
+        <p:spPr>
+          <a:xfrm>
+            <a:off x="7114032" y="3493008"/>
+            <a:ext cx="3931920" cy="320040"/>
+          </a:xfrm>
+          <a:prstGeom prst="roundRect">
+            <a:avLst/>
+          </a:prstGeom>
+          <a:solidFill>
+            <a:srgbClr val="FFFFFF"/>
+          </a:solidFill>
+          <a:ln w="9525">
+            <a:solidFill>
+              <a:srgbClr val="D3DAE2"/>
+            </a:solidFill>
+          </a:ln>
+        </p:spPr>
+        <p:txBody>
+          <a:bodyPr lIns="38100" tIns="25400" rIns="38100" bIns="25400" anchor="ctr" wrap="square">
+            <a:normAutofit fontScale="92000" lnSpcReduction="8000"/>
+          </a:bodyPr>
+          <a:lstStyle/>
+          <a:p>
+            <a:pPr algn="ctr">
+              <a:spcAft>
+                <a:spcPts val="0"/>
+              </a:spcAft>
+            </a:pPr>
+            <a:r>
+              <a:rPr lang="ca-ES" sz="850" b="1">
+                <a:solidFill>
+                  <a:srgbClr val="2A5C84"/>
+                </a:solidFill>
+                <a:latin typeface="Arial"/>
+              </a:rPr>
+              <a:t>Lead · Staff · Principal: 93,5 % amb ≥1 competència</a:t>
+            </a:r>
+          </a:p>
+        </p:txBody>
+      </p:sp>
+      <p:sp>
+        <p:nvSpPr>
+          <p:cNvPr id="17" name="IA"/>
+          <p:cNvSpPr/>
+          <p:nvPr/>
+        </p:nvSpPr>
+        <p:spPr>
+          <a:xfrm>
+            <a:off x="822960" y="4270248"/>
+            <a:ext cx="10543032" cy="512064"/>
+          </a:xfrm>
+          <a:prstGeom prst="roundRect">
+            <a:avLst/>
+          </a:prstGeom>
+          <a:solidFill>
+            <a:srgbClr val="EBF6F0"/>
+          </a:solidFill>
+          <a:ln w="9525">
+            <a:solidFill>
+              <a:srgbClr val="D3DAE2"/>
+            </a:solidFill>
+          </a:ln>
+        </p:spPr>
+        <p:txBody>
+          <a:bodyPr lIns="88900" tIns="50800" rIns="88900" bIns="50800" anchor="ctr" wrap="square">
+            <a:normAutofit fontScale="92000" lnSpcReduction="8000"/>
+          </a:bodyPr>
+          <a:lstStyle/>
+          <a:p>
+            <a:pPr algn="ctr">
+              <a:spcAft>
+                <a:spcPts val="0"/>
+              </a:spcAft>
+            </a:pPr>
+            <a:r>
+              <a:rPr lang="ca-ES" sz="1070" b="1">
+                <a:solidFill>
+                  <a:srgbClr val="2D343C"/>
+                </a:solidFill>
+                <a:latin typeface="Arial"/>
+              </a:rPr>
+              <a:t>La base tècnica és imprescindible; l'excel·lència sènior també exigeix coordinar, decidir, comunicar i acompanyar.</a:t>
+            </a:r>
+          </a:p>
+        </p:txBody>
+      </p:sp>
+      <p:sp>
+        <p:nvSpPr>
+          <p:cNvPr id="18" name="Missatge principal"/>
+          <p:cNvSpPr/>
+          <p:nvPr/>
+        </p:nvSpPr>
+        <p:spPr>
+          <a:xfrm>
+            <a:off x="896112" y="4983480"/>
+            <a:ext cx="10387584" cy="384048"/>
+          </a:xfrm>
+          <a:prstGeom prst="rect">
+            <a:avLst/>
+          </a:prstGeom>
+          <a:noFill/>
+          <a:ln w="0">
+            <a:noFill/>
+          </a:ln>
+        </p:spPr>
+        <p:txBody>
+          <a:bodyPr lIns="0" tIns="0" rIns="0" bIns="0" anchor="ctr" wrap="square">
+            <a:normAutofit fontScale="92000" lnSpcReduction="8000"/>
+          </a:bodyPr>
+          <a:lstStyle/>
+          <a:p>
+            <a:pPr algn="ctr">
+              <a:spcAft>
+                <a:spcPts val="0"/>
+              </a:spcAft>
+            </a:pPr>
+            <a:r>
+              <a:rPr lang="ca-ES" sz="1140" b="1">
+                <a:solidFill>
+                  <a:srgbClr val="1C2B3B"/>
+                </a:solidFill>
+                <a:latin typeface="Arial"/>
+              </a:rPr>
+              <a:t>Resultat robust: amb màxim 3 ofertes per empresa, 83,3 % en demanen ≥1 i 70,3 % en demanen ≥2.</a:t>
+            </a:r>
+          </a:p>
+        </p:txBody>
+      </p:sp>
+      <p:sp>
+        <p:nvSpPr>
+          <p:cNvPr id="19" name="Missatge secundari"/>
+          <p:cNvSpPr/>
+          <p:nvPr/>
+        </p:nvSpPr>
+        <p:spPr>
+          <a:xfrm>
+            <a:off x="960120" y="5404104"/>
+            <a:ext cx="10259568" cy="292608"/>
+          </a:xfrm>
+          <a:prstGeom prst="rect">
+            <a:avLst/>
+          </a:prstGeom>
+          <a:noFill/>
+          <a:ln w="0">
+            <a:noFill/>
+          </a:ln>
+        </p:spPr>
+        <p:txBody>
+          <a:bodyPr lIns="0" tIns="0" rIns="0" bIns="0" anchor="ctr" wrap="square">
+            <a:normAutofit fontScale="92000" lnSpcReduction="8000"/>
+          </a:bodyPr>
+          <a:lstStyle/>
+          <a:p>
+            <a:pPr algn="ctr">
+              <a:spcAft>
+                <a:spcPts val="0"/>
+              </a:spcAft>
+            </a:pPr>
+            <a:r>
+              <a:rPr lang="ca-ES" sz="980" b="0">
+                <a:solidFill>
+                  <a:srgbClr val="2D343C"/>
+                </a:solidFill>
+                <a:latin typeface="Arial"/>
+              </a:rPr>
+              <a:t>Criteri conservador · deduplicació · auditoria manual de 60 ofertes · feedback/revisió exclòs de l'indicador principal</a:t>
+            </a:r>
+          </a:p>
+        </p:txBody>
+      </p:sp>
+      <p:sp>
+        <p:nvSpPr>
+          <p:cNvPr id="20" name="Limitació"/>
+          <p:cNvSpPr/>
+          <p:nvPr/>
+        </p:nvSpPr>
+        <p:spPr>
+          <a:xfrm>
+            <a:off x="859536" y="5879592"/>
+            <a:ext cx="10469880" cy="274320"/>
+          </a:xfrm>
+          <a:prstGeom prst="rect">
+            <a:avLst/>
+          </a:prstGeom>
+          <a:noFill/>
+          <a:ln w="0">
+            <a:noFill/>
+          </a:ln>
+        </p:spPr>
+        <p:txBody>
+          <a:bodyPr lIns="0" tIns="0" rIns="0" bIns="0" anchor="ctr" wrap="square">
+            <a:normAutofit fontScale="92000" lnSpcReduction="8000"/>
+          </a:bodyPr>
+          <a:lstStyle/>
+          <a:p>
+            <a:pPr algn="ctr">
+              <a:spcAft>
+                <a:spcPts val="0"/>
+              </a:spcAft>
+            </a:pPr>
+            <a:r>
+              <a:rPr lang="ca-ES" sz="790" b="0" i="1">
+                <a:solidFill>
+                  <a:srgbClr val="67717C"/>
+                </a:solidFill>
+                <a:latin typeface="Arial"/>
+              </a:rPr>
+              <a:t>Estudi observacional multifuente, 17/04–16/07/2026. Fonts: The Muse, Himalayas, Arbeitnow, Jobicy, Remotive i Remote OK. No és una mostra probabilística de tot el mercat.</a:t>
+            </a:r>
           </a:p>
         </p:txBody>
       </p:sp>
@@ -21852,6 +22904,2416 @@
 </p:sld>
 </file>
 
+<file path=ppt/slides/slide8.xml><?xml version="1.0" encoding="utf-8"?>
+<p:sld xmlns:a="http://schemas.openxmlformats.org/drawingml/2006/main" xmlns:r="http://schemas.openxmlformats.org/officeDocument/2006/relationships" xmlns:p="http://schemas.openxmlformats.org/presentationml/2006/main">
+  <p:cSld>
+    <p:spTree>
+      <p:nvGrpSpPr>
+        <p:cNvPr id="1" name=""/>
+        <p:cNvGrpSpPr/>
+        <p:nvPr/>
+      </p:nvGrpSpPr>
+      <p:grpSpPr>
+        <a:xfrm>
+          <a:off x="0" y="0"/>
+          <a:ext cx="0" cy="0"/>
+          <a:chOff x="0" y="0"/>
+          <a:chExt cx="0" cy="0"/>
+        </a:xfrm>
+      </p:grpSpPr>
+      <p:sp>
+        <p:nvSpPr>
+          <p:cNvPr id="2" name="Títol"/>
+          <p:cNvSpPr/>
+          <p:nvPr/>
+        </p:nvSpPr>
+        <p:spPr>
+          <a:xfrm>
+            <a:off x="640080" y="356616"/>
+            <a:ext cx="10652760" cy="438912"/>
+          </a:xfrm>
+          <a:prstGeom prst="rect">
+            <a:avLst/>
+          </a:prstGeom>
+          <a:noFill/>
+          <a:ln w="0">
+            <a:noFill/>
+          </a:ln>
+        </p:spPr>
+        <p:txBody>
+          <a:bodyPr lIns="0" tIns="0" rIns="0" bIns="0" anchor="ctr" wrap="square">
+            <a:normAutofit fontScale="92000" lnSpcReduction="8000"/>
+          </a:bodyPr>
+          <a:lstStyle/>
+          <a:p>
+            <a:pPr algn="l">
+              <a:spcAft>
+                <a:spcPts val="0"/>
+              </a:spcAft>
+            </a:pPr>
+            <a:r>
+              <a:rPr lang="ca-ES" sz="2500" b="1">
+                <a:solidFill>
+                  <a:srgbClr val="1C2B3B"/>
+                </a:solidFill>
+                <a:latin typeface="Arial"/>
+              </a:rPr>
+              <a:t>Annex B. Aportació científica de la tesi doctoral</a:t>
+            </a:r>
+          </a:p>
+        </p:txBody>
+      </p:sp>
+      <p:sp>
+        <p:nvSpPr>
+          <p:cNvPr id="3" name="Subtítol"/>
+          <p:cNvSpPr/>
+          <p:nvPr/>
+        </p:nvSpPr>
+        <p:spPr>
+          <a:xfrm>
+            <a:off x="649224" y="804672"/>
+            <a:ext cx="10149840" cy="274320"/>
+          </a:xfrm>
+          <a:prstGeom prst="rect">
+            <a:avLst/>
+          </a:prstGeom>
+          <a:noFill/>
+          <a:ln w="0">
+            <a:noFill/>
+          </a:ln>
+        </p:spPr>
+        <p:txBody>
+          <a:bodyPr lIns="0" tIns="0" rIns="0" bIns="0" anchor="ctr" wrap="square">
+            <a:normAutofit fontScale="92000" lnSpcReduction="8000"/>
+          </a:bodyPr>
+          <a:lstStyle/>
+          <a:p>
+            <a:pPr algn="l">
+              <a:spcAft>
+                <a:spcPts val="0"/>
+              </a:spcAft>
+            </a:pPr>
+            <a:r>
+              <a:rPr lang="ca-ES" sz="1150" b="0">
+                <a:solidFill>
+                  <a:srgbClr val="67717C"/>
+                </a:solidFill>
+                <a:latin typeface="Arial"/>
+              </a:rPr>
+              <a:t>De línies existents a una integració curricular, mesurable i longitudinal</a:t>
+            </a:r>
+          </a:p>
+        </p:txBody>
+      </p:sp>
+      <p:sp>
+        <p:nvSpPr>
+          <p:cNvPr id="4" name="Separador"/>
+          <p:cNvSpPr/>
+          <p:nvPr/>
+        </p:nvSpPr>
+        <p:spPr>
+          <a:xfrm>
+            <a:off x="640080" y="1097280"/>
+            <a:ext cx="10789920" cy="13716"/>
+          </a:xfrm>
+          <a:prstGeom prst="rect">
+            <a:avLst/>
+          </a:prstGeom>
+          <a:solidFill>
+            <a:srgbClr val="D3DAE2"/>
+          </a:solidFill>
+          <a:ln w="0">
+            <a:noFill/>
+          </a:ln>
+        </p:spPr>
+        <p:txBody>
+          <a:bodyPr lIns="88900" tIns="50800" rIns="88900" bIns="50800" anchor="ctr" wrap="square">
+            <a:normAutofit fontScale="92000" lnSpcReduction="8000"/>
+          </a:bodyPr>
+          <a:lstStyle/>
+          <a:p>
+            <a:pPr algn="l">
+              <a:spcAft>
+                <a:spcPts val="200"/>
+              </a:spcAft>
+            </a:pPr>
+            <a:r>
+              <a:rPr lang="ca-ES" sz="100" b="0">
+                <a:solidFill>
+                  <a:srgbClr val="2D343C"/>
+                </a:solidFill>
+                <a:latin typeface="Arial"/>
+              </a:rPr>
+              <a:t/>
+            </a:r>
+          </a:p>
+        </p:txBody>
+      </p:sp>
+      <p:sp>
+        <p:nvSpPr>
+          <p:cNvPr id="5" name="Peu esquerre"/>
+          <p:cNvSpPr/>
+          <p:nvPr/>
+        </p:nvSpPr>
+        <p:spPr>
+          <a:xfrm>
+            <a:off x="731520" y="6519672"/>
+            <a:ext cx="8686800" cy="182880"/>
+          </a:xfrm>
+          <a:prstGeom prst="rect">
+            <a:avLst/>
+          </a:prstGeom>
+          <a:noFill/>
+          <a:ln w="0">
+            <a:noFill/>
+          </a:ln>
+        </p:spPr>
+        <p:txBody>
+          <a:bodyPr lIns="0" tIns="0" rIns="0" bIns="0" anchor="ctr" wrap="square">
+            <a:normAutofit fontScale="92000" lnSpcReduction="8000"/>
+          </a:bodyPr>
+          <a:lstStyle/>
+          <a:p>
+            <a:pPr algn="l">
+              <a:spcAft>
+                <a:spcPts val="0"/>
+              </a:spcAft>
+            </a:pPr>
+            <a:r>
+              <a:rPr lang="ca-ES" sz="740" b="0">
+                <a:solidFill>
+                  <a:srgbClr val="67717C"/>
+                </a:solidFill>
+                <a:latin typeface="Arial"/>
+              </a:rPr>
+              <a:t>Trajectòria professional, acadèmica i científica · Defensa de plaça de professorat permanent</a:t>
+            </a:r>
+          </a:p>
+        </p:txBody>
+      </p:sp>
+      <p:sp>
+        <p:nvSpPr>
+          <p:cNvPr id="6" name="Peu dret"/>
+          <p:cNvSpPr/>
+          <p:nvPr/>
+        </p:nvSpPr>
+        <p:spPr>
+          <a:xfrm>
+            <a:off x="10744200" y="6519672"/>
+            <a:ext cx="685800" cy="182880"/>
+          </a:xfrm>
+          <a:prstGeom prst="rect">
+            <a:avLst/>
+          </a:prstGeom>
+          <a:noFill/>
+          <a:ln w="0">
+            <a:noFill/>
+          </a:ln>
+        </p:spPr>
+        <p:txBody>
+          <a:bodyPr lIns="0" tIns="0" rIns="0" bIns="0" anchor="ctr" wrap="square">
+            <a:normAutofit fontScale="92000" lnSpcReduction="8000"/>
+          </a:bodyPr>
+          <a:lstStyle/>
+          <a:p>
+            <a:pPr algn="r">
+              <a:spcAft>
+                <a:spcPts val="0"/>
+              </a:spcAft>
+            </a:pPr>
+            <a:r>
+              <a:rPr lang="ca-ES" sz="740" b="0">
+                <a:solidFill>
+                  <a:srgbClr val="67717C"/>
+                </a:solidFill>
+                <a:latin typeface="Arial"/>
+              </a:rPr>
+              <a:t>Annex B</a:t>
+            </a:r>
+          </a:p>
+        </p:txBody>
+      </p:sp>
+      <p:sp>
+        <p:nvSpPr>
+          <p:cNvPr id="7" name="QUÈ JA EXISTEIX"/>
+          <p:cNvSpPr/>
+          <p:nvPr/>
+        </p:nvSpPr>
+        <p:spPr>
+          <a:xfrm>
+            <a:off x="658368" y="1261872"/>
+            <a:ext cx="1051560" cy="219456"/>
+          </a:xfrm>
+          <a:prstGeom prst="rect">
+            <a:avLst/>
+          </a:prstGeom>
+          <a:noFill/>
+          <a:ln w="0">
+            <a:noFill/>
+          </a:ln>
+        </p:spPr>
+        <p:txBody>
+          <a:bodyPr lIns="0" tIns="0" rIns="0" bIns="0" anchor="ctr" wrap="square">
+            <a:normAutofit fontScale="92000" lnSpcReduction="8000"/>
+          </a:bodyPr>
+          <a:lstStyle/>
+          <a:p>
+            <a:pPr algn="l">
+              <a:spcAft>
+                <a:spcPts val="0"/>
+              </a:spcAft>
+            </a:pPr>
+            <a:r>
+              <a:rPr lang="ca-ES" sz="820" b="1">
+                <a:solidFill>
+                  <a:srgbClr val="2A5C84"/>
+                </a:solidFill>
+                <a:latin typeface="Arial"/>
+              </a:rPr>
+              <a:t>QUÈ JA EXISTEIX</a:t>
+            </a:r>
+          </a:p>
+        </p:txBody>
+      </p:sp>
+      <p:sp>
+        <p:nvSpPr>
+          <p:cNvPr id="8" name="Antecedent 1"/>
+          <p:cNvSpPr/>
+          <p:nvPr/>
+        </p:nvSpPr>
+        <p:spPr>
+          <a:xfrm>
+            <a:off x="1783080" y="1207008"/>
+            <a:ext cx="1938528" cy="512064"/>
+          </a:xfrm>
+          <a:prstGeom prst="roundRect">
+            <a:avLst/>
+          </a:prstGeom>
+          <a:solidFill>
+            <a:srgbClr val="F7F8FA"/>
+          </a:solidFill>
+          <a:ln w="9525">
+            <a:solidFill>
+              <a:srgbClr val="D3DAE2"/>
+            </a:solidFill>
+          </a:ln>
+          <a:effectLst>
+            <a:outerShdw blurRad="50000" dist="26000" dir="5400000" rotWithShape="0">
+              <a:srgbClr val="000000">
+                <a:alpha val="22000"/>
+              </a:srgbClr>
+            </a:outerShdw>
+          </a:effectLst>
+        </p:spPr>
+        <p:txBody>
+          <a:bodyPr lIns="88900" tIns="50800" rIns="88900" bIns="50800" anchor="ctr" wrap="square">
+            <a:normAutofit fontScale="92000" lnSpcReduction="8000"/>
+          </a:bodyPr>
+          <a:lstStyle/>
+          <a:p>
+            <a:pPr algn="ctr">
+              <a:spcAft>
+                <a:spcPts val="0"/>
+              </a:spcAft>
+            </a:pPr>
+            <a:r>
+              <a:rPr lang="ca-ES" sz="1020" b="1">
+                <a:solidFill>
+                  <a:srgbClr val="2D343C"/>
+                </a:solidFill>
+                <a:latin typeface="Arial"/>
+              </a:rPr>
+              <a:t>ABP i treball</a:t>
+            </a:r>
+          </a:p>
+          <a:p>
+            <a:pPr algn="ctr">
+              <a:spcAft>
+                <a:spcPts val="0"/>
+              </a:spcAft>
+            </a:pPr>
+            <a:r>
+              <a:rPr lang="ca-ES" sz="1020" b="1">
+                <a:solidFill>
+                  <a:srgbClr val="2D343C"/>
+                </a:solidFill>
+                <a:latin typeface="Arial"/>
+              </a:rPr>
+              <a:t>en equip</a:t>
+            </a:r>
+          </a:p>
+        </p:txBody>
+      </p:sp>
+      <p:sp>
+        <p:nvSpPr>
+          <p:cNvPr id="9" name="Antecedent 2"/>
+          <p:cNvSpPr/>
+          <p:nvPr/>
+        </p:nvSpPr>
+        <p:spPr>
+          <a:xfrm>
+            <a:off x="4041648" y="1207008"/>
+            <a:ext cx="1938528" cy="512064"/>
+          </a:xfrm>
+          <a:prstGeom prst="roundRect">
+            <a:avLst/>
+          </a:prstGeom>
+          <a:solidFill>
+            <a:srgbClr val="F7F8FA"/>
+          </a:solidFill>
+          <a:ln w="9525">
+            <a:solidFill>
+              <a:srgbClr val="D3DAE2"/>
+            </a:solidFill>
+          </a:ln>
+          <a:effectLst>
+            <a:outerShdw blurRad="50000" dist="26000" dir="5400000" rotWithShape="0">
+              <a:srgbClr val="000000">
+                <a:alpha val="22000"/>
+              </a:srgbClr>
+            </a:outerShdw>
+          </a:effectLst>
+        </p:spPr>
+        <p:txBody>
+          <a:bodyPr lIns="88900" tIns="50800" rIns="88900" bIns="50800" anchor="ctr" wrap="square">
+            <a:normAutofit fontScale="92000" lnSpcReduction="8000"/>
+          </a:bodyPr>
+          <a:lstStyle/>
+          <a:p>
+            <a:pPr algn="ctr">
+              <a:spcAft>
+                <a:spcPts val="0"/>
+              </a:spcAft>
+            </a:pPr>
+            <a:r>
+              <a:rPr lang="ca-ES" sz="1020" b="1">
+                <a:solidFill>
+                  <a:srgbClr val="2D343C"/>
+                </a:solidFill>
+                <a:latin typeface="Arial"/>
+              </a:rPr>
+              <a:t>empatia i</a:t>
+            </a:r>
+          </a:p>
+          <a:p>
+            <a:pPr algn="ctr">
+              <a:spcAft>
+                <a:spcPts val="0"/>
+              </a:spcAft>
+            </a:pPr>
+            <a:r>
+              <a:rPr lang="ca-ES" sz="1020" b="1">
+                <a:solidFill>
+                  <a:srgbClr val="2D343C"/>
+                </a:solidFill>
+                <a:latin typeface="Arial"/>
+              </a:rPr>
+              <a:t>comunicació</a:t>
+            </a:r>
+          </a:p>
+        </p:txBody>
+      </p:sp>
+      <p:sp>
+        <p:nvSpPr>
+          <p:cNvPr id="10" name="Antecedent 3"/>
+          <p:cNvSpPr/>
+          <p:nvPr/>
+        </p:nvSpPr>
+        <p:spPr>
+          <a:xfrm>
+            <a:off x="6300216" y="1207008"/>
+            <a:ext cx="1938528" cy="512064"/>
+          </a:xfrm>
+          <a:prstGeom prst="roundRect">
+            <a:avLst/>
+          </a:prstGeom>
+          <a:solidFill>
+            <a:srgbClr val="F7F8FA"/>
+          </a:solidFill>
+          <a:ln w="9525">
+            <a:solidFill>
+              <a:srgbClr val="D3DAE2"/>
+            </a:solidFill>
+          </a:ln>
+          <a:effectLst>
+            <a:outerShdw blurRad="50000" dist="26000" dir="5400000" rotWithShape="0">
+              <a:srgbClr val="000000">
+                <a:alpha val="22000"/>
+              </a:srgbClr>
+            </a:outerShdw>
+          </a:effectLst>
+        </p:spPr>
+        <p:txBody>
+          <a:bodyPr lIns="88900" tIns="50800" rIns="88900" bIns="50800" anchor="ctr" wrap="square">
+            <a:normAutofit fontScale="92000" lnSpcReduction="8000"/>
+          </a:bodyPr>
+          <a:lstStyle/>
+          <a:p>
+            <a:pPr algn="ctr">
+              <a:spcAft>
+                <a:spcPts val="0"/>
+              </a:spcAft>
+            </a:pPr>
+            <a:r>
+              <a:rPr lang="ca-ES" sz="1020" b="1">
+                <a:solidFill>
+                  <a:srgbClr val="2D343C"/>
+                </a:solidFill>
+                <a:latin typeface="Arial"/>
+              </a:rPr>
+              <a:t>competències</a:t>
+            </a:r>
+          </a:p>
+          <a:p>
+            <a:pPr algn="ctr">
+              <a:spcAft>
+                <a:spcPts val="0"/>
+              </a:spcAft>
+            </a:pPr>
+            <a:r>
+              <a:rPr lang="ca-ES" sz="1020" b="1">
+                <a:solidFill>
+                  <a:srgbClr val="2D343C"/>
+                </a:solidFill>
+                <a:latin typeface="Arial"/>
+              </a:rPr>
+              <a:t>socioemocionals</a:t>
+            </a:r>
+          </a:p>
+        </p:txBody>
+      </p:sp>
+      <p:sp>
+        <p:nvSpPr>
+          <p:cNvPr id="11" name="Antecedent 4"/>
+          <p:cNvSpPr/>
+          <p:nvPr/>
+        </p:nvSpPr>
+        <p:spPr>
+          <a:xfrm>
+            <a:off x="8558784" y="1207008"/>
+            <a:ext cx="1938528" cy="512064"/>
+          </a:xfrm>
+          <a:prstGeom prst="roundRect">
+            <a:avLst/>
+          </a:prstGeom>
+          <a:solidFill>
+            <a:srgbClr val="F7F8FA"/>
+          </a:solidFill>
+          <a:ln w="9525">
+            <a:solidFill>
+              <a:srgbClr val="D3DAE2"/>
+            </a:solidFill>
+          </a:ln>
+          <a:effectLst>
+            <a:outerShdw blurRad="50000" dist="26000" dir="5400000" rotWithShape="0">
+              <a:srgbClr val="000000">
+                <a:alpha val="22000"/>
+              </a:srgbClr>
+            </a:outerShdw>
+          </a:effectLst>
+        </p:spPr>
+        <p:txBody>
+          <a:bodyPr lIns="88900" tIns="50800" rIns="88900" bIns="50800" anchor="ctr" wrap="square">
+            <a:normAutofit fontScale="92000" lnSpcReduction="8000"/>
+          </a:bodyPr>
+          <a:lstStyle/>
+          <a:p>
+            <a:pPr algn="ctr">
+              <a:spcAft>
+                <a:spcPts val="0"/>
+              </a:spcAft>
+            </a:pPr>
+            <a:r>
+              <a:rPr lang="ca-ES" sz="1020" b="1">
+                <a:solidFill>
+                  <a:srgbClr val="2D343C"/>
+                </a:solidFill>
+                <a:latin typeface="Arial"/>
+              </a:rPr>
+              <a:t>educació en</a:t>
+            </a:r>
+          </a:p>
+          <a:p>
+            <a:pPr algn="ctr">
+              <a:spcAft>
+                <a:spcPts val="0"/>
+              </a:spcAft>
+            </a:pPr>
+            <a:r>
+              <a:rPr lang="ca-ES" sz="1020" b="1">
+                <a:solidFill>
+                  <a:srgbClr val="2D343C"/>
+                </a:solidFill>
+                <a:latin typeface="Arial"/>
+              </a:rPr>
+              <a:t>enginyeria</a:t>
+            </a:r>
+          </a:p>
+        </p:txBody>
+      </p:sp>
+      <p:sp>
+        <p:nvSpPr>
+          <p:cNvPr id="12" name="ON SE SITUA"/>
+          <p:cNvSpPr/>
+          <p:nvPr/>
+        </p:nvSpPr>
+        <p:spPr>
+          <a:xfrm>
+            <a:off x="658368" y="1938528"/>
+            <a:ext cx="1051560" cy="219456"/>
+          </a:xfrm>
+          <a:prstGeom prst="rect">
+            <a:avLst/>
+          </a:prstGeom>
+          <a:noFill/>
+          <a:ln w="0">
+            <a:noFill/>
+          </a:ln>
+        </p:spPr>
+        <p:txBody>
+          <a:bodyPr lIns="0" tIns="0" rIns="0" bIns="0" anchor="ctr" wrap="square">
+            <a:normAutofit fontScale="92000" lnSpcReduction="8000"/>
+          </a:bodyPr>
+          <a:lstStyle/>
+          <a:p>
+            <a:pPr algn="l">
+              <a:spcAft>
+                <a:spcPts val="0"/>
+              </a:spcAft>
+            </a:pPr>
+            <a:r>
+              <a:rPr lang="ca-ES" sz="820" b="1">
+                <a:solidFill>
+                  <a:srgbClr val="2A5C84"/>
+                </a:solidFill>
+                <a:latin typeface="Arial"/>
+              </a:rPr>
+              <a:t>ON SE SITUA</a:t>
+            </a:r>
+          </a:p>
+        </p:txBody>
+      </p:sp>
+      <p:sp>
+        <p:nvSpPr>
+          <p:cNvPr id="13" name="Connector"/>
+          <p:cNvSpPr/>
+          <p:nvPr/>
+        </p:nvSpPr>
+        <p:spPr>
+          <a:xfrm>
+            <a:off x="2240280" y="2532888"/>
+            <a:ext cx="18288" cy="310896"/>
+          </a:xfrm>
+          <a:prstGeom prst="rect">
+            <a:avLst/>
+          </a:prstGeom>
+          <a:solidFill>
+            <a:srgbClr val="D3DAE2"/>
+          </a:solidFill>
+          <a:ln w="0">
+            <a:noFill/>
+          </a:ln>
+        </p:spPr>
+        <p:txBody>
+          <a:bodyPr lIns="88900" tIns="50800" rIns="88900" bIns="50800" anchor="ctr" wrap="square">
+            <a:normAutofit fontScale="92000" lnSpcReduction="8000"/>
+          </a:bodyPr>
+          <a:lstStyle/>
+          <a:p>
+            <a:pPr algn="l">
+              <a:spcAft>
+                <a:spcPts val="200"/>
+              </a:spcAft>
+            </a:pPr>
+            <a:r>
+              <a:rPr lang="ca-ES" sz="100" b="0">
+                <a:solidFill>
+                  <a:srgbClr val="2D343C"/>
+                </a:solidFill>
+                <a:latin typeface="Arial"/>
+              </a:rPr>
+              <a:t/>
+            </a:r>
+          </a:p>
+        </p:txBody>
+      </p:sp>
+      <p:sp>
+        <p:nvSpPr>
+          <p:cNvPr id="14" name="Connector"/>
+          <p:cNvSpPr/>
+          <p:nvPr/>
+        </p:nvSpPr>
+        <p:spPr>
+          <a:xfrm>
+            <a:off x="4151376" y="2532888"/>
+            <a:ext cx="18288" cy="310896"/>
+          </a:xfrm>
+          <a:prstGeom prst="rect">
+            <a:avLst/>
+          </a:prstGeom>
+          <a:solidFill>
+            <a:srgbClr val="D3DAE2"/>
+          </a:solidFill>
+          <a:ln w="0">
+            <a:noFill/>
+          </a:ln>
+        </p:spPr>
+        <p:txBody>
+          <a:bodyPr lIns="88900" tIns="50800" rIns="88900" bIns="50800" anchor="ctr" wrap="square">
+            <a:normAutofit fontScale="92000" lnSpcReduction="8000"/>
+          </a:bodyPr>
+          <a:lstStyle/>
+          <a:p>
+            <a:pPr algn="l">
+              <a:spcAft>
+                <a:spcPts val="200"/>
+              </a:spcAft>
+            </a:pPr>
+            <a:r>
+              <a:rPr lang="ca-ES" sz="100" b="0">
+                <a:solidFill>
+                  <a:srgbClr val="2D343C"/>
+                </a:solidFill>
+                <a:latin typeface="Arial"/>
+              </a:rPr>
+              <a:t/>
+            </a:r>
+          </a:p>
+        </p:txBody>
+      </p:sp>
+      <p:sp>
+        <p:nvSpPr>
+          <p:cNvPr id="15" name="Connector"/>
+          <p:cNvSpPr/>
+          <p:nvPr/>
+        </p:nvSpPr>
+        <p:spPr>
+          <a:xfrm>
+            <a:off x="6062472" y="2532888"/>
+            <a:ext cx="18288" cy="310896"/>
+          </a:xfrm>
+          <a:prstGeom prst="rect">
+            <a:avLst/>
+          </a:prstGeom>
+          <a:solidFill>
+            <a:srgbClr val="D3DAE2"/>
+          </a:solidFill>
+          <a:ln w="0">
+            <a:noFill/>
+          </a:ln>
+        </p:spPr>
+        <p:txBody>
+          <a:bodyPr lIns="88900" tIns="50800" rIns="88900" bIns="50800" anchor="ctr" wrap="square">
+            <a:normAutofit fontScale="92000" lnSpcReduction="8000"/>
+          </a:bodyPr>
+          <a:lstStyle/>
+          <a:p>
+            <a:pPr algn="l">
+              <a:spcAft>
+                <a:spcPts val="200"/>
+              </a:spcAft>
+            </a:pPr>
+            <a:r>
+              <a:rPr lang="ca-ES" sz="100" b="0">
+                <a:solidFill>
+                  <a:srgbClr val="2D343C"/>
+                </a:solidFill>
+                <a:latin typeface="Arial"/>
+              </a:rPr>
+              <a:t/>
+            </a:r>
+          </a:p>
+        </p:txBody>
+      </p:sp>
+      <p:sp>
+        <p:nvSpPr>
+          <p:cNvPr id="16" name="Connector"/>
+          <p:cNvSpPr/>
+          <p:nvPr/>
+        </p:nvSpPr>
+        <p:spPr>
+          <a:xfrm>
+            <a:off x="7973568" y="2532888"/>
+            <a:ext cx="18288" cy="310896"/>
+          </a:xfrm>
+          <a:prstGeom prst="rect">
+            <a:avLst/>
+          </a:prstGeom>
+          <a:solidFill>
+            <a:srgbClr val="D3DAE2"/>
+          </a:solidFill>
+          <a:ln w="0">
+            <a:noFill/>
+          </a:ln>
+        </p:spPr>
+        <p:txBody>
+          <a:bodyPr lIns="88900" tIns="50800" rIns="88900" bIns="50800" anchor="ctr" wrap="square">
+            <a:normAutofit fontScale="92000" lnSpcReduction="8000"/>
+          </a:bodyPr>
+          <a:lstStyle/>
+          <a:p>
+            <a:pPr algn="l">
+              <a:spcAft>
+                <a:spcPts val="200"/>
+              </a:spcAft>
+            </a:pPr>
+            <a:r>
+              <a:rPr lang="ca-ES" sz="100" b="0">
+                <a:solidFill>
+                  <a:srgbClr val="2D343C"/>
+                </a:solidFill>
+                <a:latin typeface="Arial"/>
+              </a:rPr>
+              <a:t/>
+            </a:r>
+          </a:p>
+        </p:txBody>
+      </p:sp>
+      <p:sp>
+        <p:nvSpPr>
+          <p:cNvPr id="17" name="Connector"/>
+          <p:cNvSpPr/>
+          <p:nvPr/>
+        </p:nvSpPr>
+        <p:spPr>
+          <a:xfrm>
+            <a:off x="9884664" y="2532888"/>
+            <a:ext cx="18288" cy="310896"/>
+          </a:xfrm>
+          <a:prstGeom prst="rect">
+            <a:avLst/>
+          </a:prstGeom>
+          <a:solidFill>
+            <a:srgbClr val="D3DAE2"/>
+          </a:solidFill>
+          <a:ln w="0">
+            <a:noFill/>
+          </a:ln>
+        </p:spPr>
+        <p:txBody>
+          <a:bodyPr lIns="88900" tIns="50800" rIns="88900" bIns="50800" anchor="ctr" wrap="square">
+            <a:normAutofit fontScale="92000" lnSpcReduction="8000"/>
+          </a:bodyPr>
+          <a:lstStyle/>
+          <a:p>
+            <a:pPr algn="l">
+              <a:spcAft>
+                <a:spcPts val="200"/>
+              </a:spcAft>
+            </a:pPr>
+            <a:r>
+              <a:rPr lang="ca-ES" sz="100" b="0">
+                <a:solidFill>
+                  <a:srgbClr val="2D343C"/>
+                </a:solidFill>
+                <a:latin typeface="Arial"/>
+              </a:rPr>
+              <a:t/>
+            </a:r>
+          </a:p>
+        </p:txBody>
+      </p:sp>
+      <p:sp>
+        <p:nvSpPr>
+          <p:cNvPr id="18" name="Dimensió 1"/>
+          <p:cNvSpPr/>
+          <p:nvPr/>
+        </p:nvSpPr>
+        <p:spPr>
+          <a:xfrm>
+            <a:off x="1417320" y="1984248"/>
+            <a:ext cx="1664208" cy="557784"/>
+          </a:xfrm>
+          <a:prstGeom prst="roundRect">
+            <a:avLst/>
+          </a:prstGeom>
+          <a:solidFill>
+            <a:srgbClr val="E8F1F8"/>
+          </a:solidFill>
+          <a:ln w="9525">
+            <a:solidFill>
+              <a:srgbClr val="D3DAE2"/>
+            </a:solidFill>
+          </a:ln>
+        </p:spPr>
+        <p:txBody>
+          <a:bodyPr lIns="88900" tIns="50800" rIns="88900" bIns="50800" anchor="ctr" wrap="square">
+            <a:normAutofit fontScale="92000" lnSpcReduction="8000"/>
+          </a:bodyPr>
+          <a:lstStyle/>
+          <a:p>
+            <a:pPr algn="ctr">
+              <a:spcAft>
+                <a:spcPts val="0"/>
+              </a:spcAft>
+            </a:pPr>
+            <a:r>
+              <a:rPr lang="ca-ES" sz="870" b="1">
+                <a:solidFill>
+                  <a:srgbClr val="2D343C"/>
+                </a:solidFill>
+                <a:latin typeface="Arial"/>
+              </a:rPr>
+              <a:t>Enginyeria del</a:t>
+            </a:r>
+          </a:p>
+          <a:p>
+            <a:pPr algn="ctr">
+              <a:spcAft>
+                <a:spcPts val="0"/>
+              </a:spcAft>
+            </a:pPr>
+            <a:r>
+              <a:rPr lang="ca-ES" sz="870" b="1">
+                <a:solidFill>
+                  <a:srgbClr val="2D343C"/>
+                </a:solidFill>
+                <a:latin typeface="Arial"/>
+              </a:rPr>
+              <a:t>Software</a:t>
+            </a:r>
+          </a:p>
+        </p:txBody>
+      </p:sp>
+      <p:sp>
+        <p:nvSpPr>
+          <p:cNvPr id="19" name="Dimensió 2"/>
+          <p:cNvSpPr/>
+          <p:nvPr/>
+        </p:nvSpPr>
+        <p:spPr>
+          <a:xfrm>
+            <a:off x="3328416" y="1984248"/>
+            <a:ext cx="1664208" cy="557784"/>
+          </a:xfrm>
+          <a:prstGeom prst="roundRect">
+            <a:avLst/>
+          </a:prstGeom>
+          <a:solidFill>
+            <a:srgbClr val="EBF6F0"/>
+          </a:solidFill>
+          <a:ln w="9525">
+            <a:solidFill>
+              <a:srgbClr val="D3DAE2"/>
+            </a:solidFill>
+          </a:ln>
+        </p:spPr>
+        <p:txBody>
+          <a:bodyPr lIns="88900" tIns="50800" rIns="88900" bIns="50800" anchor="ctr" wrap="square">
+            <a:normAutofit fontScale="92000" lnSpcReduction="8000"/>
+          </a:bodyPr>
+          <a:lstStyle/>
+          <a:p>
+            <a:pPr algn="ctr">
+              <a:spcAft>
+                <a:spcPts val="0"/>
+              </a:spcAft>
+            </a:pPr>
+            <a:r>
+              <a:rPr lang="ca-ES" sz="870" b="1">
+                <a:solidFill>
+                  <a:srgbClr val="2D343C"/>
+                </a:solidFill>
+                <a:latin typeface="Arial"/>
+              </a:rPr>
+              <a:t>integració curricular</a:t>
+            </a:r>
+          </a:p>
+          <a:p>
+            <a:pPr algn="ctr">
+              <a:spcAft>
+                <a:spcPts val="0"/>
+              </a:spcAft>
+            </a:pPr>
+            <a:r>
+              <a:rPr lang="ca-ES" sz="870" b="1">
+                <a:solidFill>
+                  <a:srgbClr val="2D343C"/>
+                </a:solidFill>
+                <a:latin typeface="Arial"/>
+              </a:rPr>
+              <a:t>en ABP</a:t>
+            </a:r>
+          </a:p>
+        </p:txBody>
+      </p:sp>
+      <p:sp>
+        <p:nvSpPr>
+          <p:cNvPr id="20" name="Dimensió 3"/>
+          <p:cNvSpPr/>
+          <p:nvPr/>
+        </p:nvSpPr>
+        <p:spPr>
+          <a:xfrm>
+            <a:off x="5239512" y="1984248"/>
+            <a:ext cx="1664208" cy="557784"/>
+          </a:xfrm>
+          <a:prstGeom prst="roundRect">
+            <a:avLst/>
+          </a:prstGeom>
+          <a:solidFill>
+            <a:srgbClr val="FFF4DB"/>
+          </a:solidFill>
+          <a:ln w="9525">
+            <a:solidFill>
+              <a:srgbClr val="D3DAE2"/>
+            </a:solidFill>
+          </a:ln>
+        </p:spPr>
+        <p:txBody>
+          <a:bodyPr lIns="88900" tIns="50800" rIns="88900" bIns="50800" anchor="ctr" wrap="square">
+            <a:normAutofit fontScale="92000" lnSpcReduction="8000"/>
+          </a:bodyPr>
+          <a:lstStyle/>
+          <a:p>
+            <a:pPr algn="ctr">
+              <a:spcAft>
+                <a:spcPts val="0"/>
+              </a:spcAft>
+            </a:pPr>
+            <a:r>
+              <a:rPr lang="ca-ES" sz="870" b="1">
+                <a:solidFill>
+                  <a:srgbClr val="2D343C"/>
+                </a:solidFill>
+                <a:latin typeface="Arial"/>
+              </a:rPr>
+              <a:t>empatia · escolta activa</a:t>
+            </a:r>
+          </a:p>
+          <a:p>
+            <a:pPr algn="ctr">
+              <a:spcAft>
+                <a:spcPts val="0"/>
+              </a:spcAft>
+            </a:pPr>
+            <a:r>
+              <a:rPr lang="ca-ES" sz="870" b="1">
+                <a:solidFill>
+                  <a:srgbClr val="2D343C"/>
+                </a:solidFill>
+                <a:latin typeface="Arial"/>
+              </a:rPr>
+              <a:t>· comunicació assertiva</a:t>
+            </a:r>
+          </a:p>
+        </p:txBody>
+      </p:sp>
+      <p:sp>
+        <p:nvSpPr>
+          <p:cNvPr id="21" name="Dimensió 4"/>
+          <p:cNvSpPr/>
+          <p:nvPr/>
+        </p:nvSpPr>
+        <p:spPr>
+          <a:xfrm>
+            <a:off x="7150608" y="1984248"/>
+            <a:ext cx="1664208" cy="557784"/>
+          </a:xfrm>
+          <a:prstGeom prst="roundRect">
+            <a:avLst/>
+          </a:prstGeom>
+          <a:solidFill>
+            <a:srgbClr val="E8F1F8"/>
+          </a:solidFill>
+          <a:ln w="9525">
+            <a:solidFill>
+              <a:srgbClr val="D3DAE2"/>
+            </a:solidFill>
+          </a:ln>
+        </p:spPr>
+        <p:txBody>
+          <a:bodyPr lIns="88900" tIns="50800" rIns="88900" bIns="50800" anchor="ctr" wrap="square">
+            <a:normAutofit fontScale="92000" lnSpcReduction="8000"/>
+          </a:bodyPr>
+          <a:lstStyle/>
+          <a:p>
+            <a:pPr algn="ctr">
+              <a:spcAft>
+                <a:spcPts val="0"/>
+              </a:spcAft>
+            </a:pPr>
+            <a:r>
+              <a:rPr lang="ca-ES" sz="870" b="1">
+                <a:solidFill>
+                  <a:srgbClr val="2D343C"/>
+                </a:solidFill>
+                <a:latin typeface="Arial"/>
+              </a:rPr>
+              <a:t>disseny mixt i</a:t>
+            </a:r>
+          </a:p>
+          <a:p>
+            <a:pPr algn="ctr">
+              <a:spcAft>
+                <a:spcPts val="0"/>
+              </a:spcAft>
+            </a:pPr>
+            <a:r>
+              <a:rPr lang="ca-ES" sz="870" b="1">
+                <a:solidFill>
+                  <a:srgbClr val="2D343C"/>
+                </a:solidFill>
+                <a:latin typeface="Arial"/>
+              </a:rPr>
+              <a:t>quasiexperimental</a:t>
+            </a:r>
+          </a:p>
+        </p:txBody>
+      </p:sp>
+      <p:sp>
+        <p:nvSpPr>
+          <p:cNvPr id="22" name="Dimensió 5"/>
+          <p:cNvSpPr/>
+          <p:nvPr/>
+        </p:nvSpPr>
+        <p:spPr>
+          <a:xfrm>
+            <a:off x="9061704" y="1984248"/>
+            <a:ext cx="1664208" cy="557784"/>
+          </a:xfrm>
+          <a:prstGeom prst="roundRect">
+            <a:avLst/>
+          </a:prstGeom>
+          <a:solidFill>
+            <a:srgbClr val="EBF6F0"/>
+          </a:solidFill>
+          <a:ln w="9525">
+            <a:solidFill>
+              <a:srgbClr val="D3DAE2"/>
+            </a:solidFill>
+          </a:ln>
+        </p:spPr>
+        <p:txBody>
+          <a:bodyPr lIns="88900" tIns="50800" rIns="88900" bIns="50800" anchor="ctr" wrap="square">
+            <a:normAutofit fontScale="92000" lnSpcReduction="8000"/>
+          </a:bodyPr>
+          <a:lstStyle/>
+          <a:p>
+            <a:pPr algn="ctr">
+              <a:spcAft>
+                <a:spcPts val="0"/>
+              </a:spcAft>
+            </a:pPr>
+            <a:r>
+              <a:rPr lang="ca-ES" sz="870" b="1">
+                <a:solidFill>
+                  <a:srgbClr val="2D343C"/>
+                </a:solidFill>
+                <a:latin typeface="Arial"/>
+              </a:rPr>
+              <a:t>dues assignatures</a:t>
+            </a:r>
+          </a:p>
+          <a:p>
+            <a:pPr algn="ctr">
+              <a:spcAft>
+                <a:spcPts val="0"/>
+              </a:spcAft>
+            </a:pPr>
+            <a:r>
+              <a:rPr lang="ca-ES" sz="870" b="1">
+                <a:solidFill>
+                  <a:srgbClr val="2D343C"/>
+                </a:solidFill>
+                <a:latin typeface="Arial"/>
+              </a:rPr>
+              <a:t>consecutives</a:t>
+            </a:r>
+          </a:p>
+        </p:txBody>
+      </p:sp>
+      <p:sp>
+        <p:nvSpPr>
+          <p:cNvPr id="23" name="Convergència"/>
+          <p:cNvSpPr/>
+          <p:nvPr/>
+        </p:nvSpPr>
+        <p:spPr>
+          <a:xfrm>
+            <a:off x="1965960" y="2816352"/>
+            <a:ext cx="8275320" cy="502920"/>
+          </a:xfrm>
+          <a:prstGeom prst="roundRect">
+            <a:avLst/>
+          </a:prstGeom>
+          <a:solidFill>
+            <a:srgbClr val="1C2B3B"/>
+          </a:solidFill>
+          <a:ln w="9525">
+            <a:solidFill>
+              <a:srgbClr val="1C2B3B"/>
+            </a:solidFill>
+          </a:ln>
+          <a:effectLst>
+            <a:outerShdw blurRad="50000" dist="26000" dir="5400000" rotWithShape="0">
+              <a:srgbClr val="000000">
+                <a:alpha val="22000"/>
+              </a:srgbClr>
+            </a:outerShdw>
+          </a:effectLst>
+        </p:spPr>
+        <p:txBody>
+          <a:bodyPr lIns="88900" tIns="50800" rIns="88900" bIns="50800" anchor="ctr" wrap="square">
+            <a:normAutofit fontScale="92000" lnSpcReduction="8000"/>
+          </a:bodyPr>
+          <a:lstStyle/>
+          <a:p>
+            <a:pPr algn="ctr">
+              <a:spcAft>
+                <a:spcPts val="0"/>
+              </a:spcAft>
+            </a:pPr>
+            <a:r>
+              <a:rPr lang="ca-ES" sz="1220" b="1">
+                <a:solidFill>
+                  <a:srgbClr val="FFFFFF"/>
+                </a:solidFill>
+                <a:latin typeface="Arial"/>
+              </a:rPr>
+              <a:t>Intervenció integrada, mesurable i situada en context docent real</a:t>
+            </a:r>
+          </a:p>
+        </p:txBody>
+      </p:sp>
+      <p:sp>
+        <p:nvSpPr>
+          <p:cNvPr id="24" name="APORTACIÓ"/>
+          <p:cNvSpPr/>
+          <p:nvPr/>
+        </p:nvSpPr>
+        <p:spPr>
+          <a:xfrm>
+            <a:off x="658368" y="3584448"/>
+            <a:ext cx="1051560" cy="219456"/>
+          </a:xfrm>
+          <a:prstGeom prst="rect">
+            <a:avLst/>
+          </a:prstGeom>
+          <a:noFill/>
+          <a:ln w="0">
+            <a:noFill/>
+          </a:ln>
+        </p:spPr>
+        <p:txBody>
+          <a:bodyPr lIns="0" tIns="0" rIns="0" bIns="0" anchor="ctr" wrap="square">
+            <a:normAutofit fontScale="92000" lnSpcReduction="8000"/>
+          </a:bodyPr>
+          <a:lstStyle/>
+          <a:p>
+            <a:pPr algn="l">
+              <a:spcAft>
+                <a:spcPts val="0"/>
+              </a:spcAft>
+            </a:pPr>
+            <a:r>
+              <a:rPr lang="ca-ES" sz="820" b="1">
+                <a:solidFill>
+                  <a:srgbClr val="2A5C84"/>
+                </a:solidFill>
+                <a:latin typeface="Arial"/>
+              </a:rPr>
+              <a:t>APORTACIÓ</a:t>
+            </a:r>
+          </a:p>
+        </p:txBody>
+      </p:sp>
+      <p:sp>
+        <p:nvSpPr>
+          <p:cNvPr id="25" name="Resultat 1"/>
+          <p:cNvSpPr/>
+          <p:nvPr/>
+        </p:nvSpPr>
+        <p:spPr>
+          <a:xfrm>
+            <a:off x="1828800" y="3529584"/>
+            <a:ext cx="2578608" cy="530352"/>
+          </a:xfrm>
+          <a:prstGeom prst="roundRect">
+            <a:avLst/>
+          </a:prstGeom>
+          <a:solidFill>
+            <a:srgbClr val="E8F1F8"/>
+          </a:solidFill>
+          <a:ln w="9525">
+            <a:solidFill>
+              <a:srgbClr val="D3DAE2"/>
+            </a:solidFill>
+          </a:ln>
+          <a:effectLst>
+            <a:outerShdw blurRad="50000" dist="26000" dir="5400000" rotWithShape="0">
+              <a:srgbClr val="000000">
+                <a:alpha val="22000"/>
+              </a:srgbClr>
+            </a:outerShdw>
+          </a:effectLst>
+        </p:spPr>
+        <p:txBody>
+          <a:bodyPr lIns="88900" tIns="50800" rIns="88900" bIns="50800" anchor="ctr" wrap="square">
+            <a:normAutofit fontScale="92000" lnSpcReduction="8000"/>
+          </a:bodyPr>
+          <a:lstStyle/>
+          <a:p>
+            <a:pPr algn="ctr">
+              <a:spcAft>
+                <a:spcPts val="0"/>
+              </a:spcAft>
+            </a:pPr>
+            <a:r>
+              <a:rPr lang="ca-ES" sz="1020" b="1">
+                <a:solidFill>
+                  <a:srgbClr val="2D343C"/>
+                </a:solidFill>
+                <a:latin typeface="Arial"/>
+              </a:rPr>
+              <a:t>evidència longitudinal</a:t>
+            </a:r>
+          </a:p>
+        </p:txBody>
+      </p:sp>
+      <p:sp>
+        <p:nvSpPr>
+          <p:cNvPr id="26" name="Resultat 2"/>
+          <p:cNvSpPr/>
+          <p:nvPr/>
+        </p:nvSpPr>
+        <p:spPr>
+          <a:xfrm>
+            <a:off x="4727448" y="3529584"/>
+            <a:ext cx="2578608" cy="530352"/>
+          </a:xfrm>
+          <a:prstGeom prst="roundRect">
+            <a:avLst/>
+          </a:prstGeom>
+          <a:solidFill>
+            <a:srgbClr val="EBF6F0"/>
+          </a:solidFill>
+          <a:ln w="9525">
+            <a:solidFill>
+              <a:srgbClr val="D3DAE2"/>
+            </a:solidFill>
+          </a:ln>
+          <a:effectLst>
+            <a:outerShdw blurRad="50000" dist="26000" dir="5400000" rotWithShape="0">
+              <a:srgbClr val="000000">
+                <a:alpha val="22000"/>
+              </a:srgbClr>
+            </a:outerShdw>
+          </a:effectLst>
+        </p:spPr>
+        <p:txBody>
+          <a:bodyPr lIns="88900" tIns="50800" rIns="88900" bIns="50800" anchor="ctr" wrap="square">
+            <a:normAutofit fontScale="92000" lnSpcReduction="8000"/>
+          </a:bodyPr>
+          <a:lstStyle/>
+          <a:p>
+            <a:pPr algn="ctr">
+              <a:spcAft>
+                <a:spcPts val="0"/>
+              </a:spcAft>
+            </a:pPr>
+            <a:r>
+              <a:rPr lang="ca-ES" sz="1020" b="1">
+                <a:solidFill>
+                  <a:srgbClr val="2D343C"/>
+                </a:solidFill>
+                <a:latin typeface="Arial"/>
+              </a:rPr>
+              <a:t>model d'intervenció transferible</a:t>
+            </a:r>
+          </a:p>
+        </p:txBody>
+      </p:sp>
+      <p:sp>
+        <p:nvSpPr>
+          <p:cNvPr id="27" name="Resultat 3"/>
+          <p:cNvSpPr/>
+          <p:nvPr/>
+        </p:nvSpPr>
+        <p:spPr>
+          <a:xfrm>
+            <a:off x="7626096" y="3529584"/>
+            <a:ext cx="2578608" cy="530352"/>
+          </a:xfrm>
+          <a:prstGeom prst="roundRect">
+            <a:avLst/>
+          </a:prstGeom>
+          <a:solidFill>
+            <a:srgbClr val="FFF4DB"/>
+          </a:solidFill>
+          <a:ln w="9525">
+            <a:solidFill>
+              <a:srgbClr val="D3DAE2"/>
+            </a:solidFill>
+          </a:ln>
+          <a:effectLst>
+            <a:outerShdw blurRad="50000" dist="26000" dir="5400000" rotWithShape="0">
+              <a:srgbClr val="000000">
+                <a:alpha val="22000"/>
+              </a:srgbClr>
+            </a:outerShdw>
+          </a:effectLst>
+        </p:spPr>
+        <p:txBody>
+          <a:bodyPr lIns="88900" tIns="50800" rIns="88900" bIns="50800" anchor="ctr" wrap="square">
+            <a:normAutofit fontScale="92000" lnSpcReduction="8000"/>
+          </a:bodyPr>
+          <a:lstStyle/>
+          <a:p>
+            <a:pPr algn="ctr">
+              <a:spcAft>
+                <a:spcPts val="0"/>
+              </a:spcAft>
+            </a:pPr>
+            <a:r>
+              <a:rPr lang="ca-ES" sz="1020" b="1">
+                <a:solidFill>
+                  <a:srgbClr val="2D343C"/>
+                </a:solidFill>
+                <a:latin typeface="Arial"/>
+              </a:rPr>
+              <a:t>connexió universitat–professió</a:t>
+            </a:r>
+          </a:p>
+        </p:txBody>
+      </p:sp>
+      <p:sp>
+        <p:nvSpPr>
+          <p:cNvPr id="28" name="Missatge final"/>
+          <p:cNvSpPr/>
+          <p:nvPr/>
+        </p:nvSpPr>
+        <p:spPr>
+          <a:xfrm>
+            <a:off x="841248" y="4297680"/>
+            <a:ext cx="10515600" cy="694944"/>
+          </a:xfrm>
+          <a:prstGeom prst="roundRect">
+            <a:avLst/>
+          </a:prstGeom>
+          <a:solidFill>
+            <a:srgbClr val="FFFFFF"/>
+          </a:solidFill>
+          <a:ln w="9525">
+            <a:solidFill>
+              <a:srgbClr val="D3DAE2"/>
+            </a:solidFill>
+          </a:ln>
+        </p:spPr>
+        <p:txBody>
+          <a:bodyPr lIns="88900" tIns="50800" rIns="88900" bIns="50800" anchor="ctr" wrap="square">
+            <a:normAutofit fontScale="92000" lnSpcReduction="8000"/>
+          </a:bodyPr>
+          <a:lstStyle/>
+          <a:p>
+            <a:pPr algn="ctr">
+              <a:spcAft>
+                <a:spcPts val="0"/>
+              </a:spcAft>
+            </a:pPr>
+            <a:r>
+              <a:rPr lang="ca-ES" sz="1200" b="1">
+                <a:solidFill>
+                  <a:srgbClr val="1C2B3B"/>
+                </a:solidFill>
+                <a:latin typeface="Arial"/>
+              </a:rPr>
+              <a:t>La novetat no és estudiar una competència de manera aïllada, sinó integrar-ne el cultiu, l'avaluació i el seguiment dins la formació ordinària en Enginyeria del Software.</a:t>
+            </a:r>
+          </a:p>
+        </p:txBody>
+      </p:sp>
+      <p:sp>
+        <p:nvSpPr>
+          <p:cNvPr id="29" name="Formulació prudent"/>
+          <p:cNvSpPr/>
+          <p:nvPr/>
+        </p:nvSpPr>
+        <p:spPr>
+          <a:xfrm>
+            <a:off x="960120" y="5148072"/>
+            <a:ext cx="10241280" cy="384048"/>
+          </a:xfrm>
+          <a:prstGeom prst="rect">
+            <a:avLst/>
+          </a:prstGeom>
+          <a:noFill/>
+          <a:ln w="0">
+            <a:noFill/>
+          </a:ln>
+        </p:spPr>
+        <p:txBody>
+          <a:bodyPr lIns="0" tIns="0" rIns="0" bIns="0" anchor="ctr" wrap="square">
+            <a:normAutofit fontScale="92000" lnSpcReduction="8000"/>
+          </a:bodyPr>
+          <a:lstStyle/>
+          <a:p>
+            <a:pPr algn="ctr">
+              <a:spcAft>
+                <a:spcPts val="0"/>
+              </a:spcAft>
+            </a:pPr>
+            <a:r>
+              <a:rPr lang="ca-ES" sz="920" b="0" i="1">
+                <a:solidFill>
+                  <a:srgbClr val="67717C"/>
+                </a:solidFill>
+                <a:latin typeface="Arial"/>
+              </a:rPr>
+              <a:t>La literatura existent aporta antecedents rellevants, però mostra una integració encara fragmentada i una necessitat de més evidència curricular, mesurable i longitudinal.</a:t>
+            </a:r>
+          </a:p>
+        </p:txBody>
+      </p:sp>
+      <p:sp>
+        <p:nvSpPr>
+          <p:cNvPr id="30" name="Fonament ABP"/>
+          <p:cNvSpPr/>
+          <p:nvPr/>
+        </p:nvSpPr>
+        <p:spPr>
+          <a:xfrm>
+            <a:off x="960120" y="5650992"/>
+            <a:ext cx="10241280" cy="310896"/>
+          </a:xfrm>
+          <a:prstGeom prst="rect">
+            <a:avLst/>
+          </a:prstGeom>
+          <a:noFill/>
+          <a:ln w="0">
+            <a:noFill/>
+          </a:ln>
+        </p:spPr>
+        <p:txBody>
+          <a:bodyPr lIns="0" tIns="0" rIns="0" bIns="0" anchor="ctr" wrap="square">
+            <a:normAutofit fontScale="92000" lnSpcReduction="8000"/>
+          </a:bodyPr>
+          <a:lstStyle/>
+          <a:p>
+            <a:pPr algn="ctr">
+              <a:spcAft>
+                <a:spcPts val="0"/>
+              </a:spcAft>
+            </a:pPr>
+            <a:r>
+              <a:rPr lang="ca-ES" sz="840" b="0">
+                <a:solidFill>
+                  <a:srgbClr val="67717C"/>
+                </a:solidFill>
+                <a:latin typeface="Arial"/>
+              </a:rPr>
+              <a:t>L'ABP aporta un context professionalitzador viable; la mida dels equips i la durada fonamenten el disseny, però no constitueixen el buit central.</a:t>
+            </a:r>
+          </a:p>
+        </p:txBody>
+      </p:sp>
+    </p:spTree>
+  </p:cSld>
+  <p:clrMapOvr>
+    <a:masterClrMapping/>
+  </p:clrMapOvr>
+</p:sld>
+</file>
+
+<file path=ppt/slides/slide9.xml><?xml version="1.0" encoding="utf-8"?>
+<p:sld xmlns:a="http://schemas.openxmlformats.org/drawingml/2006/main" xmlns:r="http://schemas.openxmlformats.org/officeDocument/2006/relationships" xmlns:p="http://schemas.openxmlformats.org/presentationml/2006/main">
+  <p:cSld>
+    <p:spTree>
+      <p:nvGrpSpPr>
+        <p:cNvPr id="1" name=""/>
+        <p:cNvGrpSpPr/>
+        <p:nvPr/>
+      </p:nvGrpSpPr>
+      <p:grpSpPr>
+        <a:xfrm>
+          <a:off x="0" y="0"/>
+          <a:ext cx="0" cy="0"/>
+          <a:chOff x="0" y="0"/>
+          <a:chExt cx="0" cy="0"/>
+        </a:xfrm>
+      </p:grpSpPr>
+      <p:sp>
+        <p:nvSpPr>
+          <p:cNvPr id="2" name="Títol"/>
+          <p:cNvSpPr/>
+          <p:nvPr/>
+        </p:nvSpPr>
+        <p:spPr>
+          <a:xfrm>
+            <a:off x="640080" y="356616"/>
+            <a:ext cx="10652760" cy="438912"/>
+          </a:xfrm>
+          <a:prstGeom prst="rect">
+            <a:avLst/>
+          </a:prstGeom>
+          <a:noFill/>
+          <a:ln w="0">
+            <a:noFill/>
+          </a:ln>
+        </p:spPr>
+        <p:txBody>
+          <a:bodyPr lIns="0" tIns="0" rIns="0" bIns="0" anchor="ctr" wrap="square">
+            <a:normAutofit fontScale="92000" lnSpcReduction="8000"/>
+          </a:bodyPr>
+          <a:lstStyle/>
+          <a:p>
+            <a:pPr algn="l">
+              <a:spcAft>
+                <a:spcPts val="0"/>
+              </a:spcAft>
+            </a:pPr>
+            <a:r>
+              <a:rPr lang="ca-ES" sz="2350" b="1">
+                <a:solidFill>
+                  <a:srgbClr val="1C2B3B"/>
+                </a:solidFill>
+                <a:latin typeface="Arial"/>
+              </a:rPr>
+              <a:t>Annex C. Estratègia de desenvolupament i modalitats de tesi</a:t>
+            </a:r>
+          </a:p>
+        </p:txBody>
+      </p:sp>
+      <p:sp>
+        <p:nvSpPr>
+          <p:cNvPr id="3" name="Subtítol"/>
+          <p:cNvSpPr/>
+          <p:nvPr/>
+        </p:nvSpPr>
+        <p:spPr>
+          <a:xfrm>
+            <a:off x="649224" y="804672"/>
+            <a:ext cx="10149840" cy="274320"/>
+          </a:xfrm>
+          <a:prstGeom prst="rect">
+            <a:avLst/>
+          </a:prstGeom>
+          <a:noFill/>
+          <a:ln w="0">
+            <a:noFill/>
+          </a:ln>
+        </p:spPr>
+        <p:txBody>
+          <a:bodyPr lIns="0" tIns="0" rIns="0" bIns="0" anchor="ctr" wrap="square">
+            <a:normAutofit fontScale="92000" lnSpcReduction="8000"/>
+          </a:bodyPr>
+          <a:lstStyle/>
+          <a:p>
+            <a:pPr algn="l">
+              <a:spcAft>
+                <a:spcPts val="0"/>
+              </a:spcAft>
+            </a:pPr>
+            <a:r>
+              <a:rPr lang="ca-ES" sz="1150" b="0">
+                <a:solidFill>
+                  <a:srgbClr val="67717C"/>
+                </a:solidFill>
+                <a:latin typeface="Arial"/>
+              </a:rPr>
+              <a:t>Objectiu ambiciós, planificació realista i flexibilitat normativa</a:t>
+            </a:r>
+          </a:p>
+        </p:txBody>
+      </p:sp>
+      <p:sp>
+        <p:nvSpPr>
+          <p:cNvPr id="4" name="Separador"/>
+          <p:cNvSpPr/>
+          <p:nvPr/>
+        </p:nvSpPr>
+        <p:spPr>
+          <a:xfrm>
+            <a:off x="640080" y="1097280"/>
+            <a:ext cx="10789920" cy="13716"/>
+          </a:xfrm>
+          <a:prstGeom prst="rect">
+            <a:avLst/>
+          </a:prstGeom>
+          <a:solidFill>
+            <a:srgbClr val="D3DAE2"/>
+          </a:solidFill>
+          <a:ln w="0">
+            <a:noFill/>
+          </a:ln>
+        </p:spPr>
+        <p:txBody>
+          <a:bodyPr lIns="88900" tIns="50800" rIns="88900" bIns="50800" anchor="ctr" wrap="square">
+            <a:normAutofit fontScale="92000" lnSpcReduction="8000"/>
+          </a:bodyPr>
+          <a:lstStyle/>
+          <a:p>
+            <a:pPr algn="l">
+              <a:spcAft>
+                <a:spcPts val="200"/>
+              </a:spcAft>
+            </a:pPr>
+            <a:r>
+              <a:rPr lang="ca-ES" sz="100" b="0">
+                <a:solidFill>
+                  <a:srgbClr val="2D343C"/>
+                </a:solidFill>
+                <a:latin typeface="Arial"/>
+              </a:rPr>
+              <a:t/>
+            </a:r>
+          </a:p>
+        </p:txBody>
+      </p:sp>
+      <p:sp>
+        <p:nvSpPr>
+          <p:cNvPr id="5" name="Peu esquerre"/>
+          <p:cNvSpPr/>
+          <p:nvPr/>
+        </p:nvSpPr>
+        <p:spPr>
+          <a:xfrm>
+            <a:off x="731520" y="6519672"/>
+            <a:ext cx="8686800" cy="182880"/>
+          </a:xfrm>
+          <a:prstGeom prst="rect">
+            <a:avLst/>
+          </a:prstGeom>
+          <a:noFill/>
+          <a:ln w="0">
+            <a:noFill/>
+          </a:ln>
+        </p:spPr>
+        <p:txBody>
+          <a:bodyPr lIns="0" tIns="0" rIns="0" bIns="0" anchor="ctr" wrap="square">
+            <a:normAutofit fontScale="92000" lnSpcReduction="8000"/>
+          </a:bodyPr>
+          <a:lstStyle/>
+          <a:p>
+            <a:pPr algn="l">
+              <a:spcAft>
+                <a:spcPts val="0"/>
+              </a:spcAft>
+            </a:pPr>
+            <a:r>
+              <a:rPr lang="ca-ES" sz="740" b="0">
+                <a:solidFill>
+                  <a:srgbClr val="67717C"/>
+                </a:solidFill>
+                <a:latin typeface="Arial"/>
+              </a:rPr>
+              <a:t>Trajectòria professional, acadèmica i científica · Defensa de plaça de professorat permanent</a:t>
+            </a:r>
+          </a:p>
+        </p:txBody>
+      </p:sp>
+      <p:sp>
+        <p:nvSpPr>
+          <p:cNvPr id="6" name="Peu dret"/>
+          <p:cNvSpPr/>
+          <p:nvPr/>
+        </p:nvSpPr>
+        <p:spPr>
+          <a:xfrm>
+            <a:off x="10744200" y="6519672"/>
+            <a:ext cx="685800" cy="182880"/>
+          </a:xfrm>
+          <a:prstGeom prst="rect">
+            <a:avLst/>
+          </a:prstGeom>
+          <a:noFill/>
+          <a:ln w="0">
+            <a:noFill/>
+          </a:ln>
+        </p:spPr>
+        <p:txBody>
+          <a:bodyPr lIns="0" tIns="0" rIns="0" bIns="0" anchor="ctr" wrap="square">
+            <a:normAutofit fontScale="92000" lnSpcReduction="8000"/>
+          </a:bodyPr>
+          <a:lstStyle/>
+          <a:p>
+            <a:pPr algn="r">
+              <a:spcAft>
+                <a:spcPts val="0"/>
+              </a:spcAft>
+            </a:pPr>
+            <a:r>
+              <a:rPr lang="ca-ES" sz="740" b="0">
+                <a:solidFill>
+                  <a:srgbClr val="67717C"/>
+                </a:solidFill>
+                <a:latin typeface="Arial"/>
+              </a:rPr>
+              <a:t>Annex C</a:t>
+            </a:r>
+          </a:p>
+        </p:txBody>
+      </p:sp>
+      <p:sp>
+        <p:nvSpPr>
+          <p:cNvPr id="7" name="Base comuna"/>
+          <p:cNvSpPr/>
+          <p:nvPr/>
+        </p:nvSpPr>
+        <p:spPr>
+          <a:xfrm>
+            <a:off x="786384" y="1243584"/>
+            <a:ext cx="10607040" cy="786384"/>
+          </a:xfrm>
+          <a:prstGeom prst="roundRect">
+            <a:avLst/>
+          </a:prstGeom>
+          <a:solidFill>
+            <a:srgbClr val="F7F8FA"/>
+          </a:solidFill>
+          <a:ln w="9525">
+            <a:solidFill>
+              <a:srgbClr val="D3DAE2"/>
+            </a:solidFill>
+          </a:ln>
+        </p:spPr>
+        <p:txBody>
+          <a:bodyPr lIns="88900" tIns="50800" rIns="88900" bIns="50800" anchor="ctr" wrap="square">
+            <a:normAutofit fontScale="92000" lnSpcReduction="8000"/>
+          </a:bodyPr>
+          <a:lstStyle/>
+          <a:p>
+            <a:pPr algn="ctr">
+              <a:spcAft>
+                <a:spcPts val="300"/>
+              </a:spcAft>
+            </a:pPr>
+            <a:r>
+              <a:rPr lang="ca-ES" sz="1400" b="1">
+                <a:solidFill>
+                  <a:srgbClr val="1C2B3B"/>
+                </a:solidFill>
+                <a:latin typeface="Arial"/>
+              </a:rPr>
+              <a:t>Una mateixa recerca doctoral original</a:t>
+            </a:r>
+          </a:p>
+          <a:p>
+            <a:pPr algn="ctr">
+              <a:spcAft>
+                <a:spcPts val="0"/>
+              </a:spcAft>
+            </a:pPr>
+            <a:r>
+              <a:rPr lang="ca-ES" sz="960" b="0">
+                <a:solidFill>
+                  <a:srgbClr val="2D343C"/>
+                </a:solidFill>
+                <a:latin typeface="Arial"/>
+              </a:rPr>
+              <a:t>pla de recerca aprovat i seguiment semestral · treball de camp, anàlisi i contribució científica · controls de qualitat, predefensa i avaluació externa</a:t>
+            </a:r>
+          </a:p>
+        </p:txBody>
+      </p:sp>
+      <p:sp>
+        <p:nvSpPr>
+          <p:cNvPr id="8" name="Itinerari 1"/>
+          <p:cNvSpPr/>
+          <p:nvPr/>
+        </p:nvSpPr>
+        <p:spPr>
+          <a:xfrm>
+            <a:off x="786384" y="2240280"/>
+            <a:ext cx="5074920" cy="2039112"/>
+          </a:xfrm>
+          <a:prstGeom prst="roundRect">
+            <a:avLst/>
+          </a:prstGeom>
+          <a:solidFill>
+            <a:srgbClr val="E8F1F8"/>
+          </a:solidFill>
+          <a:ln w="9525">
+            <a:solidFill>
+              <a:srgbClr val="D3DAE2"/>
+            </a:solidFill>
+          </a:ln>
+          <a:effectLst>
+            <a:outerShdw blurRad="50000" dist="26000" dir="5400000" rotWithShape="0">
+              <a:srgbClr val="000000">
+                <a:alpha val="22000"/>
+              </a:srgbClr>
+            </a:outerShdw>
+          </a:effectLst>
+        </p:spPr>
+        <p:txBody>
+          <a:bodyPr lIns="88900" tIns="50800" rIns="88900" bIns="50800" anchor="ctr" wrap="square">
+            <a:normAutofit fontScale="92000" lnSpcReduction="8000"/>
+          </a:bodyPr>
+          <a:lstStyle/>
+          <a:p>
+            <a:pPr algn="l">
+              <a:spcAft>
+                <a:spcPts val="200"/>
+              </a:spcAft>
+            </a:pPr>
+            <a:r>
+              <a:rPr lang="ca-ES" sz="100" b="0">
+                <a:solidFill>
+                  <a:srgbClr val="2D343C"/>
+                </a:solidFill>
+                <a:latin typeface="Arial"/>
+              </a:rPr>
+              <a:t/>
+            </a:r>
+          </a:p>
+        </p:txBody>
+      </p:sp>
+      <p:sp>
+        <p:nvSpPr>
+          <p:cNvPr id="9" name="Títol itinerari 1"/>
+          <p:cNvSpPr/>
+          <p:nvPr/>
+        </p:nvSpPr>
+        <p:spPr>
+          <a:xfrm>
+            <a:off x="1014984" y="2386584"/>
+            <a:ext cx="4617720" cy="347472"/>
+          </a:xfrm>
+          <a:prstGeom prst="rect">
+            <a:avLst/>
+          </a:prstGeom>
+          <a:noFill/>
+          <a:ln w="0">
+            <a:noFill/>
+          </a:ln>
+        </p:spPr>
+        <p:txBody>
+          <a:bodyPr lIns="0" tIns="0" rIns="0" bIns="0" anchor="ctr" wrap="square">
+            <a:normAutofit fontScale="92000" lnSpcReduction="8000"/>
+          </a:bodyPr>
+          <a:lstStyle/>
+          <a:p>
+            <a:pPr algn="ctr">
+              <a:spcAft>
+                <a:spcPts val="0"/>
+              </a:spcAft>
+            </a:pPr>
+            <a:r>
+              <a:rPr lang="ca-ES" sz="1550" b="1">
+                <a:solidFill>
+                  <a:srgbClr val="1C2B3B"/>
+                </a:solidFill>
+                <a:latin typeface="Arial"/>
+              </a:rPr>
+              <a:t>Compendi de publicacions</a:t>
+            </a:r>
+          </a:p>
+        </p:txBody>
+      </p:sp>
+      <p:sp>
+        <p:nvSpPr>
+          <p:cNvPr id="10" name="Etiqueta itinerari 1"/>
+          <p:cNvSpPr/>
+          <p:nvPr/>
+        </p:nvSpPr>
+        <p:spPr>
+          <a:xfrm>
+            <a:off x="2359152" y="2779776"/>
+            <a:ext cx="1920240" cy="274320"/>
+          </a:xfrm>
+          <a:prstGeom prst="roundRect">
+            <a:avLst/>
+          </a:prstGeom>
+          <a:solidFill>
+            <a:srgbClr val="2A5C84"/>
+          </a:solidFill>
+          <a:ln w="9525">
+            <a:solidFill>
+              <a:srgbClr val="2A5C84"/>
+            </a:solidFill>
+          </a:ln>
+        </p:spPr>
+        <p:txBody>
+          <a:bodyPr lIns="25400" tIns="12700" rIns="25400" bIns="12700" anchor="ctr" wrap="square">
+            <a:normAutofit fontScale="92000" lnSpcReduction="8000"/>
+          </a:bodyPr>
+          <a:lstStyle/>
+          <a:p>
+            <a:pPr algn="ctr">
+              <a:spcAft>
+                <a:spcPts val="0"/>
+              </a:spcAft>
+            </a:pPr>
+            <a:r>
+              <a:rPr lang="ca-ES" sz="820" b="1">
+                <a:solidFill>
+                  <a:srgbClr val="FFFFFF"/>
+                </a:solidFill>
+                <a:latin typeface="Arial"/>
+              </a:rPr>
+              <a:t>OBJECTIU PREFERENT</a:t>
+            </a:r>
+          </a:p>
+        </p:txBody>
+      </p:sp>
+      <p:sp>
+        <p:nvSpPr>
+          <p:cNvPr id="11" name="Contingut itinerari 1"/>
+          <p:cNvSpPr/>
+          <p:nvPr/>
+        </p:nvSpPr>
+        <p:spPr>
+          <a:xfrm>
+            <a:off x="1170432" y="3136392"/>
+            <a:ext cx="4370832" cy="960120"/>
+          </a:xfrm>
+          <a:prstGeom prst="rect">
+            <a:avLst/>
+          </a:prstGeom>
+          <a:noFill/>
+          <a:ln w="0">
+            <a:noFill/>
+          </a:ln>
+        </p:spPr>
+        <p:txBody>
+          <a:bodyPr lIns="0" tIns="0" rIns="0" bIns="0" anchor="t" wrap="square">
+            <a:normAutofit fontScale="92000" lnSpcReduction="8000"/>
+          </a:bodyPr>
+          <a:lstStyle/>
+          <a:p>
+            <a:pPr algn="l" marL="240000" indent="-180000">
+              <a:spcAft>
+                <a:spcPts val="300"/>
+              </a:spcAft>
+              <a:buChar char="•"/>
+            </a:pPr>
+            <a:r>
+              <a:rPr lang="ca-ES" sz="1020" b="0">
+                <a:solidFill>
+                  <a:srgbClr val="2D343C"/>
+                </a:solidFill>
+                <a:latin typeface="Arial"/>
+              </a:rPr>
+              <a:t>mínim de 3 contribucions publicades o admeses</a:t>
+            </a:r>
+          </a:p>
+          <a:p>
+            <a:pPr algn="l" marL="240000" indent="-180000">
+              <a:spcAft>
+                <a:spcPts val="300"/>
+              </a:spcAft>
+              <a:buChar char="•"/>
+            </a:pPr>
+            <a:r>
+              <a:rPr lang="ca-ES" sz="1020" b="0">
+                <a:solidFill>
+                  <a:srgbClr val="2D343C"/>
+                </a:solidFill>
+                <a:latin typeface="Arial"/>
+              </a:rPr>
+              <a:t>autorització de la direcció i de la Comissió Acadèmica</a:t>
+            </a:r>
+          </a:p>
+          <a:p>
+            <a:pPr algn="l" marL="240000" indent="-180000">
+              <a:spcAft>
+                <a:spcPts val="300"/>
+              </a:spcAft>
+              <a:buChar char="•"/>
+            </a:pPr>
+            <a:r>
+              <a:rPr lang="ca-ES" sz="1020" b="0">
+                <a:solidFill>
+                  <a:srgbClr val="2D343C"/>
+                </a:solidFill>
+                <a:latin typeface="Arial"/>
+              </a:rPr>
+              <a:t>primer autor en la majoria</a:t>
+            </a:r>
+          </a:p>
+          <a:p>
+            <a:pPr algn="l" marL="240000" indent="-180000">
+              <a:spcAft>
+                <a:spcPts val="300"/>
+              </a:spcAft>
+              <a:buChar char="•"/>
+            </a:pPr>
+            <a:r>
+              <a:rPr lang="ca-ES" sz="1020" b="0">
+                <a:solidFill>
+                  <a:srgbClr val="2D343C"/>
+                </a:solidFill>
+                <a:latin typeface="Arial"/>
+              </a:rPr>
+              <a:t>objectiu acordat amb la direcció de la tesi</a:t>
+            </a:r>
+          </a:p>
+        </p:txBody>
+      </p:sp>
+      <p:sp>
+        <p:nvSpPr>
+          <p:cNvPr id="12" name="Itinerari 2"/>
+          <p:cNvSpPr/>
+          <p:nvPr/>
+        </p:nvSpPr>
+        <p:spPr>
+          <a:xfrm>
+            <a:off x="6199632" y="2240280"/>
+            <a:ext cx="5074920" cy="2039112"/>
+          </a:xfrm>
+          <a:prstGeom prst="roundRect">
+            <a:avLst/>
+          </a:prstGeom>
+          <a:solidFill>
+            <a:srgbClr val="EBF6F0"/>
+          </a:solidFill>
+          <a:ln w="9525">
+            <a:solidFill>
+              <a:srgbClr val="D3DAE2"/>
+            </a:solidFill>
+          </a:ln>
+          <a:effectLst>
+            <a:outerShdw blurRad="50000" dist="26000" dir="5400000" rotWithShape="0">
+              <a:srgbClr val="000000">
+                <a:alpha val="22000"/>
+              </a:srgbClr>
+            </a:outerShdw>
+          </a:effectLst>
+        </p:spPr>
+        <p:txBody>
+          <a:bodyPr lIns="88900" tIns="50800" rIns="88900" bIns="50800" anchor="ctr" wrap="square">
+            <a:normAutofit fontScale="92000" lnSpcReduction="8000"/>
+          </a:bodyPr>
+          <a:lstStyle/>
+          <a:p>
+            <a:pPr algn="l">
+              <a:spcAft>
+                <a:spcPts val="200"/>
+              </a:spcAft>
+            </a:pPr>
+            <a:r>
+              <a:rPr lang="ca-ES" sz="100" b="0">
+                <a:solidFill>
+                  <a:srgbClr val="2D343C"/>
+                </a:solidFill>
+                <a:latin typeface="Arial"/>
+              </a:rPr>
+              <a:t/>
+            </a:r>
+          </a:p>
+        </p:txBody>
+      </p:sp>
+      <p:sp>
+        <p:nvSpPr>
+          <p:cNvPr id="13" name="Títol itinerari 2"/>
+          <p:cNvSpPr/>
+          <p:nvPr/>
+        </p:nvSpPr>
+        <p:spPr>
+          <a:xfrm>
+            <a:off x="6428232" y="2386584"/>
+            <a:ext cx="4617720" cy="347472"/>
+          </a:xfrm>
+          <a:prstGeom prst="rect">
+            <a:avLst/>
+          </a:prstGeom>
+          <a:noFill/>
+          <a:ln w="0">
+            <a:noFill/>
+          </a:ln>
+        </p:spPr>
+        <p:txBody>
+          <a:bodyPr lIns="0" tIns="0" rIns="0" bIns="0" anchor="ctr" wrap="square">
+            <a:normAutofit fontScale="92000" lnSpcReduction="8000"/>
+          </a:bodyPr>
+          <a:lstStyle/>
+          <a:p>
+            <a:pPr algn="ctr">
+              <a:spcAft>
+                <a:spcPts val="0"/>
+              </a:spcAft>
+            </a:pPr>
+            <a:r>
+              <a:rPr lang="ca-ES" sz="1550" b="1">
+                <a:solidFill>
+                  <a:srgbClr val="1C2B3B"/>
+                </a:solidFill>
+                <a:latin typeface="Arial"/>
+              </a:rPr>
+              <a:t>Tesi monogràfica</a:t>
+            </a:r>
+          </a:p>
+        </p:txBody>
+      </p:sp>
+      <p:sp>
+        <p:nvSpPr>
+          <p:cNvPr id="14" name="Etiqueta itinerari 2"/>
+          <p:cNvSpPr/>
+          <p:nvPr/>
+        </p:nvSpPr>
+        <p:spPr>
+          <a:xfrm>
+            <a:off x="7772400" y="2779776"/>
+            <a:ext cx="1920240" cy="274320"/>
+          </a:xfrm>
+          <a:prstGeom prst="roundRect">
+            <a:avLst/>
+          </a:prstGeom>
+          <a:solidFill>
+            <a:srgbClr val="2A5C84"/>
+          </a:solidFill>
+          <a:ln w="9525">
+            <a:solidFill>
+              <a:srgbClr val="2A5C84"/>
+            </a:solidFill>
+          </a:ln>
+        </p:spPr>
+        <p:txBody>
+          <a:bodyPr lIns="25400" tIns="12700" rIns="25400" bIns="12700" anchor="ctr" wrap="square">
+            <a:normAutofit fontScale="92000" lnSpcReduction="8000"/>
+          </a:bodyPr>
+          <a:lstStyle/>
+          <a:p>
+            <a:pPr algn="ctr">
+              <a:spcAft>
+                <a:spcPts val="0"/>
+              </a:spcAft>
+            </a:pPr>
+            <a:r>
+              <a:rPr lang="ca-ES" sz="820" b="1">
+                <a:solidFill>
+                  <a:srgbClr val="FFFFFF"/>
+                </a:solidFill>
+                <a:latin typeface="Arial"/>
+              </a:rPr>
+              <a:t>FLEXIBILITAT NORMATIVA</a:t>
+            </a:r>
+          </a:p>
+        </p:txBody>
+      </p:sp>
+      <p:sp>
+        <p:nvSpPr>
+          <p:cNvPr id="15" name="Contingut itinerari 2"/>
+          <p:cNvSpPr/>
+          <p:nvPr/>
+        </p:nvSpPr>
+        <p:spPr>
+          <a:xfrm>
+            <a:off x="6583680" y="3136392"/>
+            <a:ext cx="4370832" cy="960120"/>
+          </a:xfrm>
+          <a:prstGeom prst="rect">
+            <a:avLst/>
+          </a:prstGeom>
+          <a:noFill/>
+          <a:ln w="0">
+            <a:noFill/>
+          </a:ln>
+        </p:spPr>
+        <p:txBody>
+          <a:bodyPr lIns="0" tIns="0" rIns="0" bIns="0" anchor="t" wrap="square">
+            <a:normAutofit fontScale="92000" lnSpcReduction="8000"/>
+          </a:bodyPr>
+          <a:lstStyle/>
+          <a:p>
+            <a:pPr algn="l" marL="240000" indent="-180000">
+              <a:spcAft>
+                <a:spcPts val="300"/>
+              </a:spcAft>
+              <a:buChar char="•"/>
+            </a:pPr>
+            <a:r>
+              <a:rPr lang="ca-ES" sz="1020" b="0">
+                <a:solidFill>
+                  <a:srgbClr val="2D343C"/>
+                </a:solidFill>
+                <a:latin typeface="Arial"/>
+              </a:rPr>
+              <a:t>treball doctoral original i unitari</a:t>
+            </a:r>
+          </a:p>
+          <a:p>
+            <a:pPr algn="l" marL="240000" indent="-180000">
+              <a:spcAft>
+                <a:spcPts val="300"/>
+              </a:spcAft>
+              <a:buChar char="•"/>
+            </a:pPr>
+            <a:r>
+              <a:rPr lang="ca-ES" sz="1020" b="0">
+                <a:solidFill>
+                  <a:srgbClr val="2D343C"/>
+                </a:solidFill>
+                <a:latin typeface="Arial"/>
+              </a:rPr>
+              <a:t>1 contribució científica de qualitat per sol·licitar el dipòsit</a:t>
+            </a:r>
+          </a:p>
+          <a:p>
+            <a:pPr algn="l" marL="240000" indent="-180000">
+              <a:spcAft>
+                <a:spcPts val="300"/>
+              </a:spcAft>
+              <a:buChar char="•"/>
+            </a:pPr>
+            <a:r>
+              <a:rPr lang="ca-ES" sz="1020" b="0">
+                <a:solidFill>
+                  <a:srgbClr val="2D343C"/>
+                </a:solidFill>
+                <a:latin typeface="Arial"/>
+              </a:rPr>
+              <a:t>mateixos controls generals de qualitat</a:t>
+            </a:r>
+          </a:p>
+          <a:p>
+            <a:pPr algn="l" marL="240000" indent="-180000">
+              <a:spcAft>
+                <a:spcPts val="300"/>
+              </a:spcAft>
+              <a:buChar char="•"/>
+            </a:pPr>
+            <a:r>
+              <a:rPr lang="ca-ES" sz="1020" b="0">
+                <a:solidFill>
+                  <a:srgbClr val="2D343C"/>
+                </a:solidFill>
+                <a:latin typeface="Arial"/>
+              </a:rPr>
+              <a:t>alternativa vàlida davant la incertesa editorial</a:t>
+            </a:r>
+          </a:p>
+        </p:txBody>
+      </p:sp>
+      <p:sp>
+        <p:nvSpPr>
+          <p:cNvPr id="16" name="Línia temporal"/>
+          <p:cNvSpPr/>
+          <p:nvPr/>
+        </p:nvSpPr>
+        <p:spPr>
+          <a:xfrm>
+            <a:off x="822960" y="4526280"/>
+            <a:ext cx="10533888" cy="438912"/>
+          </a:xfrm>
+          <a:prstGeom prst="roundRect">
+            <a:avLst/>
+          </a:prstGeom>
+          <a:solidFill>
+            <a:srgbClr val="FFFFFF"/>
+          </a:solidFill>
+          <a:ln w="9525">
+            <a:solidFill>
+              <a:srgbClr val="D3DAE2"/>
+            </a:solidFill>
+          </a:ln>
+        </p:spPr>
+        <p:txBody>
+          <a:bodyPr lIns="88900" tIns="50800" rIns="88900" bIns="50800" anchor="ctr" wrap="square">
+            <a:normAutofit fontScale="92000" lnSpcReduction="8000"/>
+          </a:bodyPr>
+          <a:lstStyle/>
+          <a:p>
+            <a:pPr algn="ctr">
+              <a:spcAft>
+                <a:spcPts val="0"/>
+              </a:spcAft>
+            </a:pPr>
+            <a:r>
+              <a:rPr lang="ca-ES" sz="1060" b="1">
+                <a:solidFill>
+                  <a:srgbClr val="2A5C84"/>
+                </a:solidFill>
+                <a:latin typeface="Arial"/>
+              </a:rPr>
+              <a:t>Planificació orientada a dos anys, condicionada pel progrés de la recerca i pels processos editorials.</a:t>
+            </a:r>
+          </a:p>
+        </p:txBody>
+      </p:sp>
+      <p:sp>
+        <p:nvSpPr>
+          <p:cNvPr id="17" name="Missatge final"/>
+          <p:cNvSpPr/>
+          <p:nvPr/>
+        </p:nvSpPr>
+        <p:spPr>
+          <a:xfrm>
+            <a:off x="941832" y="5138928"/>
+            <a:ext cx="10296144" cy="548640"/>
+          </a:xfrm>
+          <a:prstGeom prst="rect">
+            <a:avLst/>
+          </a:prstGeom>
+          <a:noFill/>
+          <a:ln w="0">
+            <a:noFill/>
+          </a:ln>
+        </p:spPr>
+        <p:txBody>
+          <a:bodyPr lIns="0" tIns="0" rIns="0" bIns="0" anchor="ctr" wrap="square">
+            <a:normAutofit fontScale="92000" lnSpcReduction="8000"/>
+          </a:bodyPr>
+          <a:lstStyle/>
+          <a:p>
+            <a:pPr algn="ctr">
+              <a:spcAft>
+                <a:spcPts val="0"/>
+              </a:spcAft>
+            </a:pPr>
+            <a:r>
+              <a:rPr lang="ca-ES" sz="1140" b="1">
+                <a:solidFill>
+                  <a:srgbClr val="1C2B3B"/>
+                </a:solidFill>
+                <a:latin typeface="Arial"/>
+              </a:rPr>
+              <a:t>L'estratègia combina ambició científica i gestió responsable del risc: treballar pel compendi sense fer dependre la viabilitat del doctorat exclusivament dels calendaris editorials.</a:t>
+            </a:r>
+          </a:p>
+        </p:txBody>
+      </p:sp>
+      <p:sp>
+        <p:nvSpPr>
+          <p:cNvPr id="18" name="Font normativa"/>
+          <p:cNvSpPr/>
+          <p:nvPr/>
+        </p:nvSpPr>
+        <p:spPr>
+          <a:xfrm>
+            <a:off x="841248" y="5870448"/>
+            <a:ext cx="10515600" cy="256032"/>
+          </a:xfrm>
+          <a:prstGeom prst="rect">
+            <a:avLst/>
+          </a:prstGeom>
+          <a:noFill/>
+          <a:ln w="0">
+            <a:noFill/>
+          </a:ln>
+        </p:spPr>
+        <p:txBody>
+          <a:bodyPr lIns="0" tIns="0" rIns="0" bIns="0" anchor="ctr" wrap="square">
+            <a:normAutofit fontScale="92000" lnSpcReduction="8000"/>
+          </a:bodyPr>
+          <a:lstStyle/>
+          <a:p>
+            <a:pPr algn="ctr">
+              <a:spcAft>
+                <a:spcPts val="0"/>
+              </a:spcAft>
+            </a:pPr>
+            <a:r>
+              <a:rPr lang="ca-ES" sz="830" b="0">
+                <a:solidFill>
+                  <a:srgbClr val="67717C"/>
+                </a:solidFill>
+                <a:latin typeface="Arial"/>
+              </a:rPr>
+              <a:t>Font normativa: Reglament dels estudis de doctorat de la UDIMA, versió maig de 2026, articles 33 i 34.</a:t>
+            </a:r>
+          </a:p>
+        </p:txBody>
+      </p:sp>
+    </p:spTree>
+  </p:cSld>
+  <p:clrMapOvr>
+    <a:masterClrMapping/>
+  </p:clrMapOvr>
+</p:sld>
+</file>
+
 <file path=ppt/theme/theme1.xml><?xml version="1.0" encoding="utf-8"?>
 <a:theme xmlns:a="http://schemas.openxmlformats.org/drawingml/2006/main" name="Office Theme">
   <a:themeElements>

</xml_diff>